<commit_message>
Add a full read-aloud script for A's four sections
The speaking outline gives beats, not sentences, which is the better way to present
but not what is wanted here. This is the verbatim version: the same four sections,
written out, in the poster's revised wording.

Timing is measured rather than guessed. A word count at 140 wpm puts the full text
about thirty seconds over A's two hundred second allowance, so the sentences that can
go without losing the argument are marked, and cutting them brings it back within
about ten seconds. The per-block table records both figures.

Numbers that are easy to stumble over when read aloud are written the way they should
be said, and a short table covers the rest.

Co-Authored-By: Claude Opus 5 <noreply@anthropic.com>
</commit_message>
<xml_diff>
--- a/video_slides.pptx
+++ b/video_slides.pptx
@@ -4,18 +4,21 @@
   <p:sldMasterIdLst>
     <p:sldMasterId id="2147483648" r:id="rId1"/>
   </p:sldMasterIdLst>
+  <p:notesMasterIdLst>
+    <p:notesMasterId r:id="rId11"/>
+  </p:notesMasterIdLst>
   <p:sldIdLst>
-    <p:sldId id="256" r:id="rId7"/>
-    <p:sldId id="257" r:id="rId9"/>
-    <p:sldId id="258" r:id="rId10"/>
-    <p:sldId id="259" r:id="rId11"/>
-    <p:sldId id="260" r:id="rId12"/>
-    <p:sldId id="261" r:id="rId13"/>
-    <p:sldId id="262" r:id="rId14"/>
-    <p:sldId id="263" r:id="rId15"/>
-    <p:sldId id="264" r:id="rId16"/>
+    <p:sldId id="256" r:id="rId2"/>
+    <p:sldId id="257" r:id="rId3"/>
+    <p:sldId id="258" r:id="rId4"/>
+    <p:sldId id="259" r:id="rId5"/>
+    <p:sldId id="260" r:id="rId6"/>
+    <p:sldId id="261" r:id="rId7"/>
+    <p:sldId id="262" r:id="rId8"/>
+    <p:sldId id="263" r:id="rId9"/>
+    <p:sldId id="264" r:id="rId10"/>
   </p:sldIdLst>
-  <p:sldSz cx="12191695" cy="6858000" type="screen4x3"/>
+  <p:sldSz cx="12192000" cy="6858000"/>
   <p:notesSz cx="6858000" cy="9144000"/>
   <p:defaultTextStyle>
     <a:defPPr>
@@ -112,11 +115,27 @@
       </a:defRPr>
     </a:lvl9pPr>
   </p:defaultTextStyle>
+  <p:extLst>
+    <p:ext uri="{EFAFB233-063F-42B5-8137-9DF3F51BA10A}">
+      <p15:sldGuideLst xmlns:p15="http://schemas.microsoft.com/office/powerpoint/2012/main">
+        <p15:guide id="1" orient="horz" pos="2160">
+          <p15:clr>
+            <a:srgbClr val="A4A3A4"/>
+          </p15:clr>
+        </p15:guide>
+        <p15:guide id="2" pos="2880">
+          <p15:clr>
+            <a:srgbClr val="A4A3A4"/>
+          </p15:clr>
+        </p15:guide>
+      </p15:sldGuideLst>
+    </p:ext>
+  </p:extLst>
 </p:presentation>
 </file>
 
 <file path=ppt/notesMasters/notesMaster1.xml><?xml version="1.0" encoding="utf-8"?>
-<p:notesMaster xmlns:a="http://schemas.openxmlformats.org/drawingml/2006/main" xmlns:p="http://schemas.openxmlformats.org/presentationml/2006/main" xmlns:r="http://schemas.openxmlformats.org/officeDocument/2006/relationships">
+<p:notesMaster xmlns:a="http://schemas.openxmlformats.org/drawingml/2006/main" xmlns:r="http://schemas.openxmlformats.org/officeDocument/2006/relationships" xmlns:p="http://schemas.openxmlformats.org/presentationml/2006/main">
   <p:cSld>
     <p:bg>
       <p:bgRef idx="1001">
@@ -137,241 +156,16 @@
           <a:chExt cx="0" cy="0"/>
         </a:xfrm>
       </p:grpSpPr>
-      <p:sp>
-        <p:nvSpPr>
-          <p:cNvPr id="2" name="Header Placeholder 1"/>
-          <p:cNvSpPr>
-            <a:spLocks noGrp="1"/>
-          </p:cNvSpPr>
-          <p:nvPr>
-            <p:ph type="hdr" sz="quarter"/>
-          </p:nvPr>
-        </p:nvSpPr>
-        <p:spPr>
-          <a:xfrm>
-            <a:off x="0" y="0"/>
-            <a:ext cx="2971800" cy="457200"/>
-          </a:xfrm>
-          <a:prstGeom prst="rect">
-            <a:avLst/>
-          </a:prstGeom>
-        </p:spPr>
-        <p:txBody>
-          <a:bodyPr vert="horz" lIns="91440" tIns="45720" rIns="91440" bIns="45720" rtlCol="0"/>
-          <a:lstStyle>
-            <a:lvl1pPr algn="l">
-              <a:defRPr sz="1200"/>
-            </a:lvl1pPr>
-          </a:lstStyle>
-          <a:p>
-            <a:endParaRPr lang="en-US"/>
-          </a:p>
-        </p:txBody>
-      </p:sp>
-      <p:sp>
-        <p:nvSpPr>
-          <p:cNvPr id="3" name="Date Placeholder 2"/>
-          <p:cNvSpPr>
-            <a:spLocks noGrp="1"/>
-          </p:cNvSpPr>
-          <p:nvPr>
-            <p:ph type="dt" idx="1"/>
-          </p:nvPr>
-        </p:nvSpPr>
-        <p:spPr>
-          <a:xfrm>
-            <a:off x="3884613" y="0"/>
-            <a:ext cx="2971800" cy="457200"/>
-          </a:xfrm>
-          <a:prstGeom prst="rect">
-            <a:avLst/>
-          </a:prstGeom>
-        </p:spPr>
-        <p:txBody>
-          <a:bodyPr vert="horz" lIns="91440" tIns="45720" rIns="91440" bIns="45720" rtlCol="0"/>
-          <a:lstStyle>
-            <a:lvl1pPr algn="r">
-              <a:defRPr sz="1200"/>
-            </a:lvl1pPr>
-          </a:lstStyle>
-          <a:p>
-            <a:fld id="{0F89C1C7-3DCD-1040-A9CF-14679D8B5DDD}" type="datetimeFigureOut">
-              <a:rPr lang="en-US" smtClean="0"/>
-              <a:t>10/17/16</a:t>
-            </a:fld>
-            <a:endParaRPr lang="en-US"/>
-          </a:p>
-        </p:txBody>
-      </p:sp>
-      <p:sp>
-        <p:nvSpPr>
-          <p:cNvPr id="4" name="Slide Image Placeholder 3"/>
-          <p:cNvSpPr>
-            <a:spLocks noGrp="1" noRot="1" noChangeAspect="1"/>
-          </p:cNvSpPr>
-          <p:nvPr>
-            <p:ph type="sldImg" idx="2"/>
-          </p:nvPr>
-        </p:nvSpPr>
-        <p:spPr>
-          <a:xfrm>
-            <a:off x="1143000" y="685800"/>
-            <a:ext cx="4572000" cy="3429000"/>
-          </a:xfrm>
-          <a:prstGeom prst="rect">
-            <a:avLst/>
-          </a:prstGeom>
-          <a:noFill/>
-          <a:ln w="12700">
-            <a:solidFill>
-              <a:prstClr val="black"/>
-            </a:solidFill>
-          </a:ln>
-        </p:spPr>
-        <p:txBody>
-          <a:bodyPr vert="horz" lIns="91440" tIns="45720" rIns="91440" bIns="45720" rtlCol="0" anchor="ctr"/>
-          <a:lstStyle/>
-          <a:p>
-            <a:endParaRPr lang="en-US"/>
-          </a:p>
-        </p:txBody>
-      </p:sp>
-      <p:sp>
-        <p:nvSpPr>
-          <p:cNvPr id="5" name="Notes Placeholder 4"/>
-          <p:cNvSpPr>
-            <a:spLocks noGrp="1"/>
-          </p:cNvSpPr>
-          <p:nvPr>
-            <p:ph type="body" sz="quarter" idx="3"/>
-          </p:nvPr>
-        </p:nvSpPr>
-        <p:spPr>
-          <a:xfrm>
-            <a:off x="685800" y="4343400"/>
-            <a:ext cx="5486400" cy="4114800"/>
-          </a:xfrm>
-          <a:prstGeom prst="rect">
-            <a:avLst/>
-          </a:prstGeom>
-        </p:spPr>
-        <p:txBody>
-          <a:bodyPr vert="horz" lIns="91440" tIns="45720" rIns="91440" bIns="45720" rtlCol="0"/>
-          <a:lstStyle/>
-          <a:p>
-            <a:pPr lvl="0"/>
-            <a:r>
-              <a:rPr lang="en-US" smtClean="0"/>
-              <a:t>Click to edit Master text styles</a:t>
-            </a:r>
-          </a:p>
-          <a:p>
-            <a:pPr lvl="1"/>
-            <a:r>
-              <a:rPr lang="en-US" smtClean="0"/>
-              <a:t>Second level</a:t>
-            </a:r>
-          </a:p>
-          <a:p>
-            <a:pPr lvl="2"/>
-            <a:r>
-              <a:rPr lang="en-US" smtClean="0"/>
-              <a:t>Third level</a:t>
-            </a:r>
-          </a:p>
-          <a:p>
-            <a:pPr lvl="3"/>
-            <a:r>
-              <a:rPr lang="en-US" smtClean="0"/>
-              <a:t>Fourth level</a:t>
-            </a:r>
-          </a:p>
-          <a:p>
-            <a:pPr lvl="4"/>
-            <a:r>
-              <a:rPr lang="en-US" smtClean="0"/>
-              <a:t>Fifth level</a:t>
-            </a:r>
-            <a:endParaRPr lang="en-US"/>
-          </a:p>
-        </p:txBody>
-      </p:sp>
-      <p:sp>
-        <p:nvSpPr>
-          <p:cNvPr id="6" name="Footer Placeholder 5"/>
-          <p:cNvSpPr>
-            <a:spLocks noGrp="1"/>
-          </p:cNvSpPr>
-          <p:nvPr>
-            <p:ph type="ftr" sz="quarter" idx="4"/>
-          </p:nvPr>
-        </p:nvSpPr>
-        <p:spPr>
-          <a:xfrm>
-            <a:off x="0" y="8685213"/>
-            <a:ext cx="2971800" cy="457200"/>
-          </a:xfrm>
-          <a:prstGeom prst="rect">
-            <a:avLst/>
-          </a:prstGeom>
-        </p:spPr>
-        <p:txBody>
-          <a:bodyPr vert="horz" lIns="91440" tIns="45720" rIns="91440" bIns="45720" rtlCol="0" anchor="b"/>
-          <a:lstStyle>
-            <a:lvl1pPr algn="l">
-              <a:defRPr sz="1200"/>
-            </a:lvl1pPr>
-          </a:lstStyle>
-          <a:p>
-            <a:endParaRPr lang="en-US"/>
-          </a:p>
-        </p:txBody>
-      </p:sp>
-      <p:sp>
-        <p:nvSpPr>
-          <p:cNvPr id="7" name="Slide Number Placeholder 6"/>
-          <p:cNvSpPr>
-            <a:spLocks noGrp="1"/>
-          </p:cNvSpPr>
-          <p:nvPr>
-            <p:ph type="sldNum" sz="quarter" idx="5"/>
-          </p:nvPr>
-        </p:nvSpPr>
-        <p:spPr>
-          <a:xfrm>
-            <a:off x="3884613" y="8685213"/>
-            <a:ext cx="2971800" cy="457200"/>
-          </a:xfrm>
-          <a:prstGeom prst="rect">
-            <a:avLst/>
-          </a:prstGeom>
-        </p:spPr>
-        <p:txBody>
-          <a:bodyPr vert="horz" lIns="91440" tIns="45720" rIns="91440" bIns="45720" rtlCol="0" anchor="b"/>
-          <a:lstStyle>
-            <a:lvl1pPr algn="r">
-              <a:defRPr sz="1200"/>
-            </a:lvl1pPr>
-          </a:lstStyle>
-          <a:p>
-            <a:fld id="{BB5E49A5-4136-284D-997B-48E1D791AD67}" type="slidenum">
-              <a:rPr lang="en-US" smtClean="0"/>
-              <a:t>‹#›</a:t>
-            </a:fld>
-            <a:endParaRPr lang="en-US"/>
-          </a:p>
-        </p:txBody>
-      </p:sp>
     </p:spTree>
     <p:extLst>
       <p:ext uri="{BB962C8B-B14F-4D97-AF65-F5344CB8AC3E}">
-        <p14:creationId xmlns:p14="http://schemas.microsoft.com/office/powerpoint/2010/main" val="2623252185"/>
+        <p14:creationId xmlns:p14="http://schemas.microsoft.com/office/powerpoint/2010/main" val="2956616574"/>
       </p:ext>
     </p:extLst>
   </p:cSld>
   <p:clrMap bg1="lt1" tx1="dk1" bg2="lt2" tx2="dk2" accent1="accent1" accent2="accent2" accent3="accent3" accent4="accent4" accent5="accent5" accent6="accent6" hlink="hlink" folHlink="folHlink"/>
   <p:notesStyle>
-    <a:lvl1pPr marL="0" algn="l" defTabSz="457200" rtl="0" eaLnBrk="1" latinLnBrk="0" hangingPunct="1">
+    <a:lvl1pPr marL="0" algn="l" defTabSz="914400" rtl="0" eaLnBrk="1" latinLnBrk="0" hangingPunct="1">
       <a:defRPr sz="1200" kern="1200">
         <a:solidFill>
           <a:schemeClr val="tx1"/>
@@ -381,7 +175,7 @@
         <a:cs typeface="+mn-cs"/>
       </a:defRPr>
     </a:lvl1pPr>
-    <a:lvl2pPr marL="457200" algn="l" defTabSz="457200" rtl="0" eaLnBrk="1" latinLnBrk="0" hangingPunct="1">
+    <a:lvl2pPr marL="457200" algn="l" defTabSz="914400" rtl="0" eaLnBrk="1" latinLnBrk="0" hangingPunct="1">
       <a:defRPr sz="1200" kern="1200">
         <a:solidFill>
           <a:schemeClr val="tx1"/>
@@ -391,7 +185,7 @@
         <a:cs typeface="+mn-cs"/>
       </a:defRPr>
     </a:lvl2pPr>
-    <a:lvl3pPr marL="914400" algn="l" defTabSz="457200" rtl="0" eaLnBrk="1" latinLnBrk="0" hangingPunct="1">
+    <a:lvl3pPr marL="914400" algn="l" defTabSz="914400" rtl="0" eaLnBrk="1" latinLnBrk="0" hangingPunct="1">
       <a:defRPr sz="1200" kern="1200">
         <a:solidFill>
           <a:schemeClr val="tx1"/>
@@ -401,7 +195,7 @@
         <a:cs typeface="+mn-cs"/>
       </a:defRPr>
     </a:lvl3pPr>
-    <a:lvl4pPr marL="1371600" algn="l" defTabSz="457200" rtl="0" eaLnBrk="1" latinLnBrk="0" hangingPunct="1">
+    <a:lvl4pPr marL="1371600" algn="l" defTabSz="914400" rtl="0" eaLnBrk="1" latinLnBrk="0" hangingPunct="1">
       <a:defRPr sz="1200" kern="1200">
         <a:solidFill>
           <a:schemeClr val="tx1"/>
@@ -411,7 +205,7 @@
         <a:cs typeface="+mn-cs"/>
       </a:defRPr>
     </a:lvl4pPr>
-    <a:lvl5pPr marL="1828800" algn="l" defTabSz="457200" rtl="0" eaLnBrk="1" latinLnBrk="0" hangingPunct="1">
+    <a:lvl5pPr marL="1828800" algn="l" defTabSz="914400" rtl="0" eaLnBrk="1" latinLnBrk="0" hangingPunct="1">
       <a:defRPr sz="1200" kern="1200">
         <a:solidFill>
           <a:schemeClr val="tx1"/>
@@ -421,7 +215,7 @@
         <a:cs typeface="+mn-cs"/>
       </a:defRPr>
     </a:lvl5pPr>
-    <a:lvl6pPr marL="2286000" algn="l" defTabSz="457200" rtl="0" eaLnBrk="1" latinLnBrk="0" hangingPunct="1">
+    <a:lvl6pPr marL="2286000" algn="l" defTabSz="914400" rtl="0" eaLnBrk="1" latinLnBrk="0" hangingPunct="1">
       <a:defRPr sz="1200" kern="1200">
         <a:solidFill>
           <a:schemeClr val="tx1"/>
@@ -431,7 +225,7 @@
         <a:cs typeface="+mn-cs"/>
       </a:defRPr>
     </a:lvl6pPr>
-    <a:lvl7pPr marL="2743200" algn="l" defTabSz="457200" rtl="0" eaLnBrk="1" latinLnBrk="0" hangingPunct="1">
+    <a:lvl7pPr marL="2743200" algn="l" defTabSz="914400" rtl="0" eaLnBrk="1" latinLnBrk="0" hangingPunct="1">
       <a:defRPr sz="1200" kern="1200">
         <a:solidFill>
           <a:schemeClr val="tx1"/>
@@ -441,7 +235,7 @@
         <a:cs typeface="+mn-cs"/>
       </a:defRPr>
     </a:lvl7pPr>
-    <a:lvl8pPr marL="3200400" algn="l" defTabSz="457200" rtl="0" eaLnBrk="1" latinLnBrk="0" hangingPunct="1">
+    <a:lvl8pPr marL="3200400" algn="l" defTabSz="914400" rtl="0" eaLnBrk="1" latinLnBrk="0" hangingPunct="1">
       <a:defRPr sz="1200" kern="1200">
         <a:solidFill>
           <a:schemeClr val="tx1"/>
@@ -451,7 +245,7 @@
         <a:cs typeface="+mn-cs"/>
       </a:defRPr>
     </a:lvl8pPr>
-    <a:lvl9pPr marL="3657600" algn="l" defTabSz="457200" rtl="0" eaLnBrk="1" latinLnBrk="0" hangingPunct="1">
+    <a:lvl9pPr marL="3657600" algn="l" defTabSz="914400" rtl="0" eaLnBrk="1" latinLnBrk="0" hangingPunct="1">
       <a:defRPr sz="1200" kern="1200">
         <a:solidFill>
           <a:schemeClr val="tx1"/>
@@ -466,7 +260,7 @@
 </file>
 
 <file path=ppt/notesSlides/notesSlide1.xml><?xml version="1.0" encoding="utf-8"?>
-<p:notes xmlns:a="http://schemas.openxmlformats.org/drawingml/2006/main" xmlns:p="http://schemas.openxmlformats.org/presentationml/2006/main" xmlns:r="http://schemas.openxmlformats.org/officeDocument/2006/relationships">
+<p:notes xmlns:a="http://schemas.openxmlformats.org/drawingml/2006/main" xmlns:r="http://schemas.openxmlformats.org/officeDocument/2006/relationships" xmlns:p="http://schemas.openxmlformats.org/presentationml/2006/main">
   <p:cSld>
     <p:spTree>
       <p:nvGrpSpPr>
@@ -486,7 +280,7 @@
         <p:nvSpPr>
           <p:cNvPr id="2" name="Slide Image Placeholder 1"/>
           <p:cNvSpPr>
-            <a:spLocks noGrp="1"/>
+            <a:spLocks noGrp="1" noRot="1" noChangeAspect="1"/>
           </p:cNvSpPr>
           <p:nvPr>
             <p:ph type="sldImg" idx="2"/>
@@ -501,7 +295,7 @@
             <a:spLocks noGrp="1"/>
           </p:cNvSpPr>
           <p:nvPr>
-            <p:ph type="body" idx="3" sz="quarter"/>
+            <p:ph type="body" sz="quarter" idx="3"/>
           </p:nvPr>
         </p:nvSpPr>
         <p:spPr/>
@@ -522,7 +316,7 @@
             <a:spLocks noGrp="1"/>
           </p:cNvSpPr>
           <p:nvPr>
-            <p:ph type="sldNum" idx="5" sz="quarter"/>
+            <p:ph type="sldNum" sz="quarter" idx="5"/>
           </p:nvPr>
         </p:nvSpPr>
         <p:spPr/>
@@ -536,7 +330,7 @@
 </file>
 
 <file path=ppt/notesSlides/notesSlide2.xml><?xml version="1.0" encoding="utf-8"?>
-<p:notes xmlns:a="http://schemas.openxmlformats.org/drawingml/2006/main" xmlns:p="http://schemas.openxmlformats.org/presentationml/2006/main" xmlns:r="http://schemas.openxmlformats.org/officeDocument/2006/relationships">
+<p:notes xmlns:a="http://schemas.openxmlformats.org/drawingml/2006/main" xmlns:r="http://schemas.openxmlformats.org/officeDocument/2006/relationships" xmlns:p="http://schemas.openxmlformats.org/presentationml/2006/main">
   <p:cSld>
     <p:spTree>
       <p:nvGrpSpPr>
@@ -556,7 +350,7 @@
         <p:nvSpPr>
           <p:cNvPr id="2" name="Slide Image Placeholder 1"/>
           <p:cNvSpPr>
-            <a:spLocks noGrp="1"/>
+            <a:spLocks noGrp="1" noRot="1" noChangeAspect="1"/>
           </p:cNvSpPr>
           <p:nvPr>
             <p:ph type="sldImg" idx="2"/>
@@ -571,7 +365,7 @@
             <a:spLocks noGrp="1"/>
           </p:cNvSpPr>
           <p:nvPr>
-            <p:ph type="body" idx="3" sz="quarter"/>
+            <p:ph type="body" sz="quarter" idx="3"/>
           </p:nvPr>
         </p:nvSpPr>
         <p:spPr/>
@@ -592,7 +386,7 @@
             <a:spLocks noGrp="1"/>
           </p:cNvSpPr>
           <p:nvPr>
-            <p:ph type="sldNum" idx="5" sz="quarter"/>
+            <p:ph type="sldNum" sz="quarter" idx="5"/>
           </p:nvPr>
         </p:nvSpPr>
         <p:spPr/>
@@ -606,7 +400,7 @@
 </file>
 
 <file path=ppt/notesSlides/notesSlide3.xml><?xml version="1.0" encoding="utf-8"?>
-<p:notes xmlns:a="http://schemas.openxmlformats.org/drawingml/2006/main" xmlns:p="http://schemas.openxmlformats.org/presentationml/2006/main" xmlns:r="http://schemas.openxmlformats.org/officeDocument/2006/relationships">
+<p:notes xmlns:a="http://schemas.openxmlformats.org/drawingml/2006/main" xmlns:r="http://schemas.openxmlformats.org/officeDocument/2006/relationships" xmlns:p="http://schemas.openxmlformats.org/presentationml/2006/main">
   <p:cSld>
     <p:spTree>
       <p:nvGrpSpPr>
@@ -626,7 +420,7 @@
         <p:nvSpPr>
           <p:cNvPr id="2" name="Slide Image Placeholder 1"/>
           <p:cNvSpPr>
-            <a:spLocks noGrp="1"/>
+            <a:spLocks noGrp="1" noRot="1" noChangeAspect="1"/>
           </p:cNvSpPr>
           <p:nvPr>
             <p:ph type="sldImg" idx="2"/>
@@ -641,7 +435,7 @@
             <a:spLocks noGrp="1"/>
           </p:cNvSpPr>
           <p:nvPr>
-            <p:ph type="body" idx="3" sz="quarter"/>
+            <p:ph type="body" sz="quarter" idx="3"/>
           </p:nvPr>
         </p:nvSpPr>
         <p:spPr/>
@@ -662,7 +456,7 @@
             <a:spLocks noGrp="1"/>
           </p:cNvSpPr>
           <p:nvPr>
-            <p:ph type="sldNum" idx="5" sz="quarter"/>
+            <p:ph type="sldNum" sz="quarter" idx="5"/>
           </p:nvPr>
         </p:nvSpPr>
         <p:spPr/>
@@ -676,7 +470,7 @@
 </file>
 
 <file path=ppt/notesSlides/notesSlide4.xml><?xml version="1.0" encoding="utf-8"?>
-<p:notes xmlns:a="http://schemas.openxmlformats.org/drawingml/2006/main" xmlns:p="http://schemas.openxmlformats.org/presentationml/2006/main" xmlns:r="http://schemas.openxmlformats.org/officeDocument/2006/relationships">
+<p:notes xmlns:a="http://schemas.openxmlformats.org/drawingml/2006/main" xmlns:r="http://schemas.openxmlformats.org/officeDocument/2006/relationships" xmlns:p="http://schemas.openxmlformats.org/presentationml/2006/main">
   <p:cSld>
     <p:spTree>
       <p:nvGrpSpPr>
@@ -696,7 +490,7 @@
         <p:nvSpPr>
           <p:cNvPr id="2" name="Slide Image Placeholder 1"/>
           <p:cNvSpPr>
-            <a:spLocks noGrp="1"/>
+            <a:spLocks noGrp="1" noRot="1" noChangeAspect="1"/>
           </p:cNvSpPr>
           <p:nvPr>
             <p:ph type="sldImg" idx="2"/>
@@ -711,7 +505,7 @@
             <a:spLocks noGrp="1"/>
           </p:cNvSpPr>
           <p:nvPr>
-            <p:ph type="body" idx="3" sz="quarter"/>
+            <p:ph type="body" sz="quarter" idx="3"/>
           </p:nvPr>
         </p:nvSpPr>
         <p:spPr/>
@@ -732,7 +526,7 @@
             <a:spLocks noGrp="1"/>
           </p:cNvSpPr>
           <p:nvPr>
-            <p:ph type="sldNum" idx="5" sz="quarter"/>
+            <p:ph type="sldNum" sz="quarter" idx="5"/>
           </p:nvPr>
         </p:nvSpPr>
         <p:spPr/>
@@ -746,7 +540,7 @@
 </file>
 
 <file path=ppt/notesSlides/notesSlide5.xml><?xml version="1.0" encoding="utf-8"?>
-<p:notes xmlns:a="http://schemas.openxmlformats.org/drawingml/2006/main" xmlns:p="http://schemas.openxmlformats.org/presentationml/2006/main" xmlns:r="http://schemas.openxmlformats.org/officeDocument/2006/relationships">
+<p:notes xmlns:a="http://schemas.openxmlformats.org/drawingml/2006/main" xmlns:r="http://schemas.openxmlformats.org/officeDocument/2006/relationships" xmlns:p="http://schemas.openxmlformats.org/presentationml/2006/main">
   <p:cSld>
     <p:spTree>
       <p:nvGrpSpPr>
@@ -766,7 +560,7 @@
         <p:nvSpPr>
           <p:cNvPr id="2" name="Slide Image Placeholder 1"/>
           <p:cNvSpPr>
-            <a:spLocks noGrp="1"/>
+            <a:spLocks noGrp="1" noRot="1" noChangeAspect="1"/>
           </p:cNvSpPr>
           <p:nvPr>
             <p:ph type="sldImg" idx="2"/>
@@ -781,7 +575,7 @@
             <a:spLocks noGrp="1"/>
           </p:cNvSpPr>
           <p:nvPr>
-            <p:ph type="body" idx="3" sz="quarter"/>
+            <p:ph type="body" sz="quarter" idx="3"/>
           </p:nvPr>
         </p:nvSpPr>
         <p:spPr/>
@@ -802,7 +596,7 @@
             <a:spLocks noGrp="1"/>
           </p:cNvSpPr>
           <p:nvPr>
-            <p:ph type="sldNum" idx="5" sz="quarter"/>
+            <p:ph type="sldNum" sz="quarter" idx="5"/>
           </p:nvPr>
         </p:nvSpPr>
         <p:spPr/>
@@ -816,7 +610,7 @@
 </file>
 
 <file path=ppt/notesSlides/notesSlide6.xml><?xml version="1.0" encoding="utf-8"?>
-<p:notes xmlns:a="http://schemas.openxmlformats.org/drawingml/2006/main" xmlns:p="http://schemas.openxmlformats.org/presentationml/2006/main" xmlns:r="http://schemas.openxmlformats.org/officeDocument/2006/relationships">
+<p:notes xmlns:a="http://schemas.openxmlformats.org/drawingml/2006/main" xmlns:r="http://schemas.openxmlformats.org/officeDocument/2006/relationships" xmlns:p="http://schemas.openxmlformats.org/presentationml/2006/main">
   <p:cSld>
     <p:spTree>
       <p:nvGrpSpPr>
@@ -836,7 +630,7 @@
         <p:nvSpPr>
           <p:cNvPr id="2" name="Slide Image Placeholder 1"/>
           <p:cNvSpPr>
-            <a:spLocks noGrp="1"/>
+            <a:spLocks noGrp="1" noRot="1" noChangeAspect="1"/>
           </p:cNvSpPr>
           <p:nvPr>
             <p:ph type="sldImg" idx="2"/>
@@ -851,7 +645,7 @@
             <a:spLocks noGrp="1"/>
           </p:cNvSpPr>
           <p:nvPr>
-            <p:ph type="body" idx="3" sz="quarter"/>
+            <p:ph type="body" sz="quarter" idx="3"/>
           </p:nvPr>
         </p:nvSpPr>
         <p:spPr/>
@@ -872,7 +666,7 @@
             <a:spLocks noGrp="1"/>
           </p:cNvSpPr>
           <p:nvPr>
-            <p:ph type="sldNum" idx="5" sz="quarter"/>
+            <p:ph type="sldNum" sz="quarter" idx="5"/>
           </p:nvPr>
         </p:nvSpPr>
         <p:spPr/>
@@ -886,7 +680,7 @@
 </file>
 
 <file path=ppt/notesSlides/notesSlide7.xml><?xml version="1.0" encoding="utf-8"?>
-<p:notes xmlns:a="http://schemas.openxmlformats.org/drawingml/2006/main" xmlns:p="http://schemas.openxmlformats.org/presentationml/2006/main" xmlns:r="http://schemas.openxmlformats.org/officeDocument/2006/relationships">
+<p:notes xmlns:a="http://schemas.openxmlformats.org/drawingml/2006/main" xmlns:r="http://schemas.openxmlformats.org/officeDocument/2006/relationships" xmlns:p="http://schemas.openxmlformats.org/presentationml/2006/main">
   <p:cSld>
     <p:spTree>
       <p:nvGrpSpPr>
@@ -906,7 +700,7 @@
         <p:nvSpPr>
           <p:cNvPr id="2" name="Slide Image Placeholder 1"/>
           <p:cNvSpPr>
-            <a:spLocks noGrp="1"/>
+            <a:spLocks noGrp="1" noRot="1" noChangeAspect="1"/>
           </p:cNvSpPr>
           <p:nvPr>
             <p:ph type="sldImg" idx="2"/>
@@ -921,7 +715,7 @@
             <a:spLocks noGrp="1"/>
           </p:cNvSpPr>
           <p:nvPr>
-            <p:ph type="body" idx="3" sz="quarter"/>
+            <p:ph type="body" sz="quarter" idx="3"/>
           </p:nvPr>
         </p:nvSpPr>
         <p:spPr/>
@@ -942,7 +736,7 @@
             <a:spLocks noGrp="1"/>
           </p:cNvSpPr>
           <p:nvPr>
-            <p:ph type="sldNum" idx="5" sz="quarter"/>
+            <p:ph type="sldNum" sz="quarter" idx="5"/>
           </p:nvPr>
         </p:nvSpPr>
         <p:spPr/>
@@ -956,7 +750,7 @@
 </file>
 
 <file path=ppt/notesSlides/notesSlide8.xml><?xml version="1.0" encoding="utf-8"?>
-<p:notes xmlns:a="http://schemas.openxmlformats.org/drawingml/2006/main" xmlns:p="http://schemas.openxmlformats.org/presentationml/2006/main" xmlns:r="http://schemas.openxmlformats.org/officeDocument/2006/relationships">
+<p:notes xmlns:a="http://schemas.openxmlformats.org/drawingml/2006/main" xmlns:r="http://schemas.openxmlformats.org/officeDocument/2006/relationships" xmlns:p="http://schemas.openxmlformats.org/presentationml/2006/main">
   <p:cSld>
     <p:spTree>
       <p:nvGrpSpPr>
@@ -976,7 +770,7 @@
         <p:nvSpPr>
           <p:cNvPr id="2" name="Slide Image Placeholder 1"/>
           <p:cNvSpPr>
-            <a:spLocks noGrp="1"/>
+            <a:spLocks noGrp="1" noRot="1" noChangeAspect="1"/>
           </p:cNvSpPr>
           <p:nvPr>
             <p:ph type="sldImg" idx="2"/>
@@ -991,7 +785,7 @@
             <a:spLocks noGrp="1"/>
           </p:cNvSpPr>
           <p:nvPr>
-            <p:ph type="body" idx="3" sz="quarter"/>
+            <p:ph type="body" sz="quarter" idx="3"/>
           </p:nvPr>
         </p:nvSpPr>
         <p:spPr/>
@@ -1012,7 +806,7 @@
             <a:spLocks noGrp="1"/>
           </p:cNvSpPr>
           <p:nvPr>
-            <p:ph type="sldNum" idx="5" sz="quarter"/>
+            <p:ph type="sldNum" sz="quarter" idx="5"/>
           </p:nvPr>
         </p:nvSpPr>
         <p:spPr/>
@@ -1026,7 +820,7 @@
 </file>
 
 <file path=ppt/notesSlides/notesSlide9.xml><?xml version="1.0" encoding="utf-8"?>
-<p:notes xmlns:a="http://schemas.openxmlformats.org/drawingml/2006/main" xmlns:p="http://schemas.openxmlformats.org/presentationml/2006/main" xmlns:r="http://schemas.openxmlformats.org/officeDocument/2006/relationships">
+<p:notes xmlns:a="http://schemas.openxmlformats.org/drawingml/2006/main" xmlns:r="http://schemas.openxmlformats.org/officeDocument/2006/relationships" xmlns:p="http://schemas.openxmlformats.org/presentationml/2006/main">
   <p:cSld>
     <p:spTree>
       <p:nvGrpSpPr>
@@ -1046,7 +840,7 @@
         <p:nvSpPr>
           <p:cNvPr id="2" name="Slide Image Placeholder 1"/>
           <p:cNvSpPr>
-            <a:spLocks noGrp="1"/>
+            <a:spLocks noGrp="1" noRot="1" noChangeAspect="1"/>
           </p:cNvSpPr>
           <p:nvPr>
             <p:ph type="sldImg" idx="2"/>
@@ -1061,7 +855,7 @@
             <a:spLocks noGrp="1"/>
           </p:cNvSpPr>
           <p:nvPr>
-            <p:ph type="body" idx="3" sz="quarter"/>
+            <p:ph type="body" sz="quarter" idx="3"/>
           </p:nvPr>
         </p:nvSpPr>
         <p:spPr/>
@@ -1082,7 +876,7 @@
             <a:spLocks noGrp="1"/>
           </p:cNvSpPr>
           <p:nvPr>
-            <p:ph type="sldNum" idx="5" sz="quarter"/>
+            <p:ph type="sldNum" sz="quarter" idx="5"/>
           </p:nvPr>
         </p:nvSpPr>
         <p:spPr/>
@@ -1133,10 +927,9 @@
           <a:lstStyle/>
           <a:p>
             <a:r>
-              <a:rPr lang="en-US" smtClean="0"/>
+              <a:rPr lang="en-US"/>
               <a:t>Click to edit Master title style</a:t>
             </a:r>
-            <a:endParaRPr lang="en-US"/>
           </a:p>
         </p:txBody>
       </p:sp>
@@ -1252,10 +1045,9 @@
           </a:lstStyle>
           <a:p>
             <a:r>
-              <a:rPr lang="en-US" smtClean="0"/>
+              <a:rPr lang="en-US"/>
               <a:t>Click to edit Master subtitle style</a:t>
             </a:r>
-            <a:endParaRPr lang="en-US"/>
           </a:p>
         </p:txBody>
       </p:sp>
@@ -1276,7 +1068,7 @@
           <a:p>
             <a:fld id="{5BCAD085-E8A6-8845-BD4E-CB4CCA059FC4}" type="datetimeFigureOut">
               <a:rPr lang="en-US" smtClean="0"/>
-              <a:t>1/27/13</a:t>
+              <a:t>8/31/2026</a:t>
             </a:fld>
             <a:endParaRPr lang="en-US"/>
           </a:p>
@@ -1370,10 +1162,9 @@
           <a:lstStyle/>
           <a:p>
             <a:r>
-              <a:rPr lang="en-US" smtClean="0"/>
+              <a:rPr lang="en-US"/>
               <a:t>Click to edit Master title style</a:t>
             </a:r>
-            <a:endParaRPr lang="en-US"/>
           </a:p>
         </p:txBody>
       </p:sp>
@@ -1394,38 +1185,37 @@
           <a:p>
             <a:pPr lvl="0"/>
             <a:r>
-              <a:rPr lang="en-US" smtClean="0"/>
+              <a:rPr lang="en-US"/>
               <a:t>Click to edit Master text styles</a:t>
             </a:r>
           </a:p>
           <a:p>
             <a:pPr lvl="1"/>
             <a:r>
-              <a:rPr lang="en-US" smtClean="0"/>
+              <a:rPr lang="en-US"/>
               <a:t>Second level</a:t>
             </a:r>
           </a:p>
           <a:p>
             <a:pPr lvl="2"/>
             <a:r>
-              <a:rPr lang="en-US" smtClean="0"/>
+              <a:rPr lang="en-US"/>
               <a:t>Third level</a:t>
             </a:r>
           </a:p>
           <a:p>
             <a:pPr lvl="3"/>
             <a:r>
-              <a:rPr lang="en-US" smtClean="0"/>
+              <a:rPr lang="en-US"/>
               <a:t>Fourth level</a:t>
             </a:r>
           </a:p>
           <a:p>
             <a:pPr lvl="4"/>
             <a:r>
-              <a:rPr lang="en-US" smtClean="0"/>
+              <a:rPr lang="en-US"/>
               <a:t>Fifth level</a:t>
             </a:r>
-            <a:endParaRPr lang="en-US"/>
           </a:p>
         </p:txBody>
       </p:sp>
@@ -1446,7 +1236,7 @@
           <a:p>
             <a:fld id="{5BCAD085-E8A6-8845-BD4E-CB4CCA059FC4}" type="datetimeFigureOut">
               <a:rPr lang="en-US" smtClean="0"/>
-              <a:t>1/27/13</a:t>
+              <a:t>8/31/2026</a:t>
             </a:fld>
             <a:endParaRPr lang="en-US"/>
           </a:p>
@@ -1545,10 +1335,9 @@
           <a:lstStyle/>
           <a:p>
             <a:r>
-              <a:rPr lang="en-US" smtClean="0"/>
+              <a:rPr lang="en-US"/>
               <a:t>Click to edit Master title style</a:t>
             </a:r>
-            <a:endParaRPr lang="en-US"/>
           </a:p>
         </p:txBody>
       </p:sp>
@@ -1574,38 +1363,37 @@
           <a:p>
             <a:pPr lvl="0"/>
             <a:r>
-              <a:rPr lang="en-US" smtClean="0"/>
+              <a:rPr lang="en-US"/>
               <a:t>Click to edit Master text styles</a:t>
             </a:r>
           </a:p>
           <a:p>
             <a:pPr lvl="1"/>
             <a:r>
-              <a:rPr lang="en-US" smtClean="0"/>
+              <a:rPr lang="en-US"/>
               <a:t>Second level</a:t>
             </a:r>
           </a:p>
           <a:p>
             <a:pPr lvl="2"/>
             <a:r>
-              <a:rPr lang="en-US" smtClean="0"/>
+              <a:rPr lang="en-US"/>
               <a:t>Third level</a:t>
             </a:r>
           </a:p>
           <a:p>
             <a:pPr lvl="3"/>
             <a:r>
-              <a:rPr lang="en-US" smtClean="0"/>
+              <a:rPr lang="en-US"/>
               <a:t>Fourth level</a:t>
             </a:r>
           </a:p>
           <a:p>
             <a:pPr lvl="4"/>
             <a:r>
-              <a:rPr lang="en-US" smtClean="0"/>
+              <a:rPr lang="en-US"/>
               <a:t>Fifth level</a:t>
             </a:r>
-            <a:endParaRPr lang="en-US"/>
           </a:p>
         </p:txBody>
       </p:sp>
@@ -1626,7 +1414,7 @@
           <a:p>
             <a:fld id="{5BCAD085-E8A6-8845-BD4E-CB4CCA059FC4}" type="datetimeFigureOut">
               <a:rPr lang="en-US" smtClean="0"/>
-              <a:t>1/27/13</a:t>
+              <a:t>8/31/2026</a:t>
             </a:fld>
             <a:endParaRPr lang="en-US"/>
           </a:p>
@@ -1720,10 +1508,9 @@
           <a:lstStyle/>
           <a:p>
             <a:r>
-              <a:rPr lang="en-US" smtClean="0"/>
+              <a:rPr lang="en-US"/>
               <a:t>Click to edit Master title style</a:t>
             </a:r>
-            <a:endParaRPr lang="en-US"/>
           </a:p>
         </p:txBody>
       </p:sp>
@@ -1744,38 +1531,37 @@
           <a:p>
             <a:pPr lvl="0"/>
             <a:r>
-              <a:rPr lang="en-US" smtClean="0"/>
+              <a:rPr lang="en-US"/>
               <a:t>Click to edit Master text styles</a:t>
             </a:r>
           </a:p>
           <a:p>
             <a:pPr lvl="1"/>
             <a:r>
-              <a:rPr lang="en-US" smtClean="0"/>
+              <a:rPr lang="en-US"/>
               <a:t>Second level</a:t>
             </a:r>
           </a:p>
           <a:p>
             <a:pPr lvl="2"/>
             <a:r>
-              <a:rPr lang="en-US" smtClean="0"/>
+              <a:rPr lang="en-US"/>
               <a:t>Third level</a:t>
             </a:r>
           </a:p>
           <a:p>
             <a:pPr lvl="3"/>
             <a:r>
-              <a:rPr lang="en-US" smtClean="0"/>
+              <a:rPr lang="en-US"/>
               <a:t>Fourth level</a:t>
             </a:r>
           </a:p>
           <a:p>
             <a:pPr lvl="4"/>
             <a:r>
-              <a:rPr lang="en-US" smtClean="0"/>
+              <a:rPr lang="en-US"/>
               <a:t>Fifth level</a:t>
             </a:r>
-            <a:endParaRPr lang="en-US"/>
           </a:p>
         </p:txBody>
       </p:sp>
@@ -1796,7 +1582,7 @@
           <a:p>
             <a:fld id="{5BCAD085-E8A6-8845-BD4E-CB4CCA059FC4}" type="datetimeFigureOut">
               <a:rPr lang="en-US" smtClean="0"/>
-              <a:t>1/27/13</a:t>
+              <a:t>8/31/2026</a:t>
             </a:fld>
             <a:endParaRPr lang="en-US"/>
           </a:p>
@@ -1899,10 +1685,9 @@
           </a:lstStyle>
           <a:p>
             <a:r>
-              <a:rPr lang="en-US" smtClean="0"/>
+              <a:rPr lang="en-US"/>
               <a:t>Click to edit Master title style</a:t>
             </a:r>
-            <a:endParaRPr lang="en-US"/>
           </a:p>
         </p:txBody>
       </p:sp>
@@ -2019,7 +1804,7 @@
           <a:p>
             <a:pPr lvl="0"/>
             <a:r>
-              <a:rPr lang="en-US" smtClean="0"/>
+              <a:rPr lang="en-US"/>
               <a:t>Click to edit Master text styles</a:t>
             </a:r>
           </a:p>
@@ -2042,7 +1827,7 @@
           <a:p>
             <a:fld id="{5BCAD085-E8A6-8845-BD4E-CB4CCA059FC4}" type="datetimeFigureOut">
               <a:rPr lang="en-US" smtClean="0"/>
-              <a:t>1/27/13</a:t>
+              <a:t>8/31/2026</a:t>
             </a:fld>
             <a:endParaRPr lang="en-US"/>
           </a:p>
@@ -2136,10 +1921,9 @@
           <a:lstStyle/>
           <a:p>
             <a:r>
-              <a:rPr lang="en-US" smtClean="0"/>
+              <a:rPr lang="en-US"/>
               <a:t>Click to edit Master title style</a:t>
             </a:r>
-            <a:endParaRPr lang="en-US"/>
           </a:p>
         </p:txBody>
       </p:sp>
@@ -2193,38 +1977,37 @@
           <a:p>
             <a:pPr lvl="0"/>
             <a:r>
-              <a:rPr lang="en-US" smtClean="0"/>
+              <a:rPr lang="en-US"/>
               <a:t>Click to edit Master text styles</a:t>
             </a:r>
           </a:p>
           <a:p>
             <a:pPr lvl="1"/>
             <a:r>
-              <a:rPr lang="en-US" smtClean="0"/>
+              <a:rPr lang="en-US"/>
               <a:t>Second level</a:t>
             </a:r>
           </a:p>
           <a:p>
             <a:pPr lvl="2"/>
             <a:r>
-              <a:rPr lang="en-US" smtClean="0"/>
+              <a:rPr lang="en-US"/>
               <a:t>Third level</a:t>
             </a:r>
           </a:p>
           <a:p>
             <a:pPr lvl="3"/>
             <a:r>
-              <a:rPr lang="en-US" smtClean="0"/>
+              <a:rPr lang="en-US"/>
               <a:t>Fourth level</a:t>
             </a:r>
           </a:p>
           <a:p>
             <a:pPr lvl="4"/>
             <a:r>
-              <a:rPr lang="en-US" smtClean="0"/>
+              <a:rPr lang="en-US"/>
               <a:t>Fifth level</a:t>
             </a:r>
-            <a:endParaRPr lang="en-US"/>
           </a:p>
         </p:txBody>
       </p:sp>
@@ -2278,38 +2061,37 @@
           <a:p>
             <a:pPr lvl="0"/>
             <a:r>
-              <a:rPr lang="en-US" smtClean="0"/>
+              <a:rPr lang="en-US"/>
               <a:t>Click to edit Master text styles</a:t>
             </a:r>
           </a:p>
           <a:p>
             <a:pPr lvl="1"/>
             <a:r>
-              <a:rPr lang="en-US" smtClean="0"/>
+              <a:rPr lang="en-US"/>
               <a:t>Second level</a:t>
             </a:r>
           </a:p>
           <a:p>
             <a:pPr lvl="2"/>
             <a:r>
-              <a:rPr lang="en-US" smtClean="0"/>
+              <a:rPr lang="en-US"/>
               <a:t>Third level</a:t>
             </a:r>
           </a:p>
           <a:p>
             <a:pPr lvl="3"/>
             <a:r>
-              <a:rPr lang="en-US" smtClean="0"/>
+              <a:rPr lang="en-US"/>
               <a:t>Fourth level</a:t>
             </a:r>
           </a:p>
           <a:p>
             <a:pPr lvl="4"/>
             <a:r>
-              <a:rPr lang="en-US" smtClean="0"/>
+              <a:rPr lang="en-US"/>
               <a:t>Fifth level</a:t>
             </a:r>
-            <a:endParaRPr lang="en-US"/>
           </a:p>
         </p:txBody>
       </p:sp>
@@ -2330,7 +2112,7 @@
           <a:p>
             <a:fld id="{5BCAD085-E8A6-8845-BD4E-CB4CCA059FC4}" type="datetimeFigureOut">
               <a:rPr lang="en-US" smtClean="0"/>
-              <a:t>1/27/13</a:t>
+              <a:t>8/31/2026</a:t>
             </a:fld>
             <a:endParaRPr lang="en-US"/>
           </a:p>
@@ -2428,10 +2210,9 @@
           </a:lstStyle>
           <a:p>
             <a:r>
-              <a:rPr lang="en-US" smtClean="0"/>
+              <a:rPr lang="en-US"/>
               <a:t>Click to edit Master title style</a:t>
             </a:r>
-            <a:endParaRPr lang="en-US"/>
           </a:p>
         </p:txBody>
       </p:sp>
@@ -2494,7 +2275,7 @@
           <a:p>
             <a:pPr lvl="0"/>
             <a:r>
-              <a:rPr lang="en-US" smtClean="0"/>
+              <a:rPr lang="en-US"/>
               <a:t>Click to edit Master text styles</a:t>
             </a:r>
           </a:p>
@@ -2550,38 +2331,37 @@
           <a:p>
             <a:pPr lvl="0"/>
             <a:r>
-              <a:rPr lang="en-US" smtClean="0"/>
+              <a:rPr lang="en-US"/>
               <a:t>Click to edit Master text styles</a:t>
             </a:r>
           </a:p>
           <a:p>
             <a:pPr lvl="1"/>
             <a:r>
-              <a:rPr lang="en-US" smtClean="0"/>
+              <a:rPr lang="en-US"/>
               <a:t>Second level</a:t>
             </a:r>
           </a:p>
           <a:p>
             <a:pPr lvl="2"/>
             <a:r>
-              <a:rPr lang="en-US" smtClean="0"/>
+              <a:rPr lang="en-US"/>
               <a:t>Third level</a:t>
             </a:r>
           </a:p>
           <a:p>
             <a:pPr lvl="3"/>
             <a:r>
-              <a:rPr lang="en-US" smtClean="0"/>
+              <a:rPr lang="en-US"/>
               <a:t>Fourth level</a:t>
             </a:r>
           </a:p>
           <a:p>
             <a:pPr lvl="4"/>
             <a:r>
-              <a:rPr lang="en-US" smtClean="0"/>
+              <a:rPr lang="en-US"/>
               <a:t>Fifth level</a:t>
             </a:r>
-            <a:endParaRPr lang="en-US"/>
           </a:p>
         </p:txBody>
       </p:sp>
@@ -2644,7 +2424,7 @@
           <a:p>
             <a:pPr lvl="0"/>
             <a:r>
-              <a:rPr lang="en-US" smtClean="0"/>
+              <a:rPr lang="en-US"/>
               <a:t>Click to edit Master text styles</a:t>
             </a:r>
           </a:p>
@@ -2700,38 +2480,37 @@
           <a:p>
             <a:pPr lvl="0"/>
             <a:r>
-              <a:rPr lang="en-US" smtClean="0"/>
+              <a:rPr lang="en-US"/>
               <a:t>Click to edit Master text styles</a:t>
             </a:r>
           </a:p>
           <a:p>
             <a:pPr lvl="1"/>
             <a:r>
-              <a:rPr lang="en-US" smtClean="0"/>
+              <a:rPr lang="en-US"/>
               <a:t>Second level</a:t>
             </a:r>
           </a:p>
           <a:p>
             <a:pPr lvl="2"/>
             <a:r>
-              <a:rPr lang="en-US" smtClean="0"/>
+              <a:rPr lang="en-US"/>
               <a:t>Third level</a:t>
             </a:r>
           </a:p>
           <a:p>
             <a:pPr lvl="3"/>
             <a:r>
-              <a:rPr lang="en-US" smtClean="0"/>
+              <a:rPr lang="en-US"/>
               <a:t>Fourth level</a:t>
             </a:r>
           </a:p>
           <a:p>
             <a:pPr lvl="4"/>
             <a:r>
-              <a:rPr lang="en-US" smtClean="0"/>
+              <a:rPr lang="en-US"/>
               <a:t>Fifth level</a:t>
             </a:r>
-            <a:endParaRPr lang="en-US"/>
           </a:p>
         </p:txBody>
       </p:sp>
@@ -2752,7 +2531,7 @@
           <a:p>
             <a:fld id="{5BCAD085-E8A6-8845-BD4E-CB4CCA059FC4}" type="datetimeFigureOut">
               <a:rPr lang="en-US" smtClean="0"/>
-              <a:t>1/27/13</a:t>
+              <a:t>8/31/2026</a:t>
             </a:fld>
             <a:endParaRPr lang="en-US"/>
           </a:p>
@@ -2846,10 +2625,9 @@
           <a:lstStyle/>
           <a:p>
             <a:r>
-              <a:rPr lang="en-US" smtClean="0"/>
+              <a:rPr lang="en-US"/>
               <a:t>Click to edit Master title style</a:t>
             </a:r>
-            <a:endParaRPr lang="en-US"/>
           </a:p>
         </p:txBody>
       </p:sp>
@@ -2870,7 +2648,7 @@
           <a:p>
             <a:fld id="{5BCAD085-E8A6-8845-BD4E-CB4CCA059FC4}" type="datetimeFigureOut">
               <a:rPr lang="en-US" smtClean="0"/>
-              <a:t>1/27/13</a:t>
+              <a:t>8/31/2026</a:t>
             </a:fld>
             <a:endParaRPr lang="en-US"/>
           </a:p>
@@ -2965,7 +2743,7 @@
           <a:p>
             <a:fld id="{5BCAD085-E8A6-8845-BD4E-CB4CCA059FC4}" type="datetimeFigureOut">
               <a:rPr lang="en-US" smtClean="0"/>
-              <a:t>1/27/13</a:t>
+              <a:t>8/31/2026</a:t>
             </a:fld>
             <a:endParaRPr lang="en-US"/>
           </a:p>
@@ -3068,10 +2846,9 @@
           </a:lstStyle>
           <a:p>
             <a:r>
-              <a:rPr lang="en-US" smtClean="0"/>
+              <a:rPr lang="en-US"/>
               <a:t>Click to edit Master title style</a:t>
             </a:r>
-            <a:endParaRPr lang="en-US"/>
           </a:p>
         </p:txBody>
       </p:sp>
@@ -3125,38 +2902,37 @@
           <a:p>
             <a:pPr lvl="0"/>
             <a:r>
-              <a:rPr lang="en-US" smtClean="0"/>
+              <a:rPr lang="en-US"/>
               <a:t>Click to edit Master text styles</a:t>
             </a:r>
           </a:p>
           <a:p>
             <a:pPr lvl="1"/>
             <a:r>
-              <a:rPr lang="en-US" smtClean="0"/>
+              <a:rPr lang="en-US"/>
               <a:t>Second level</a:t>
             </a:r>
           </a:p>
           <a:p>
             <a:pPr lvl="2"/>
             <a:r>
-              <a:rPr lang="en-US" smtClean="0"/>
+              <a:rPr lang="en-US"/>
               <a:t>Third level</a:t>
             </a:r>
           </a:p>
           <a:p>
             <a:pPr lvl="3"/>
             <a:r>
-              <a:rPr lang="en-US" smtClean="0"/>
+              <a:rPr lang="en-US"/>
               <a:t>Fourth level</a:t>
             </a:r>
           </a:p>
           <a:p>
             <a:pPr lvl="4"/>
             <a:r>
-              <a:rPr lang="en-US" smtClean="0"/>
+              <a:rPr lang="en-US"/>
               <a:t>Fifth level</a:t>
             </a:r>
-            <a:endParaRPr lang="en-US"/>
           </a:p>
         </p:txBody>
       </p:sp>
@@ -3219,7 +2995,7 @@
           <a:p>
             <a:pPr lvl="0"/>
             <a:r>
-              <a:rPr lang="en-US" smtClean="0"/>
+              <a:rPr lang="en-US"/>
               <a:t>Click to edit Master text styles</a:t>
             </a:r>
           </a:p>
@@ -3242,7 +3018,7 @@
           <a:p>
             <a:fld id="{5BCAD085-E8A6-8845-BD4E-CB4CCA059FC4}" type="datetimeFigureOut">
               <a:rPr lang="en-US" smtClean="0"/>
-              <a:t>1/27/13</a:t>
+              <a:t>8/31/2026</a:t>
             </a:fld>
             <a:endParaRPr lang="en-US"/>
           </a:p>
@@ -3345,10 +3121,9 @@
           </a:lstStyle>
           <a:p>
             <a:r>
-              <a:rPr lang="en-US" smtClean="0"/>
+              <a:rPr lang="en-US"/>
               <a:t>Click to edit Master title style</a:t>
             </a:r>
-            <a:endParaRPr lang="en-US"/>
           </a:p>
         </p:txBody>
       </p:sp>
@@ -3472,7 +3247,7 @@
           <a:p>
             <a:pPr lvl="0"/>
             <a:r>
-              <a:rPr lang="en-US" smtClean="0"/>
+              <a:rPr lang="en-US"/>
               <a:t>Click to edit Master text styles</a:t>
             </a:r>
           </a:p>
@@ -3495,7 +3270,7 @@
           <a:p>
             <a:fld id="{5BCAD085-E8A6-8845-BD4E-CB4CCA059FC4}" type="datetimeFigureOut">
               <a:rPr lang="en-US" smtClean="0"/>
-              <a:t>1/27/13</a:t>
+              <a:t>8/31/2026</a:t>
             </a:fld>
             <a:endParaRPr lang="en-US"/>
           </a:p>
@@ -3604,10 +3379,9 @@
           <a:lstStyle/>
           <a:p>
             <a:r>
-              <a:rPr lang="en-US" smtClean="0"/>
+              <a:rPr lang="en-US"/>
               <a:t>Click to edit Master title style</a:t>
             </a:r>
-            <a:endParaRPr lang="en-US"/>
           </a:p>
         </p:txBody>
       </p:sp>
@@ -3638,38 +3412,37 @@
           <a:p>
             <a:pPr lvl="0"/>
             <a:r>
-              <a:rPr lang="en-US" smtClean="0"/>
+              <a:rPr lang="en-US"/>
               <a:t>Click to edit Master text styles</a:t>
             </a:r>
           </a:p>
           <a:p>
             <a:pPr lvl="1"/>
             <a:r>
-              <a:rPr lang="en-US" smtClean="0"/>
+              <a:rPr lang="en-US"/>
               <a:t>Second level</a:t>
             </a:r>
           </a:p>
           <a:p>
             <a:pPr lvl="2"/>
             <a:r>
-              <a:rPr lang="en-US" smtClean="0"/>
+              <a:rPr lang="en-US"/>
               <a:t>Third level</a:t>
             </a:r>
           </a:p>
           <a:p>
             <a:pPr lvl="3"/>
             <a:r>
-              <a:rPr lang="en-US" smtClean="0"/>
+              <a:rPr lang="en-US"/>
               <a:t>Fourth level</a:t>
             </a:r>
           </a:p>
           <a:p>
             <a:pPr lvl="4"/>
             <a:r>
-              <a:rPr lang="en-US" smtClean="0"/>
+              <a:rPr lang="en-US"/>
               <a:t>Fifth level</a:t>
             </a:r>
-            <a:endParaRPr lang="en-US"/>
           </a:p>
         </p:txBody>
       </p:sp>
@@ -3708,7 +3481,7 @@
           <a:p>
             <a:fld id="{5BCAD085-E8A6-8845-BD4E-CB4CCA059FC4}" type="datetimeFigureOut">
               <a:rPr lang="en-US" smtClean="0"/>
-              <a:t>1/27/13</a:t>
+              <a:t>8/31/2026</a:t>
             </a:fld>
             <a:endParaRPr lang="en-US"/>
           </a:p>
@@ -4067,7 +3840,7 @@
 </file>
 
 <file path=ppt/slides/slide1.xml><?xml version="1.0" encoding="utf-8"?>
-<p:sld xmlns:a="http://schemas.openxmlformats.org/drawingml/2006/main" xmlns:p="http://schemas.openxmlformats.org/presentationml/2006/main" xmlns:r="http://schemas.openxmlformats.org/officeDocument/2006/relationships">
+<p:sld xmlns:a="http://schemas.openxmlformats.org/drawingml/2006/main" xmlns:r="http://schemas.openxmlformats.org/officeDocument/2006/relationships" xmlns:p="http://schemas.openxmlformats.org/presentationml/2006/main">
   <p:cSld>
     <p:bg>
       <p:bgPr>
@@ -4083,7 +3856,14 @@
         <p:cNvGrpSpPr/>
         <p:nvPr/>
       </p:nvGrpSpPr>
-      <p:grpSpPr/>
+      <p:grpSpPr>
+        <a:xfrm>
+          <a:off x="0" y="0"/>
+          <a:ext cx="0" cy="0"/>
+          <a:chOff x="0" y="0"/>
+          <a:chExt cx="0" cy="0"/>
+        </a:xfrm>
+      </p:grpSpPr>
       <p:sp>
         <p:nvSpPr>
           <p:cNvPr id="2" name="TextBox 1"/>
@@ -4101,7 +3881,7 @@
           <a:noFill/>
         </p:spPr>
         <p:txBody>
-          <a:bodyPr wrap="square" lIns="0" rIns="0" tIns="0" bIns="0">
+          <a:bodyPr wrap="square" lIns="0" tIns="0" rIns="0" bIns="0">
             <a:spAutoFit/>
           </a:bodyPr>
           <a:lstStyle/>
@@ -4144,7 +3924,7 @@
           <a:noFill/>
         </p:spPr>
         <p:txBody>
-          <a:bodyPr wrap="square" lIns="0" rIns="0" tIns="0" bIns="0">
+          <a:bodyPr wrap="square" lIns="0" tIns="0" rIns="0" bIns="0">
             <a:spAutoFit/>
           </a:bodyPr>
           <a:lstStyle/>
@@ -4183,7 +3963,7 @@
           <a:noFill/>
         </p:spPr>
         <p:txBody>
-          <a:bodyPr wrap="square" lIns="0" rIns="0" tIns="0" bIns="0">
+          <a:bodyPr wrap="square" lIns="0" tIns="0" rIns="0" bIns="0">
             <a:spAutoFit/>
           </a:bodyPr>
           <a:lstStyle/>
@@ -4230,7 +4010,7 @@
           <p:nvPr/>
         </p:nvPicPr>
         <p:blipFill>
-          <a:blip r:embed="rId2"/>
+          <a:blip r:embed="rId3"/>
           <a:stretch>
             <a:fillRect/>
           </a:stretch>
@@ -4254,7 +4034,7 @@
 </file>
 
 <file path=ppt/slides/slide2.xml><?xml version="1.0" encoding="utf-8"?>
-<p:sld xmlns:a="http://schemas.openxmlformats.org/drawingml/2006/main" xmlns:p="http://schemas.openxmlformats.org/presentationml/2006/main" xmlns:r="http://schemas.openxmlformats.org/officeDocument/2006/relationships">
+<p:sld xmlns:a="http://schemas.openxmlformats.org/drawingml/2006/main" xmlns:r="http://schemas.openxmlformats.org/officeDocument/2006/relationships" xmlns:p="http://schemas.openxmlformats.org/presentationml/2006/main">
   <p:cSld>
     <p:bg>
       <p:bgPr>
@@ -4270,7 +4050,14 @@
         <p:cNvGrpSpPr/>
         <p:nvPr/>
       </p:nvGrpSpPr>
-      <p:grpSpPr/>
+      <p:grpSpPr>
+        <a:xfrm>
+          <a:off x="0" y="0"/>
+          <a:ext cx="0" cy="0"/>
+          <a:chOff x="0" y="0"/>
+          <a:chExt cx="0" cy="0"/>
+        </a:xfrm>
+      </p:grpSpPr>
       <p:sp>
         <p:nvSpPr>
           <p:cNvPr id="2" name="TextBox 1"/>
@@ -4288,7 +4075,7 @@
           <a:noFill/>
         </p:spPr>
         <p:txBody>
-          <a:bodyPr wrap="square" lIns="0" rIns="0" tIns="0" bIns="0">
+          <a:bodyPr wrap="square" lIns="0" tIns="0" rIns="0" bIns="0">
             <a:spAutoFit/>
           </a:bodyPr>
           <a:lstStyle/>
@@ -4327,7 +4114,7 @@
           <a:noFill/>
         </p:spPr>
         <p:txBody>
-          <a:bodyPr wrap="square" lIns="0" rIns="0" tIns="0" bIns="0">
+          <a:bodyPr wrap="square" lIns="0" tIns="0" rIns="0" bIns="0">
             <a:spAutoFit/>
           </a:bodyPr>
           <a:lstStyle/>
@@ -4433,6 +4220,7 @@
           <a:lstStyle/>
           <a:p>
             <a:pPr algn="ctr"/>
+            <a:endParaRPr/>
           </a:p>
         </p:txBody>
       </p:sp>
@@ -4453,7 +4241,7 @@
           <a:noFill/>
         </p:spPr>
         <p:txBody>
-          <a:bodyPr wrap="square" lIns="0" rIns="0" tIns="0" bIns="0">
+          <a:bodyPr wrap="square" lIns="0" tIns="0" rIns="0" bIns="0">
             <a:spAutoFit/>
           </a:bodyPr>
           <a:lstStyle/>
@@ -4521,6 +4309,7 @@
           <a:lstStyle/>
           <a:p>
             <a:pPr algn="ctr"/>
+            <a:endParaRPr/>
           </a:p>
         </p:txBody>
       </p:sp>
@@ -4541,7 +4330,7 @@
           <a:noFill/>
         </p:spPr>
         <p:txBody>
-          <a:bodyPr wrap="square" lIns="0" rIns="0" tIns="0" bIns="0">
+          <a:bodyPr wrap="square" lIns="0" tIns="0" rIns="0" bIns="0">
             <a:spAutoFit/>
           </a:bodyPr>
           <a:lstStyle/>
@@ -4583,7 +4372,7 @@
           <a:noFill/>
         </p:spPr>
         <p:txBody>
-          <a:bodyPr wrap="square" lIns="0" rIns="0" tIns="0" bIns="0">
+          <a:bodyPr wrap="square" lIns="0" tIns="0" rIns="0" bIns="0">
             <a:spAutoFit/>
           </a:bodyPr>
           <a:lstStyle/>
@@ -4622,7 +4411,7 @@
           <a:noFill/>
         </p:spPr>
         <p:txBody>
-          <a:bodyPr wrap="square" lIns="0" rIns="0" tIns="0" bIns="0">
+          <a:bodyPr wrap="square" lIns="0" tIns="0" rIns="0" bIns="0">
             <a:spAutoFit/>
           </a:bodyPr>
           <a:lstStyle/>
@@ -4661,7 +4450,7 @@
           <a:noFill/>
         </p:spPr>
         <p:txBody>
-          <a:bodyPr wrap="square" lIns="0" rIns="0" tIns="0" bIns="0">
+          <a:bodyPr wrap="square" lIns="0" tIns="0" rIns="0" bIns="0">
             <a:spAutoFit/>
           </a:bodyPr>
           <a:lstStyle/>
@@ -4700,7 +4489,7 @@
           <a:noFill/>
         </p:spPr>
         <p:txBody>
-          <a:bodyPr wrap="square" lIns="0" rIns="0" tIns="0" bIns="0">
+          <a:bodyPr wrap="square" lIns="0" tIns="0" rIns="0" bIns="0">
             <a:spAutoFit/>
           </a:bodyPr>
           <a:lstStyle/>
@@ -4742,7 +4531,7 @@
           <a:noFill/>
         </p:spPr>
         <p:txBody>
-          <a:bodyPr wrap="square" lIns="0" rIns="0" tIns="0" bIns="0">
+          <a:bodyPr wrap="square" lIns="0" tIns="0" rIns="0" bIns="0">
             <a:spAutoFit/>
           </a:bodyPr>
           <a:lstStyle/>
@@ -4781,7 +4570,7 @@
           <a:noFill/>
         </p:spPr>
         <p:txBody>
-          <a:bodyPr wrap="square" lIns="0" rIns="0" tIns="0" bIns="0">
+          <a:bodyPr wrap="square" lIns="0" tIns="0" rIns="0" bIns="0">
             <a:spAutoFit/>
           </a:bodyPr>
           <a:lstStyle/>
@@ -4820,7 +4609,7 @@
           <a:noFill/>
         </p:spPr>
         <p:txBody>
-          <a:bodyPr wrap="square" lIns="0" rIns="0" tIns="0" bIns="0">
+          <a:bodyPr wrap="square" lIns="0" tIns="0" rIns="0" bIns="0">
             <a:spAutoFit/>
           </a:bodyPr>
           <a:lstStyle/>
@@ -4854,7 +4643,7 @@
 </file>
 
 <file path=ppt/slides/slide3.xml><?xml version="1.0" encoding="utf-8"?>
-<p:sld xmlns:a="http://schemas.openxmlformats.org/drawingml/2006/main" xmlns:p="http://schemas.openxmlformats.org/presentationml/2006/main" xmlns:r="http://schemas.openxmlformats.org/officeDocument/2006/relationships">
+<p:sld xmlns:a="http://schemas.openxmlformats.org/drawingml/2006/main" xmlns:r="http://schemas.openxmlformats.org/officeDocument/2006/relationships" xmlns:p="http://schemas.openxmlformats.org/presentationml/2006/main">
   <p:cSld>
     <p:bg>
       <p:bgPr>
@@ -4870,7 +4659,14 @@
         <p:cNvGrpSpPr/>
         <p:nvPr/>
       </p:nvGrpSpPr>
-      <p:grpSpPr/>
+      <p:grpSpPr>
+        <a:xfrm>
+          <a:off x="0" y="0"/>
+          <a:ext cx="0" cy="0"/>
+          <a:chOff x="0" y="0"/>
+          <a:chExt cx="0" cy="0"/>
+        </a:xfrm>
+      </p:grpSpPr>
       <p:sp>
         <p:nvSpPr>
           <p:cNvPr id="2" name="TextBox 1"/>
@@ -4888,7 +4684,7 @@
           <a:noFill/>
         </p:spPr>
         <p:txBody>
-          <a:bodyPr wrap="square" lIns="0" rIns="0" tIns="0" bIns="0">
+          <a:bodyPr wrap="square" lIns="0" tIns="0" rIns="0" bIns="0">
             <a:spAutoFit/>
           </a:bodyPr>
           <a:lstStyle/>
@@ -4951,7 +4747,7 @@
           </a:fontRef>
         </p:style>
         <p:txBody>
-          <a:bodyPr rtlCol="0" anchor="ctr" wrap="square"/>
+          <a:bodyPr wrap="square" rtlCol="0" anchor="ctr"/>
           <a:lstStyle/>
           <a:p>
             <a:pPr algn="ctr"/>
@@ -5009,6 +4805,7 @@
           <a:lstStyle/>
           <a:p>
             <a:pPr algn="ctr"/>
+            <a:endParaRPr/>
           </a:p>
         </p:txBody>
       </p:sp>
@@ -5053,7 +4850,7 @@
           </a:fontRef>
         </p:style>
         <p:txBody>
-          <a:bodyPr rtlCol="0" anchor="ctr" wrap="square"/>
+          <a:bodyPr wrap="square" rtlCol="0" anchor="ctr"/>
           <a:lstStyle/>
           <a:p>
             <a:pPr algn="ctr"/>
@@ -5110,6 +4907,7 @@
           <a:lstStyle/>
           <a:p>
             <a:pPr algn="ctr"/>
+            <a:endParaRPr/>
           </a:p>
         </p:txBody>
       </p:sp>
@@ -5154,7 +4952,7 @@
           </a:fontRef>
         </p:style>
         <p:txBody>
-          <a:bodyPr rtlCol="0" anchor="ctr" wrap="square"/>
+          <a:bodyPr wrap="square" rtlCol="0" anchor="ctr"/>
           <a:lstStyle/>
           <a:p>
             <a:pPr algn="ctr"/>
@@ -5211,6 +5009,7 @@
           <a:lstStyle/>
           <a:p>
             <a:pPr algn="ctr"/>
+            <a:endParaRPr/>
           </a:p>
         </p:txBody>
       </p:sp>
@@ -5255,7 +5054,7 @@
           </a:fontRef>
         </p:style>
         <p:txBody>
-          <a:bodyPr rtlCol="0" anchor="ctr" wrap="square"/>
+          <a:bodyPr wrap="square" rtlCol="0" anchor="ctr"/>
           <a:lstStyle/>
           <a:p>
             <a:pPr algn="ctr"/>
@@ -5312,6 +5111,7 @@
           <a:lstStyle/>
           <a:p>
             <a:pPr algn="ctr"/>
+            <a:endParaRPr/>
           </a:p>
         </p:txBody>
       </p:sp>
@@ -5356,7 +5156,7 @@
           </a:fontRef>
         </p:style>
         <p:txBody>
-          <a:bodyPr rtlCol="0" anchor="ctr" wrap="square"/>
+          <a:bodyPr wrap="square" rtlCol="0" anchor="ctr"/>
           <a:lstStyle/>
           <a:p>
             <a:pPr algn="ctr"/>
@@ -5390,7 +5190,7 @@
           <a:noFill/>
         </p:spPr>
         <p:txBody>
-          <a:bodyPr wrap="square" lIns="0" rIns="0" tIns="0" bIns="0">
+          <a:bodyPr wrap="square" lIns="0" tIns="0" rIns="0" bIns="0">
             <a:spAutoFit/>
           </a:bodyPr>
           <a:lstStyle/>
@@ -5429,7 +5229,7 @@
           <a:noFill/>
         </p:spPr>
         <p:txBody>
-          <a:bodyPr wrap="square" lIns="0" rIns="0" tIns="0" bIns="0">
+          <a:bodyPr wrap="square" lIns="0" tIns="0" rIns="0" bIns="0">
             <a:spAutoFit/>
           </a:bodyPr>
           <a:lstStyle/>
@@ -5468,7 +5268,7 @@
           <a:noFill/>
         </p:spPr>
         <p:txBody>
-          <a:bodyPr wrap="square" lIns="0" rIns="0" tIns="0" bIns="0">
+          <a:bodyPr wrap="square" lIns="0" tIns="0" rIns="0" bIns="0">
             <a:spAutoFit/>
           </a:bodyPr>
           <a:lstStyle/>
@@ -5529,7 +5329,7 @@
           <a:noFill/>
         </p:spPr>
         <p:txBody>
-          <a:bodyPr wrap="square" lIns="0" rIns="0" tIns="0" bIns="0">
+          <a:bodyPr wrap="square" lIns="0" tIns="0" rIns="0" bIns="0">
             <a:spAutoFit/>
           </a:bodyPr>
           <a:lstStyle/>
@@ -5568,7 +5368,7 @@
           <a:noFill/>
         </p:spPr>
         <p:txBody>
-          <a:bodyPr wrap="square" lIns="0" rIns="0" tIns="0" bIns="0">
+          <a:bodyPr wrap="square" lIns="0" tIns="0" rIns="0" bIns="0">
             <a:spAutoFit/>
           </a:bodyPr>
           <a:lstStyle/>
@@ -5610,7 +5410,7 @@
           <a:noFill/>
         </p:spPr>
         <p:txBody>
-          <a:bodyPr wrap="square" lIns="0" rIns="0" tIns="0" bIns="0">
+          <a:bodyPr wrap="square" lIns="0" tIns="0" rIns="0" bIns="0">
             <a:spAutoFit/>
           </a:bodyPr>
           <a:lstStyle/>
@@ -5649,7 +5449,7 @@
           <a:noFill/>
         </p:spPr>
         <p:txBody>
-          <a:bodyPr wrap="square" lIns="0" rIns="0" tIns="0" bIns="0">
+          <a:bodyPr wrap="square" lIns="0" tIns="0" rIns="0" bIns="0">
             <a:spAutoFit/>
           </a:bodyPr>
           <a:lstStyle/>
@@ -5683,7 +5483,7 @@
 </file>
 
 <file path=ppt/slides/slide4.xml><?xml version="1.0" encoding="utf-8"?>
-<p:sld xmlns:a="http://schemas.openxmlformats.org/drawingml/2006/main" xmlns:p="http://schemas.openxmlformats.org/presentationml/2006/main" xmlns:r="http://schemas.openxmlformats.org/officeDocument/2006/relationships">
+<p:sld xmlns:a="http://schemas.openxmlformats.org/drawingml/2006/main" xmlns:r="http://schemas.openxmlformats.org/officeDocument/2006/relationships" xmlns:p="http://schemas.openxmlformats.org/presentationml/2006/main">
   <p:cSld>
     <p:bg>
       <p:bgPr>
@@ -5699,7 +5499,14 @@
         <p:cNvGrpSpPr/>
         <p:nvPr/>
       </p:nvGrpSpPr>
-      <p:grpSpPr/>
+      <p:grpSpPr>
+        <a:xfrm>
+          <a:off x="0" y="0"/>
+          <a:ext cx="0" cy="0"/>
+          <a:chOff x="0" y="0"/>
+          <a:chExt cx="0" cy="0"/>
+        </a:xfrm>
+      </p:grpSpPr>
       <p:sp>
         <p:nvSpPr>
           <p:cNvPr id="2" name="TextBox 1"/>
@@ -5717,7 +5524,7 @@
           <a:noFill/>
         </p:spPr>
         <p:txBody>
-          <a:bodyPr wrap="square" lIns="0" rIns="0" tIns="0" bIns="0">
+          <a:bodyPr wrap="square" lIns="0" tIns="0" rIns="0" bIns="0">
             <a:spAutoFit/>
           </a:bodyPr>
           <a:lstStyle/>
@@ -5748,7 +5555,7 @@
           <p:nvPr/>
         </p:nvPicPr>
         <p:blipFill>
-          <a:blip r:embed="rId2"/>
+          <a:blip r:embed="rId3"/>
           <a:stretch>
             <a:fillRect/>
           </a:stretch>
@@ -5780,7 +5587,7 @@
           <a:noFill/>
         </p:spPr>
         <p:txBody>
-          <a:bodyPr wrap="square" lIns="0" rIns="0" tIns="0" bIns="0">
+          <a:bodyPr wrap="square" lIns="0" tIns="0" rIns="0" bIns="0">
             <a:spAutoFit/>
           </a:bodyPr>
           <a:lstStyle/>
@@ -5841,7 +5648,7 @@
           <a:noFill/>
         </p:spPr>
         <p:txBody>
-          <a:bodyPr wrap="square" lIns="0" rIns="0" tIns="0" bIns="0">
+          <a:bodyPr wrap="square" lIns="0" tIns="0" rIns="0" bIns="0">
             <a:spAutoFit/>
           </a:bodyPr>
           <a:lstStyle/>
@@ -5880,7 +5687,7 @@
           <a:noFill/>
         </p:spPr>
         <p:txBody>
-          <a:bodyPr wrap="square" lIns="0" rIns="0" tIns="0" bIns="0">
+          <a:bodyPr wrap="square" lIns="0" tIns="0" rIns="0" bIns="0">
             <a:spAutoFit/>
           </a:bodyPr>
           <a:lstStyle/>
@@ -5914,7 +5721,7 @@
 </file>
 
 <file path=ppt/slides/slide5.xml><?xml version="1.0" encoding="utf-8"?>
-<p:sld xmlns:a="http://schemas.openxmlformats.org/drawingml/2006/main" xmlns:p="http://schemas.openxmlformats.org/presentationml/2006/main" xmlns:r="http://schemas.openxmlformats.org/officeDocument/2006/relationships">
+<p:sld xmlns:a="http://schemas.openxmlformats.org/drawingml/2006/main" xmlns:r="http://schemas.openxmlformats.org/officeDocument/2006/relationships" xmlns:p="http://schemas.openxmlformats.org/presentationml/2006/main">
   <p:cSld>
     <p:bg>
       <p:bgPr>
@@ -5930,7 +5737,14 @@
         <p:cNvGrpSpPr/>
         <p:nvPr/>
       </p:nvGrpSpPr>
-      <p:grpSpPr/>
+      <p:grpSpPr>
+        <a:xfrm>
+          <a:off x="0" y="0"/>
+          <a:ext cx="0" cy="0"/>
+          <a:chOff x="0" y="0"/>
+          <a:chExt cx="0" cy="0"/>
+        </a:xfrm>
+      </p:grpSpPr>
       <p:sp>
         <p:nvSpPr>
           <p:cNvPr id="2" name="TextBox 1"/>
@@ -5948,7 +5762,7 @@
           <a:noFill/>
         </p:spPr>
         <p:txBody>
-          <a:bodyPr wrap="square" lIns="0" rIns="0" tIns="0" bIns="0">
+          <a:bodyPr wrap="square" lIns="0" tIns="0" rIns="0" bIns="0">
             <a:spAutoFit/>
           </a:bodyPr>
           <a:lstStyle/>
@@ -5989,10 +5803,34 @@
                 <a:tableStyleId>{5C22544A-7EE6-4342-B048-85BDC9FD1C3A}</a:tableStyleId>
               </a:tblPr>
               <a:tblGrid>
-                <a:gridCol w="3383280"/>
-                <a:gridCol w="1188720"/>
-                <a:gridCol w="1188720"/>
-                <a:gridCol w="1188720"/>
+                <a:gridCol w="3383280">
+                  <a:extLst>
+                    <a:ext uri="{9D8B030D-6E8A-4147-A177-3AD203B41FA5}">
+                      <a16:colId xmlns:a16="http://schemas.microsoft.com/office/drawing/2014/main" val="20000"/>
+                    </a:ext>
+                  </a:extLst>
+                </a:gridCol>
+                <a:gridCol w="1188720">
+                  <a:extLst>
+                    <a:ext uri="{9D8B030D-6E8A-4147-A177-3AD203B41FA5}">
+                      <a16:colId xmlns:a16="http://schemas.microsoft.com/office/drawing/2014/main" val="20001"/>
+                    </a:ext>
+                  </a:extLst>
+                </a:gridCol>
+                <a:gridCol w="1188720">
+                  <a:extLst>
+                    <a:ext uri="{9D8B030D-6E8A-4147-A177-3AD203B41FA5}">
+                      <a16:colId xmlns:a16="http://schemas.microsoft.com/office/drawing/2014/main" val="20002"/>
+                    </a:ext>
+                  </a:extLst>
+                </a:gridCol>
+                <a:gridCol w="1188720">
+                  <a:extLst>
+                    <a:ext uri="{9D8B030D-6E8A-4147-A177-3AD203B41FA5}">
+                      <a16:colId xmlns:a16="http://schemas.microsoft.com/office/drawing/2014/main" val="20003"/>
+                    </a:ext>
+                  </a:extLst>
+                </a:gridCol>
               </a:tblGrid>
               <a:tr h="457200">
                 <a:tc>
@@ -6087,6 +5925,11 @@
                     </a:solidFill>
                   </a:tcPr>
                 </a:tc>
+                <a:extLst>
+                  <a:ext uri="{0D108BD9-81ED-4DB2-BD59-A6C34878D82A}">
+                    <a16:rowId xmlns:a16="http://schemas.microsoft.com/office/drawing/2014/main" val="10000"/>
+                  </a:ext>
+                </a:extLst>
               </a:tr>
               <a:tr h="457200">
                 <a:tc>
@@ -6181,6 +6024,11 @@
                     </a:solidFill>
                   </a:tcPr>
                 </a:tc>
+                <a:extLst>
+                  <a:ext uri="{0D108BD9-81ED-4DB2-BD59-A6C34878D82A}">
+                    <a16:rowId xmlns:a16="http://schemas.microsoft.com/office/drawing/2014/main" val="10001"/>
+                  </a:ext>
+                </a:extLst>
               </a:tr>
               <a:tr h="457200">
                 <a:tc>
@@ -6275,6 +6123,11 @@
                     </a:solidFill>
                   </a:tcPr>
                 </a:tc>
+                <a:extLst>
+                  <a:ext uri="{0D108BD9-81ED-4DB2-BD59-A6C34878D82A}">
+                    <a16:rowId xmlns:a16="http://schemas.microsoft.com/office/drawing/2014/main" val="10002"/>
+                  </a:ext>
+                </a:extLst>
               </a:tr>
               <a:tr h="457200">
                 <a:tc>
@@ -6369,6 +6222,11 @@
                     </a:solidFill>
                   </a:tcPr>
                 </a:tc>
+                <a:extLst>
+                  <a:ext uri="{0D108BD9-81ED-4DB2-BD59-A6C34878D82A}">
+                    <a16:rowId xmlns:a16="http://schemas.microsoft.com/office/drawing/2014/main" val="10003"/>
+                  </a:ext>
+                </a:extLst>
               </a:tr>
               <a:tr h="457200">
                 <a:tc>
@@ -6463,6 +6321,11 @@
                     </a:solidFill>
                   </a:tcPr>
                 </a:tc>
+                <a:extLst>
+                  <a:ext uri="{0D108BD9-81ED-4DB2-BD59-A6C34878D82A}">
+                    <a16:rowId xmlns:a16="http://schemas.microsoft.com/office/drawing/2014/main" val="10004"/>
+                  </a:ext>
+                </a:extLst>
               </a:tr>
               <a:tr h="457200">
                 <a:tc>
@@ -6557,6 +6420,11 @@
                     </a:solidFill>
                   </a:tcPr>
                 </a:tc>
+                <a:extLst>
+                  <a:ext uri="{0D108BD9-81ED-4DB2-BD59-A6C34878D82A}">
+                    <a16:rowId xmlns:a16="http://schemas.microsoft.com/office/drawing/2014/main" val="10005"/>
+                  </a:ext>
+                </a:extLst>
               </a:tr>
             </a:tbl>
           </a:graphicData>
@@ -6579,7 +6447,7 @@
           <a:noFill/>
         </p:spPr>
         <p:txBody>
-          <a:bodyPr wrap="square" lIns="0" rIns="0" tIns="0" bIns="0">
+          <a:bodyPr wrap="square" lIns="0" tIns="0" rIns="0" bIns="0">
             <a:spAutoFit/>
           </a:bodyPr>
           <a:lstStyle/>
@@ -6618,7 +6486,7 @@
           <a:noFill/>
         </p:spPr>
         <p:txBody>
-          <a:bodyPr wrap="square" lIns="0" rIns="0" tIns="0" bIns="0">
+          <a:bodyPr wrap="square" lIns="0" tIns="0" rIns="0" bIns="0">
             <a:spAutoFit/>
           </a:bodyPr>
           <a:lstStyle/>
@@ -6657,7 +6525,7 @@
           <a:noFill/>
         </p:spPr>
         <p:txBody>
-          <a:bodyPr wrap="square" lIns="0" rIns="0" tIns="0" bIns="0">
+          <a:bodyPr wrap="square" lIns="0" tIns="0" rIns="0" bIns="0">
             <a:spAutoFit/>
           </a:bodyPr>
           <a:lstStyle/>
@@ -6699,7 +6567,7 @@
           <a:noFill/>
         </p:spPr>
         <p:txBody>
-          <a:bodyPr wrap="square" lIns="0" rIns="0" tIns="0" bIns="0">
+          <a:bodyPr wrap="square" lIns="0" tIns="0" rIns="0" bIns="0">
             <a:spAutoFit/>
           </a:bodyPr>
           <a:lstStyle/>
@@ -6738,7 +6606,7 @@
           <a:noFill/>
         </p:spPr>
         <p:txBody>
-          <a:bodyPr wrap="square" lIns="0" rIns="0" tIns="0" bIns="0">
+          <a:bodyPr wrap="square" lIns="0" tIns="0" rIns="0" bIns="0">
             <a:spAutoFit/>
           </a:bodyPr>
           <a:lstStyle/>
@@ -6780,7 +6648,7 @@
           <a:noFill/>
         </p:spPr>
         <p:txBody>
-          <a:bodyPr wrap="square" lIns="0" rIns="0" tIns="0" bIns="0">
+          <a:bodyPr wrap="square" lIns="0" tIns="0" rIns="0" bIns="0">
             <a:spAutoFit/>
           </a:bodyPr>
           <a:lstStyle/>
@@ -6814,7 +6682,7 @@
 </file>
 
 <file path=ppt/slides/slide6.xml><?xml version="1.0" encoding="utf-8"?>
-<p:sld xmlns:a="http://schemas.openxmlformats.org/drawingml/2006/main" xmlns:p="http://schemas.openxmlformats.org/presentationml/2006/main" xmlns:r="http://schemas.openxmlformats.org/officeDocument/2006/relationships">
+<p:sld xmlns:a="http://schemas.openxmlformats.org/drawingml/2006/main" xmlns:r="http://schemas.openxmlformats.org/officeDocument/2006/relationships" xmlns:p="http://schemas.openxmlformats.org/presentationml/2006/main">
   <p:cSld>
     <p:bg>
       <p:bgPr>
@@ -6830,7 +6698,14 @@
         <p:cNvGrpSpPr/>
         <p:nvPr/>
       </p:nvGrpSpPr>
-      <p:grpSpPr/>
+      <p:grpSpPr>
+        <a:xfrm>
+          <a:off x="0" y="0"/>
+          <a:ext cx="0" cy="0"/>
+          <a:chOff x="0" y="0"/>
+          <a:chExt cx="0" cy="0"/>
+        </a:xfrm>
+      </p:grpSpPr>
       <p:sp>
         <p:nvSpPr>
           <p:cNvPr id="2" name="TextBox 1"/>
@@ -6848,7 +6723,7 @@
           <a:noFill/>
         </p:spPr>
         <p:txBody>
-          <a:bodyPr wrap="square" lIns="0" rIns="0" tIns="0" bIns="0">
+          <a:bodyPr wrap="square" lIns="0" tIns="0" rIns="0" bIns="0">
             <a:spAutoFit/>
           </a:bodyPr>
           <a:lstStyle/>
@@ -6879,7 +6754,7 @@
           <p:nvPr/>
         </p:nvPicPr>
         <p:blipFill>
-          <a:blip r:embed="rId2"/>
+          <a:blip r:embed="rId3"/>
           <a:stretch>
             <a:fillRect/>
           </a:stretch>
@@ -6911,7 +6786,7 @@
           <a:noFill/>
         </p:spPr>
         <p:txBody>
-          <a:bodyPr wrap="square" lIns="0" rIns="0" tIns="0" bIns="0">
+          <a:bodyPr wrap="square" lIns="0" tIns="0" rIns="0" bIns="0">
             <a:spAutoFit/>
           </a:bodyPr>
           <a:lstStyle/>
@@ -6972,7 +6847,7 @@
           <a:noFill/>
         </p:spPr>
         <p:txBody>
-          <a:bodyPr wrap="square" lIns="0" rIns="0" tIns="0" bIns="0">
+          <a:bodyPr wrap="square" lIns="0" tIns="0" rIns="0" bIns="0">
             <a:spAutoFit/>
           </a:bodyPr>
           <a:lstStyle/>
@@ -7011,7 +6886,7 @@
           <a:noFill/>
         </p:spPr>
         <p:txBody>
-          <a:bodyPr wrap="square" lIns="0" rIns="0" tIns="0" bIns="0">
+          <a:bodyPr wrap="square" lIns="0" tIns="0" rIns="0" bIns="0">
             <a:spAutoFit/>
           </a:bodyPr>
           <a:lstStyle/>
@@ -7053,7 +6928,7 @@
           <a:noFill/>
         </p:spPr>
         <p:txBody>
-          <a:bodyPr wrap="square" lIns="0" rIns="0" tIns="0" bIns="0">
+          <a:bodyPr wrap="square" lIns="0" tIns="0" rIns="0" bIns="0">
             <a:spAutoFit/>
           </a:bodyPr>
           <a:lstStyle/>
@@ -7092,7 +6967,7 @@
           <a:noFill/>
         </p:spPr>
         <p:txBody>
-          <a:bodyPr wrap="square" lIns="0" rIns="0" tIns="0" bIns="0">
+          <a:bodyPr wrap="square" lIns="0" tIns="0" rIns="0" bIns="0">
             <a:spAutoFit/>
           </a:bodyPr>
           <a:lstStyle/>
@@ -7126,7 +7001,7 @@
 </file>
 
 <file path=ppt/slides/slide7.xml><?xml version="1.0" encoding="utf-8"?>
-<p:sld xmlns:a="http://schemas.openxmlformats.org/drawingml/2006/main" xmlns:p="http://schemas.openxmlformats.org/presentationml/2006/main" xmlns:r="http://schemas.openxmlformats.org/officeDocument/2006/relationships">
+<p:sld xmlns:a="http://schemas.openxmlformats.org/drawingml/2006/main" xmlns:r="http://schemas.openxmlformats.org/officeDocument/2006/relationships" xmlns:p="http://schemas.openxmlformats.org/presentationml/2006/main">
   <p:cSld>
     <p:bg>
       <p:bgPr>
@@ -7142,7 +7017,14 @@
         <p:cNvGrpSpPr/>
         <p:nvPr/>
       </p:nvGrpSpPr>
-      <p:grpSpPr/>
+      <p:grpSpPr>
+        <a:xfrm>
+          <a:off x="0" y="0"/>
+          <a:ext cx="0" cy="0"/>
+          <a:chOff x="0" y="0"/>
+          <a:chExt cx="0" cy="0"/>
+        </a:xfrm>
+      </p:grpSpPr>
       <p:sp>
         <p:nvSpPr>
           <p:cNvPr id="2" name="TextBox 1"/>
@@ -7160,7 +7042,7 @@
           <a:noFill/>
         </p:spPr>
         <p:txBody>
-          <a:bodyPr wrap="square" lIns="0" rIns="0" tIns="0" bIns="0">
+          <a:bodyPr wrap="square" lIns="0" tIns="0" rIns="0" bIns="0">
             <a:spAutoFit/>
           </a:bodyPr>
           <a:lstStyle/>
@@ -7199,7 +7081,7 @@
           <a:noFill/>
         </p:spPr>
         <p:txBody>
-          <a:bodyPr wrap="square" lIns="0" rIns="0" tIns="0" bIns="0">
+          <a:bodyPr wrap="square" lIns="0" tIns="0" rIns="0" bIns="0">
             <a:spAutoFit/>
           </a:bodyPr>
           <a:lstStyle/>
@@ -7238,7 +7120,7 @@
           <a:noFill/>
         </p:spPr>
         <p:txBody>
-          <a:bodyPr wrap="square" lIns="0" rIns="0" tIns="0" bIns="0">
+          <a:bodyPr wrap="square" lIns="0" tIns="0" rIns="0" bIns="0">
             <a:spAutoFit/>
           </a:bodyPr>
           <a:lstStyle/>
@@ -7277,7 +7159,7 @@
           <a:noFill/>
         </p:spPr>
         <p:txBody>
-          <a:bodyPr wrap="square" lIns="0" rIns="0" tIns="0" bIns="0">
+          <a:bodyPr wrap="square" lIns="0" tIns="0" rIns="0" bIns="0">
             <a:spAutoFit/>
           </a:bodyPr>
           <a:lstStyle/>
@@ -7316,7 +7198,7 @@
           <a:noFill/>
         </p:spPr>
         <p:txBody>
-          <a:bodyPr wrap="square" lIns="0" rIns="0" tIns="0" bIns="0">
+          <a:bodyPr wrap="square" lIns="0" tIns="0" rIns="0" bIns="0">
             <a:spAutoFit/>
           </a:bodyPr>
           <a:lstStyle/>
@@ -7358,7 +7240,7 @@
           <a:noFill/>
         </p:spPr>
         <p:txBody>
-          <a:bodyPr wrap="square" lIns="0" rIns="0" tIns="0" bIns="0">
+          <a:bodyPr wrap="square" lIns="0" tIns="0" rIns="0" bIns="0">
             <a:spAutoFit/>
           </a:bodyPr>
           <a:lstStyle/>
@@ -7397,7 +7279,7 @@
           <a:noFill/>
         </p:spPr>
         <p:txBody>
-          <a:bodyPr wrap="square" lIns="0" rIns="0" tIns="0" bIns="0">
+          <a:bodyPr wrap="square" lIns="0" tIns="0" rIns="0" bIns="0">
             <a:spAutoFit/>
           </a:bodyPr>
           <a:lstStyle/>
@@ -7436,7 +7318,7 @@
           <a:noFill/>
         </p:spPr>
         <p:txBody>
-          <a:bodyPr wrap="square" lIns="0" rIns="0" tIns="0" bIns="0">
+          <a:bodyPr wrap="square" lIns="0" tIns="0" rIns="0" bIns="0">
             <a:spAutoFit/>
           </a:bodyPr>
           <a:lstStyle/>
@@ -7504,6 +7386,7 @@
           <a:lstStyle/>
           <a:p>
             <a:pPr algn="ctr"/>
+            <a:endParaRPr/>
           </a:p>
         </p:txBody>
       </p:sp>
@@ -7524,7 +7407,7 @@
           <a:noFill/>
         </p:spPr>
         <p:txBody>
-          <a:bodyPr wrap="square" lIns="0" rIns="0" tIns="0" bIns="0">
+          <a:bodyPr wrap="square" lIns="0" tIns="0" rIns="0" bIns="0">
             <a:spAutoFit/>
           </a:bodyPr>
           <a:lstStyle/>
@@ -7563,7 +7446,7 @@
           <a:noFill/>
         </p:spPr>
         <p:txBody>
-          <a:bodyPr wrap="square" lIns="0" rIns="0" tIns="0" bIns="0">
+          <a:bodyPr wrap="square" lIns="0" tIns="0" rIns="0" bIns="0">
             <a:spAutoFit/>
           </a:bodyPr>
           <a:lstStyle/>
@@ -7635,7 +7518,7 @@
 </file>
 
 <file path=ppt/slides/slide8.xml><?xml version="1.0" encoding="utf-8"?>
-<p:sld xmlns:a="http://schemas.openxmlformats.org/drawingml/2006/main" xmlns:p="http://schemas.openxmlformats.org/presentationml/2006/main" xmlns:r="http://schemas.openxmlformats.org/officeDocument/2006/relationships">
+<p:sld xmlns:a="http://schemas.openxmlformats.org/drawingml/2006/main" xmlns:r="http://schemas.openxmlformats.org/officeDocument/2006/relationships" xmlns:p="http://schemas.openxmlformats.org/presentationml/2006/main">
   <p:cSld>
     <p:bg>
       <p:bgPr>
@@ -7651,7 +7534,14 @@
         <p:cNvGrpSpPr/>
         <p:nvPr/>
       </p:nvGrpSpPr>
-      <p:grpSpPr/>
+      <p:grpSpPr>
+        <a:xfrm>
+          <a:off x="0" y="0"/>
+          <a:ext cx="0" cy="0"/>
+          <a:chOff x="0" y="0"/>
+          <a:chExt cx="0" cy="0"/>
+        </a:xfrm>
+      </p:grpSpPr>
       <p:sp>
         <p:nvSpPr>
           <p:cNvPr id="2" name="TextBox 1"/>
@@ -7669,7 +7559,7 @@
           <a:noFill/>
         </p:spPr>
         <p:txBody>
-          <a:bodyPr wrap="square" lIns="0" rIns="0" tIns="0" bIns="0">
+          <a:bodyPr wrap="square" lIns="0" tIns="0" rIns="0" bIns="0">
             <a:spAutoFit/>
           </a:bodyPr>
           <a:lstStyle/>
@@ -7708,7 +7598,7 @@
           <a:noFill/>
         </p:spPr>
         <p:txBody>
-          <a:bodyPr wrap="square" lIns="0" rIns="0" tIns="0" bIns="0">
+          <a:bodyPr wrap="square" lIns="0" tIns="0" rIns="0" bIns="0">
             <a:spAutoFit/>
           </a:bodyPr>
           <a:lstStyle/>
@@ -7747,7 +7637,7 @@
           <a:noFill/>
         </p:spPr>
         <p:txBody>
-          <a:bodyPr wrap="square" lIns="0" rIns="0" tIns="0" bIns="0">
+          <a:bodyPr wrap="square" lIns="0" tIns="0" rIns="0" bIns="0">
             <a:spAutoFit/>
           </a:bodyPr>
           <a:lstStyle/>
@@ -7786,7 +7676,7 @@
           <a:noFill/>
         </p:spPr>
         <p:txBody>
-          <a:bodyPr wrap="square" lIns="0" rIns="0" tIns="0" bIns="0">
+          <a:bodyPr wrap="square" lIns="0" tIns="0" rIns="0" bIns="0">
             <a:spAutoFit/>
           </a:bodyPr>
           <a:lstStyle/>
@@ -7825,7 +7715,7 @@
           <a:noFill/>
         </p:spPr>
         <p:txBody>
-          <a:bodyPr wrap="square" lIns="0" rIns="0" tIns="0" bIns="0">
+          <a:bodyPr wrap="square" lIns="0" tIns="0" rIns="0" bIns="0">
             <a:spAutoFit/>
           </a:bodyPr>
           <a:lstStyle/>
@@ -7867,7 +7757,7 @@
           <a:noFill/>
         </p:spPr>
         <p:txBody>
-          <a:bodyPr wrap="square" lIns="0" rIns="0" tIns="0" bIns="0">
+          <a:bodyPr wrap="square" lIns="0" tIns="0" rIns="0" bIns="0">
             <a:spAutoFit/>
           </a:bodyPr>
           <a:lstStyle/>
@@ -7906,7 +7796,7 @@
           <a:noFill/>
         </p:spPr>
         <p:txBody>
-          <a:bodyPr wrap="square" lIns="0" rIns="0" tIns="0" bIns="0">
+          <a:bodyPr wrap="square" lIns="0" tIns="0" rIns="0" bIns="0">
             <a:spAutoFit/>
           </a:bodyPr>
           <a:lstStyle/>
@@ -7945,7 +7835,7 @@
           <a:noFill/>
         </p:spPr>
         <p:txBody>
-          <a:bodyPr wrap="square" lIns="0" rIns="0" tIns="0" bIns="0">
+          <a:bodyPr wrap="square" lIns="0" tIns="0" rIns="0" bIns="0">
             <a:spAutoFit/>
           </a:bodyPr>
           <a:lstStyle/>
@@ -8013,6 +7903,7 @@
           <a:lstStyle/>
           <a:p>
             <a:pPr algn="ctr"/>
+            <a:endParaRPr/>
           </a:p>
         </p:txBody>
       </p:sp>
@@ -8033,7 +7924,7 @@
           <a:noFill/>
         </p:spPr>
         <p:txBody>
-          <a:bodyPr wrap="square" lIns="0" rIns="0" tIns="0" bIns="0">
+          <a:bodyPr wrap="square" lIns="0" tIns="0" rIns="0" bIns="0">
             <a:spAutoFit/>
           </a:bodyPr>
           <a:lstStyle/>
@@ -8072,7 +7963,7 @@
           <a:noFill/>
         </p:spPr>
         <p:txBody>
-          <a:bodyPr wrap="square" lIns="0" rIns="0" tIns="0" bIns="0">
+          <a:bodyPr wrap="square" lIns="0" tIns="0" rIns="0" bIns="0">
             <a:spAutoFit/>
           </a:bodyPr>
           <a:lstStyle/>
@@ -8144,7 +8035,7 @@
 </file>
 
 <file path=ppt/slides/slide9.xml><?xml version="1.0" encoding="utf-8"?>
-<p:sld xmlns:a="http://schemas.openxmlformats.org/drawingml/2006/main" xmlns:p="http://schemas.openxmlformats.org/presentationml/2006/main" xmlns:r="http://schemas.openxmlformats.org/officeDocument/2006/relationships">
+<p:sld xmlns:a="http://schemas.openxmlformats.org/drawingml/2006/main" xmlns:r="http://schemas.openxmlformats.org/officeDocument/2006/relationships" xmlns:p="http://schemas.openxmlformats.org/presentationml/2006/main">
   <p:cSld>
     <p:bg>
       <p:bgPr>
@@ -8160,7 +8051,14 @@
         <p:cNvGrpSpPr/>
         <p:nvPr/>
       </p:nvGrpSpPr>
-      <p:grpSpPr/>
+      <p:grpSpPr>
+        <a:xfrm>
+          <a:off x="0" y="0"/>
+          <a:ext cx="0" cy="0"/>
+          <a:chOff x="0" y="0"/>
+          <a:chExt cx="0" cy="0"/>
+        </a:xfrm>
+      </p:grpSpPr>
       <p:sp>
         <p:nvSpPr>
           <p:cNvPr id="2" name="TextBox 1"/>
@@ -8178,7 +8076,7 @@
           <a:noFill/>
         </p:spPr>
         <p:txBody>
-          <a:bodyPr wrap="square" lIns="0" rIns="0" tIns="0" bIns="0">
+          <a:bodyPr wrap="square" lIns="0" tIns="0" rIns="0" bIns="0">
             <a:spAutoFit/>
           </a:bodyPr>
           <a:lstStyle/>
@@ -8217,7 +8115,7 @@
           <a:noFill/>
         </p:spPr>
         <p:txBody>
-          <a:bodyPr wrap="square" lIns="0" rIns="0" tIns="0" bIns="0">
+          <a:bodyPr wrap="square" lIns="0" tIns="0" rIns="0" bIns="0">
             <a:spAutoFit/>
           </a:bodyPr>
           <a:lstStyle/>
@@ -8304,6 +8202,7 @@
           <a:lstStyle/>
           <a:p>
             <a:pPr algn="ctr"/>
+            <a:endParaRPr/>
           </a:p>
         </p:txBody>
       </p:sp>
@@ -8324,7 +8223,7 @@
           <a:noFill/>
         </p:spPr>
         <p:txBody>
-          <a:bodyPr wrap="square" lIns="0" rIns="0" tIns="0" bIns="0">
+          <a:bodyPr wrap="square" lIns="0" tIns="0" rIns="0" bIns="0">
             <a:spAutoFit/>
           </a:bodyPr>
           <a:lstStyle/>
@@ -8385,7 +8284,7 @@
           <a:noFill/>
         </p:spPr>
         <p:txBody>
-          <a:bodyPr wrap="square" lIns="0" rIns="0" tIns="0" bIns="0">
+          <a:bodyPr wrap="square" lIns="0" tIns="0" rIns="0" bIns="0">
             <a:spAutoFit/>
           </a:bodyPr>
           <a:lstStyle/>
@@ -8746,44 +8645,44 @@
         <a:sysClr val="window" lastClr="FFFFFF"/>
       </a:lt1>
       <a:dk2>
-        <a:srgbClr val="1F497D"/>
+        <a:srgbClr val="0E2841"/>
       </a:dk2>
       <a:lt2>
-        <a:srgbClr val="EEECE1"/>
+        <a:srgbClr val="E8E8E8"/>
       </a:lt2>
       <a:accent1>
-        <a:srgbClr val="4F81BD"/>
+        <a:srgbClr val="156082"/>
       </a:accent1>
       <a:accent2>
-        <a:srgbClr val="C0504D"/>
+        <a:srgbClr val="E97132"/>
       </a:accent2>
       <a:accent3>
-        <a:srgbClr val="9BBB59"/>
+        <a:srgbClr val="196B24"/>
       </a:accent3>
       <a:accent4>
-        <a:srgbClr val="8064A2"/>
+        <a:srgbClr val="0F9ED5"/>
       </a:accent4>
       <a:accent5>
-        <a:srgbClr val="4BACC6"/>
+        <a:srgbClr val="A02B93"/>
       </a:accent5>
       <a:accent6>
-        <a:srgbClr val="F79646"/>
+        <a:srgbClr val="4EA72E"/>
       </a:accent6>
       <a:hlink>
-        <a:srgbClr val="0000FF"/>
+        <a:srgbClr val="467886"/>
       </a:hlink>
       <a:folHlink>
-        <a:srgbClr val="800080"/>
+        <a:srgbClr val="96607D"/>
       </a:folHlink>
     </a:clrScheme>
     <a:fontScheme name="Office">
       <a:majorFont>
-        <a:latin typeface="Calibri"/>
+        <a:latin typeface="Aptos Display" panose="02110004020202020204"/>
         <a:ea typeface=""/>
         <a:cs typeface=""/>
-        <a:font script="Jpan" typeface="ＭＳ Ｐゴシック"/>
+        <a:font script="Jpan" typeface="游ゴシック Light"/>
         <a:font script="Hang" typeface="맑은 고딕"/>
-        <a:font script="Hans" typeface="宋体"/>
+        <a:font script="Hans" typeface="等线 Light"/>
         <a:font script="Hant" typeface="新細明體"/>
         <a:font script="Arab" typeface="Times New Roman"/>
         <a:font script="Hebr" typeface="Times New Roman"/>
@@ -8811,14 +8710,31 @@
         <a:font script="Viet" typeface="Times New Roman"/>
         <a:font script="Uigh" typeface="Microsoft Uighur"/>
         <a:font script="Geor" typeface="Sylfaen"/>
+        <a:font script="Armn" typeface="Arial"/>
+        <a:font script="Bugi" typeface="Leelawadee UI"/>
+        <a:font script="Bopo" typeface="Microsoft JhengHei"/>
+        <a:font script="Java" typeface="Javanese Text"/>
+        <a:font script="Lisu" typeface="Segoe UI"/>
+        <a:font script="Mymr" typeface="Myanmar Text"/>
+        <a:font script="Nkoo" typeface="Ebrima"/>
+        <a:font script="Olck" typeface="Nirmala UI"/>
+        <a:font script="Osma" typeface="Ebrima"/>
+        <a:font script="Phag" typeface="Phagspa"/>
+        <a:font script="Syrn" typeface="Estrangelo Edessa"/>
+        <a:font script="Syrj" typeface="Estrangelo Edessa"/>
+        <a:font script="Syre" typeface="Estrangelo Edessa"/>
+        <a:font script="Sora" typeface="Nirmala UI"/>
+        <a:font script="Tale" typeface="Microsoft Tai Le"/>
+        <a:font script="Talu" typeface="Microsoft New Tai Lue"/>
+        <a:font script="Tfng" typeface="Ebrima"/>
       </a:majorFont>
       <a:minorFont>
-        <a:latin typeface="Calibri"/>
+        <a:latin typeface="Aptos" panose="02110004020202020204"/>
         <a:ea typeface=""/>
         <a:cs typeface=""/>
-        <a:font script="Jpan" typeface="ＭＳ Ｐゴシック"/>
+        <a:font script="Jpan" typeface="游ゴシック"/>
         <a:font script="Hang" typeface="맑은 고딕"/>
-        <a:font script="Hans" typeface="宋体"/>
+        <a:font script="Hans" typeface="等线"/>
         <a:font script="Hant" typeface="新細明體"/>
         <a:font script="Arab" typeface="Arial"/>
         <a:font script="Hebr" typeface="Arial"/>
@@ -8846,6 +8762,23 @@
         <a:font script="Viet" typeface="Arial"/>
         <a:font script="Uigh" typeface="Microsoft Uighur"/>
         <a:font script="Geor" typeface="Sylfaen"/>
+        <a:font script="Armn" typeface="Arial"/>
+        <a:font script="Bugi" typeface="Leelawadee UI"/>
+        <a:font script="Bopo" typeface="Microsoft JhengHei"/>
+        <a:font script="Java" typeface="Javanese Text"/>
+        <a:font script="Lisu" typeface="Segoe UI"/>
+        <a:font script="Mymr" typeface="Myanmar Text"/>
+        <a:font script="Nkoo" typeface="Ebrima"/>
+        <a:font script="Olck" typeface="Nirmala UI"/>
+        <a:font script="Osma" typeface="Ebrima"/>
+        <a:font script="Phag" typeface="Phagspa"/>
+        <a:font script="Syrn" typeface="Estrangelo Edessa"/>
+        <a:font script="Syrj" typeface="Estrangelo Edessa"/>
+        <a:font script="Syre" typeface="Estrangelo Edessa"/>
+        <a:font script="Sora" typeface="Nirmala UI"/>
+        <a:font script="Tale" typeface="Microsoft Tai Le"/>
+        <a:font script="Talu" typeface="Microsoft New Tai Lue"/>
+        <a:font script="Tfng" typeface="Ebrima"/>
       </a:minorFont>
     </a:fontScheme>
     <a:fmtScheme name="Office">
@@ -8857,180 +8790,136 @@
           <a:gsLst>
             <a:gs pos="0">
               <a:schemeClr val="phClr">
-                <a:tint val="50000"/>
-                <a:satMod val="300000"/>
+                <a:lumMod val="110000"/>
+                <a:satMod val="105000"/>
+                <a:tint val="67000"/>
               </a:schemeClr>
             </a:gs>
-            <a:gs pos="35000">
+            <a:gs pos="50000">
               <a:schemeClr val="phClr">
-                <a:tint val="37000"/>
-                <a:satMod val="300000"/>
+                <a:lumMod val="105000"/>
+                <a:satMod val="103000"/>
+                <a:tint val="73000"/>
               </a:schemeClr>
             </a:gs>
             <a:gs pos="100000">
               <a:schemeClr val="phClr">
-                <a:tint val="15000"/>
-                <a:satMod val="350000"/>
+                <a:lumMod val="105000"/>
+                <a:satMod val="109000"/>
+                <a:tint val="81000"/>
               </a:schemeClr>
             </a:gs>
           </a:gsLst>
-          <a:lin ang="16200000" scaled="1"/>
+          <a:lin ang="5400000" scaled="0"/>
         </a:gradFill>
         <a:gradFill rotWithShape="1">
           <a:gsLst>
             <a:gs pos="0">
               <a:schemeClr val="phClr">
-                <a:tint val="100000"/>
+                <a:satMod val="103000"/>
+                <a:lumMod val="102000"/>
+                <a:tint val="94000"/>
+              </a:schemeClr>
+            </a:gs>
+            <a:gs pos="50000">
+              <a:schemeClr val="phClr">
+                <a:satMod val="110000"/>
+                <a:lumMod val="100000"/>
                 <a:shade val="100000"/>
-                <a:satMod val="130000"/>
               </a:schemeClr>
             </a:gs>
             <a:gs pos="100000">
               <a:schemeClr val="phClr">
-                <a:tint val="50000"/>
-                <a:shade val="100000"/>
-                <a:satMod val="350000"/>
+                <a:lumMod val="99000"/>
+                <a:satMod val="120000"/>
+                <a:shade val="78000"/>
               </a:schemeClr>
             </a:gs>
           </a:gsLst>
-          <a:lin ang="16200000" scaled="0"/>
+          <a:lin ang="5400000" scaled="0"/>
         </a:gradFill>
       </a:fillStyleLst>
       <a:lnStyleLst>
-        <a:ln w="9525" cap="flat" cmpd="sng" algn="ctr">
+        <a:ln w="12700" cap="flat" cmpd="sng" algn="ctr">
           <a:solidFill>
-            <a:schemeClr val="phClr">
-              <a:shade val="95000"/>
-              <a:satMod val="105000"/>
-            </a:schemeClr>
+            <a:schemeClr val="phClr"/>
           </a:solidFill>
           <a:prstDash val="solid"/>
+          <a:miter lim="800000"/>
+        </a:ln>
+        <a:ln w="19050" cap="flat" cmpd="sng" algn="ctr">
+          <a:solidFill>
+            <a:schemeClr val="phClr"/>
+          </a:solidFill>
+          <a:prstDash val="solid"/>
+          <a:miter lim="800000"/>
         </a:ln>
         <a:ln w="25400" cap="flat" cmpd="sng" algn="ctr">
           <a:solidFill>
             <a:schemeClr val="phClr"/>
           </a:solidFill>
           <a:prstDash val="solid"/>
-        </a:ln>
-        <a:ln w="38100" cap="flat" cmpd="sng" algn="ctr">
-          <a:solidFill>
-            <a:schemeClr val="phClr"/>
-          </a:solidFill>
-          <a:prstDash val="solid"/>
+          <a:miter lim="800000"/>
         </a:ln>
       </a:lnStyleLst>
       <a:effectStyleLst>
         <a:effectStyle>
+          <a:effectLst/>
+        </a:effectStyle>
+        <a:effectStyle>
+          <a:effectLst/>
+        </a:effectStyle>
+        <a:effectStyle>
           <a:effectLst>
-            <a:outerShdw blurRad="40000" dist="20000" dir="5400000" rotWithShape="0">
+            <a:outerShdw blurRad="57150" dist="19050" dir="5400000" algn="ctr" rotWithShape="0">
               <a:srgbClr val="000000">
-                <a:alpha val="38000"/>
+                <a:alpha val="63000"/>
               </a:srgbClr>
             </a:outerShdw>
           </a:effectLst>
-        </a:effectStyle>
-        <a:effectStyle>
-          <a:effectLst>
-            <a:outerShdw blurRad="40000" dist="23000" dir="5400000" rotWithShape="0">
-              <a:srgbClr val="000000">
-                <a:alpha val="35000"/>
-              </a:srgbClr>
-            </a:outerShdw>
-          </a:effectLst>
-        </a:effectStyle>
-        <a:effectStyle>
-          <a:effectLst>
-            <a:outerShdw blurRad="40000" dist="23000" dir="5400000" rotWithShape="0">
-              <a:srgbClr val="000000">
-                <a:alpha val="35000"/>
-              </a:srgbClr>
-            </a:outerShdw>
-          </a:effectLst>
-          <a:scene3d>
-            <a:camera prst="orthographicFront">
-              <a:rot lat="0" lon="0" rev="0"/>
-            </a:camera>
-            <a:lightRig rig="threePt" dir="t">
-              <a:rot lat="0" lon="0" rev="1200000"/>
-            </a:lightRig>
-          </a:scene3d>
-          <a:sp3d>
-            <a:bevelT w="63500" h="25400"/>
-          </a:sp3d>
         </a:effectStyle>
       </a:effectStyleLst>
       <a:bgFillStyleLst>
         <a:solidFill>
           <a:schemeClr val="phClr"/>
         </a:solidFill>
+        <a:solidFill>
+          <a:schemeClr val="phClr">
+            <a:tint val="95000"/>
+            <a:satMod val="170000"/>
+          </a:schemeClr>
+        </a:solidFill>
         <a:gradFill rotWithShape="1">
           <a:gsLst>
             <a:gs pos="0">
               <a:schemeClr val="phClr">
-                <a:tint val="40000"/>
-                <a:satMod val="350000"/>
+                <a:tint val="93000"/>
+                <a:satMod val="150000"/>
+                <a:shade val="98000"/>
+                <a:lumMod val="102000"/>
               </a:schemeClr>
             </a:gs>
-            <a:gs pos="40000">
+            <a:gs pos="50000">
               <a:schemeClr val="phClr">
-                <a:tint val="45000"/>
-                <a:shade val="99000"/>
-                <a:satMod val="350000"/>
+                <a:tint val="98000"/>
+                <a:satMod val="130000"/>
+                <a:shade val="90000"/>
+                <a:lumMod val="103000"/>
               </a:schemeClr>
             </a:gs>
             <a:gs pos="100000">
               <a:schemeClr val="phClr">
-                <a:shade val="20000"/>
-                <a:satMod val="255000"/>
+                <a:shade val="63000"/>
+                <a:satMod val="120000"/>
               </a:schemeClr>
             </a:gs>
           </a:gsLst>
-          <a:path path="circle">
-            <a:fillToRect l="50000" t="-80000" r="50000" b="180000"/>
-          </a:path>
-        </a:gradFill>
-        <a:gradFill rotWithShape="1">
-          <a:gsLst>
-            <a:gs pos="0">
-              <a:schemeClr val="phClr">
-                <a:tint val="80000"/>
-                <a:satMod val="300000"/>
-              </a:schemeClr>
-            </a:gs>
-            <a:gs pos="100000">
-              <a:schemeClr val="phClr">
-                <a:shade val="30000"/>
-                <a:satMod val="200000"/>
-              </a:schemeClr>
-            </a:gs>
-          </a:gsLst>
-          <a:path path="circle">
-            <a:fillToRect l="50000" t="50000" r="50000" b="50000"/>
-          </a:path>
+          <a:lin ang="5400000" scaled="0"/>
         </a:gradFill>
       </a:bgFillStyleLst>
     </a:fmtScheme>
   </a:themeElements>
   <a:objectDefaults>
-    <a:spDef>
-      <a:spPr/>
-      <a:bodyPr/>
-      <a:lstStyle/>
-      <a:style>
-        <a:lnRef idx="1">
-          <a:schemeClr val="accent1"/>
-        </a:lnRef>
-        <a:fillRef idx="3">
-          <a:schemeClr val="accent1"/>
-        </a:fillRef>
-        <a:effectRef idx="2">
-          <a:schemeClr val="accent1"/>
-        </a:effectRef>
-        <a:fontRef idx="minor">
-          <a:schemeClr val="lt1"/>
-        </a:fontRef>
-      </a:style>
-    </a:spDef>
     <a:lnDef>
       <a:spPr/>
       <a:bodyPr/>
@@ -9052,5 +8941,10 @@
     </a:lnDef>
   </a:objectDefaults>
   <a:extraClrSchemeLst/>
+  <a:extLst>
+    <a:ext uri="{05A4C25C-085E-4340-85A3-A5531E510DB2}">
+      <thm15:themeFamily xmlns:thm15="http://schemas.microsoft.com/office/thememl/2012/main" name="Office Theme" id="{2E142A2C-CD16-42D6-873A-C26D2A0506FA}" vid="{1BDDFF52-6CD6-40A5-AB3C-68EB2F1E4D0A}"/>
+    </a:ext>
+  </a:extLst>
 </a:theme>
 </file>
</xml_diff>

<commit_message>
Point the poster's QR code at the recorded presentation
LivSURF requires the poster's QR to open the video, not the repository. make_qr.py
now takes the URL as an argument so the code that generates the symbol does not have
to be edited to change where it points, and the caption says what it opens.

Verified by decoding the symbol back out of the rendered A1 PDF rather than by
looking at it: it returns the exact share link, and still decodes when the render is
scaled to 30 percent, so there is margin for a phone camera at reading distance.

The repository link is not lost. It is on the final slide of the video, which is what
the QR now opens.

Co-Authored-By: Claude Opus 5 <noreply@anthropic.com>
</commit_message>
<xml_diff>
--- a/video_slides.pptx
+++ b/video_slides.pptx
@@ -4,21 +4,18 @@
   <p:sldMasterIdLst>
     <p:sldMasterId id="2147483648" r:id="rId1"/>
   </p:sldMasterIdLst>
-  <p:notesMasterIdLst>
-    <p:notesMasterId r:id="rId11"/>
-  </p:notesMasterIdLst>
   <p:sldIdLst>
-    <p:sldId id="256" r:id="rId2"/>
-    <p:sldId id="257" r:id="rId3"/>
-    <p:sldId id="258" r:id="rId4"/>
-    <p:sldId id="259" r:id="rId5"/>
-    <p:sldId id="260" r:id="rId6"/>
-    <p:sldId id="261" r:id="rId7"/>
-    <p:sldId id="262" r:id="rId8"/>
-    <p:sldId id="263" r:id="rId9"/>
-    <p:sldId id="264" r:id="rId10"/>
+    <p:sldId id="256" r:id="rId7"/>
+    <p:sldId id="257" r:id="rId9"/>
+    <p:sldId id="258" r:id="rId10"/>
+    <p:sldId id="259" r:id="rId11"/>
+    <p:sldId id="260" r:id="rId12"/>
+    <p:sldId id="261" r:id="rId13"/>
+    <p:sldId id="262" r:id="rId14"/>
+    <p:sldId id="263" r:id="rId15"/>
+    <p:sldId id="264" r:id="rId16"/>
   </p:sldIdLst>
-  <p:sldSz cx="12192000" cy="6858000"/>
+  <p:sldSz cx="12191695" cy="6858000" type="screen4x3"/>
   <p:notesSz cx="6858000" cy="9144000"/>
   <p:defaultTextStyle>
     <a:defPPr>
@@ -115,27 +112,11 @@
       </a:defRPr>
     </a:lvl9pPr>
   </p:defaultTextStyle>
-  <p:extLst>
-    <p:ext uri="{EFAFB233-063F-42B5-8137-9DF3F51BA10A}">
-      <p15:sldGuideLst xmlns:p15="http://schemas.microsoft.com/office/powerpoint/2012/main">
-        <p15:guide id="1" orient="horz" pos="2160">
-          <p15:clr>
-            <a:srgbClr val="A4A3A4"/>
-          </p15:clr>
-        </p15:guide>
-        <p15:guide id="2" pos="2880">
-          <p15:clr>
-            <a:srgbClr val="A4A3A4"/>
-          </p15:clr>
-        </p15:guide>
-      </p15:sldGuideLst>
-    </p:ext>
-  </p:extLst>
 </p:presentation>
 </file>
 
 <file path=ppt/notesMasters/notesMaster1.xml><?xml version="1.0" encoding="utf-8"?>
-<p:notesMaster xmlns:a="http://schemas.openxmlformats.org/drawingml/2006/main" xmlns:r="http://schemas.openxmlformats.org/officeDocument/2006/relationships" xmlns:p="http://schemas.openxmlformats.org/presentationml/2006/main">
+<p:notesMaster xmlns:a="http://schemas.openxmlformats.org/drawingml/2006/main" xmlns:p="http://schemas.openxmlformats.org/presentationml/2006/main" xmlns:r="http://schemas.openxmlformats.org/officeDocument/2006/relationships">
   <p:cSld>
     <p:bg>
       <p:bgRef idx="1001">
@@ -156,16 +137,241 @@
           <a:chExt cx="0" cy="0"/>
         </a:xfrm>
       </p:grpSpPr>
+      <p:sp>
+        <p:nvSpPr>
+          <p:cNvPr id="2" name="Header Placeholder 1"/>
+          <p:cNvSpPr>
+            <a:spLocks noGrp="1"/>
+          </p:cNvSpPr>
+          <p:nvPr>
+            <p:ph type="hdr" sz="quarter"/>
+          </p:nvPr>
+        </p:nvSpPr>
+        <p:spPr>
+          <a:xfrm>
+            <a:off x="0" y="0"/>
+            <a:ext cx="2971800" cy="457200"/>
+          </a:xfrm>
+          <a:prstGeom prst="rect">
+            <a:avLst/>
+          </a:prstGeom>
+        </p:spPr>
+        <p:txBody>
+          <a:bodyPr vert="horz" lIns="91440" tIns="45720" rIns="91440" bIns="45720" rtlCol="0"/>
+          <a:lstStyle>
+            <a:lvl1pPr algn="l">
+              <a:defRPr sz="1200"/>
+            </a:lvl1pPr>
+          </a:lstStyle>
+          <a:p>
+            <a:endParaRPr lang="en-US"/>
+          </a:p>
+        </p:txBody>
+      </p:sp>
+      <p:sp>
+        <p:nvSpPr>
+          <p:cNvPr id="3" name="Date Placeholder 2"/>
+          <p:cNvSpPr>
+            <a:spLocks noGrp="1"/>
+          </p:cNvSpPr>
+          <p:nvPr>
+            <p:ph type="dt" idx="1"/>
+          </p:nvPr>
+        </p:nvSpPr>
+        <p:spPr>
+          <a:xfrm>
+            <a:off x="3884613" y="0"/>
+            <a:ext cx="2971800" cy="457200"/>
+          </a:xfrm>
+          <a:prstGeom prst="rect">
+            <a:avLst/>
+          </a:prstGeom>
+        </p:spPr>
+        <p:txBody>
+          <a:bodyPr vert="horz" lIns="91440" tIns="45720" rIns="91440" bIns="45720" rtlCol="0"/>
+          <a:lstStyle>
+            <a:lvl1pPr algn="r">
+              <a:defRPr sz="1200"/>
+            </a:lvl1pPr>
+          </a:lstStyle>
+          <a:p>
+            <a:fld id="{0F89C1C7-3DCD-1040-A9CF-14679D8B5DDD}" type="datetimeFigureOut">
+              <a:rPr lang="en-US" smtClean="0"/>
+              <a:t>10/17/16</a:t>
+            </a:fld>
+            <a:endParaRPr lang="en-US"/>
+          </a:p>
+        </p:txBody>
+      </p:sp>
+      <p:sp>
+        <p:nvSpPr>
+          <p:cNvPr id="4" name="Slide Image Placeholder 3"/>
+          <p:cNvSpPr>
+            <a:spLocks noGrp="1" noRot="1" noChangeAspect="1"/>
+          </p:cNvSpPr>
+          <p:nvPr>
+            <p:ph type="sldImg" idx="2"/>
+          </p:nvPr>
+        </p:nvSpPr>
+        <p:spPr>
+          <a:xfrm>
+            <a:off x="1143000" y="685800"/>
+            <a:ext cx="4572000" cy="3429000"/>
+          </a:xfrm>
+          <a:prstGeom prst="rect">
+            <a:avLst/>
+          </a:prstGeom>
+          <a:noFill/>
+          <a:ln w="12700">
+            <a:solidFill>
+              <a:prstClr val="black"/>
+            </a:solidFill>
+          </a:ln>
+        </p:spPr>
+        <p:txBody>
+          <a:bodyPr vert="horz" lIns="91440" tIns="45720" rIns="91440" bIns="45720" rtlCol="0" anchor="ctr"/>
+          <a:lstStyle/>
+          <a:p>
+            <a:endParaRPr lang="en-US"/>
+          </a:p>
+        </p:txBody>
+      </p:sp>
+      <p:sp>
+        <p:nvSpPr>
+          <p:cNvPr id="5" name="Notes Placeholder 4"/>
+          <p:cNvSpPr>
+            <a:spLocks noGrp="1"/>
+          </p:cNvSpPr>
+          <p:nvPr>
+            <p:ph type="body" sz="quarter" idx="3"/>
+          </p:nvPr>
+        </p:nvSpPr>
+        <p:spPr>
+          <a:xfrm>
+            <a:off x="685800" y="4343400"/>
+            <a:ext cx="5486400" cy="4114800"/>
+          </a:xfrm>
+          <a:prstGeom prst="rect">
+            <a:avLst/>
+          </a:prstGeom>
+        </p:spPr>
+        <p:txBody>
+          <a:bodyPr vert="horz" lIns="91440" tIns="45720" rIns="91440" bIns="45720" rtlCol="0"/>
+          <a:lstStyle/>
+          <a:p>
+            <a:pPr lvl="0"/>
+            <a:r>
+              <a:rPr lang="en-US" smtClean="0"/>
+              <a:t>Click to edit Master text styles</a:t>
+            </a:r>
+          </a:p>
+          <a:p>
+            <a:pPr lvl="1"/>
+            <a:r>
+              <a:rPr lang="en-US" smtClean="0"/>
+              <a:t>Second level</a:t>
+            </a:r>
+          </a:p>
+          <a:p>
+            <a:pPr lvl="2"/>
+            <a:r>
+              <a:rPr lang="en-US" smtClean="0"/>
+              <a:t>Third level</a:t>
+            </a:r>
+          </a:p>
+          <a:p>
+            <a:pPr lvl="3"/>
+            <a:r>
+              <a:rPr lang="en-US" smtClean="0"/>
+              <a:t>Fourth level</a:t>
+            </a:r>
+          </a:p>
+          <a:p>
+            <a:pPr lvl="4"/>
+            <a:r>
+              <a:rPr lang="en-US" smtClean="0"/>
+              <a:t>Fifth level</a:t>
+            </a:r>
+            <a:endParaRPr lang="en-US"/>
+          </a:p>
+        </p:txBody>
+      </p:sp>
+      <p:sp>
+        <p:nvSpPr>
+          <p:cNvPr id="6" name="Footer Placeholder 5"/>
+          <p:cNvSpPr>
+            <a:spLocks noGrp="1"/>
+          </p:cNvSpPr>
+          <p:nvPr>
+            <p:ph type="ftr" sz="quarter" idx="4"/>
+          </p:nvPr>
+        </p:nvSpPr>
+        <p:spPr>
+          <a:xfrm>
+            <a:off x="0" y="8685213"/>
+            <a:ext cx="2971800" cy="457200"/>
+          </a:xfrm>
+          <a:prstGeom prst="rect">
+            <a:avLst/>
+          </a:prstGeom>
+        </p:spPr>
+        <p:txBody>
+          <a:bodyPr vert="horz" lIns="91440" tIns="45720" rIns="91440" bIns="45720" rtlCol="0" anchor="b"/>
+          <a:lstStyle>
+            <a:lvl1pPr algn="l">
+              <a:defRPr sz="1200"/>
+            </a:lvl1pPr>
+          </a:lstStyle>
+          <a:p>
+            <a:endParaRPr lang="en-US"/>
+          </a:p>
+        </p:txBody>
+      </p:sp>
+      <p:sp>
+        <p:nvSpPr>
+          <p:cNvPr id="7" name="Slide Number Placeholder 6"/>
+          <p:cNvSpPr>
+            <a:spLocks noGrp="1"/>
+          </p:cNvSpPr>
+          <p:nvPr>
+            <p:ph type="sldNum" sz="quarter" idx="5"/>
+          </p:nvPr>
+        </p:nvSpPr>
+        <p:spPr>
+          <a:xfrm>
+            <a:off x="3884613" y="8685213"/>
+            <a:ext cx="2971800" cy="457200"/>
+          </a:xfrm>
+          <a:prstGeom prst="rect">
+            <a:avLst/>
+          </a:prstGeom>
+        </p:spPr>
+        <p:txBody>
+          <a:bodyPr vert="horz" lIns="91440" tIns="45720" rIns="91440" bIns="45720" rtlCol="0" anchor="b"/>
+          <a:lstStyle>
+            <a:lvl1pPr algn="r">
+              <a:defRPr sz="1200"/>
+            </a:lvl1pPr>
+          </a:lstStyle>
+          <a:p>
+            <a:fld id="{BB5E49A5-4136-284D-997B-48E1D791AD67}" type="slidenum">
+              <a:rPr lang="en-US" smtClean="0"/>
+              <a:t>‹#›</a:t>
+            </a:fld>
+            <a:endParaRPr lang="en-US"/>
+          </a:p>
+        </p:txBody>
+      </p:sp>
     </p:spTree>
     <p:extLst>
       <p:ext uri="{BB962C8B-B14F-4D97-AF65-F5344CB8AC3E}">
-        <p14:creationId xmlns:p14="http://schemas.microsoft.com/office/powerpoint/2010/main" val="2956616574"/>
+        <p14:creationId xmlns:p14="http://schemas.microsoft.com/office/powerpoint/2010/main" val="2623252185"/>
       </p:ext>
     </p:extLst>
   </p:cSld>
   <p:clrMap bg1="lt1" tx1="dk1" bg2="lt2" tx2="dk2" accent1="accent1" accent2="accent2" accent3="accent3" accent4="accent4" accent5="accent5" accent6="accent6" hlink="hlink" folHlink="folHlink"/>
   <p:notesStyle>
-    <a:lvl1pPr marL="0" algn="l" defTabSz="914400" rtl="0" eaLnBrk="1" latinLnBrk="0" hangingPunct="1">
+    <a:lvl1pPr marL="0" algn="l" defTabSz="457200" rtl="0" eaLnBrk="1" latinLnBrk="0" hangingPunct="1">
       <a:defRPr sz="1200" kern="1200">
         <a:solidFill>
           <a:schemeClr val="tx1"/>
@@ -175,7 +381,7 @@
         <a:cs typeface="+mn-cs"/>
       </a:defRPr>
     </a:lvl1pPr>
-    <a:lvl2pPr marL="457200" algn="l" defTabSz="914400" rtl="0" eaLnBrk="1" latinLnBrk="0" hangingPunct="1">
+    <a:lvl2pPr marL="457200" algn="l" defTabSz="457200" rtl="0" eaLnBrk="1" latinLnBrk="0" hangingPunct="1">
       <a:defRPr sz="1200" kern="1200">
         <a:solidFill>
           <a:schemeClr val="tx1"/>
@@ -185,7 +391,7 @@
         <a:cs typeface="+mn-cs"/>
       </a:defRPr>
     </a:lvl2pPr>
-    <a:lvl3pPr marL="914400" algn="l" defTabSz="914400" rtl="0" eaLnBrk="1" latinLnBrk="0" hangingPunct="1">
+    <a:lvl3pPr marL="914400" algn="l" defTabSz="457200" rtl="0" eaLnBrk="1" latinLnBrk="0" hangingPunct="1">
       <a:defRPr sz="1200" kern="1200">
         <a:solidFill>
           <a:schemeClr val="tx1"/>
@@ -195,7 +401,7 @@
         <a:cs typeface="+mn-cs"/>
       </a:defRPr>
     </a:lvl3pPr>
-    <a:lvl4pPr marL="1371600" algn="l" defTabSz="914400" rtl="0" eaLnBrk="1" latinLnBrk="0" hangingPunct="1">
+    <a:lvl4pPr marL="1371600" algn="l" defTabSz="457200" rtl="0" eaLnBrk="1" latinLnBrk="0" hangingPunct="1">
       <a:defRPr sz="1200" kern="1200">
         <a:solidFill>
           <a:schemeClr val="tx1"/>
@@ -205,7 +411,7 @@
         <a:cs typeface="+mn-cs"/>
       </a:defRPr>
     </a:lvl4pPr>
-    <a:lvl5pPr marL="1828800" algn="l" defTabSz="914400" rtl="0" eaLnBrk="1" latinLnBrk="0" hangingPunct="1">
+    <a:lvl5pPr marL="1828800" algn="l" defTabSz="457200" rtl="0" eaLnBrk="1" latinLnBrk="0" hangingPunct="1">
       <a:defRPr sz="1200" kern="1200">
         <a:solidFill>
           <a:schemeClr val="tx1"/>
@@ -215,7 +421,7 @@
         <a:cs typeface="+mn-cs"/>
       </a:defRPr>
     </a:lvl5pPr>
-    <a:lvl6pPr marL="2286000" algn="l" defTabSz="914400" rtl="0" eaLnBrk="1" latinLnBrk="0" hangingPunct="1">
+    <a:lvl6pPr marL="2286000" algn="l" defTabSz="457200" rtl="0" eaLnBrk="1" latinLnBrk="0" hangingPunct="1">
       <a:defRPr sz="1200" kern="1200">
         <a:solidFill>
           <a:schemeClr val="tx1"/>
@@ -225,7 +431,7 @@
         <a:cs typeface="+mn-cs"/>
       </a:defRPr>
     </a:lvl6pPr>
-    <a:lvl7pPr marL="2743200" algn="l" defTabSz="914400" rtl="0" eaLnBrk="1" latinLnBrk="0" hangingPunct="1">
+    <a:lvl7pPr marL="2743200" algn="l" defTabSz="457200" rtl="0" eaLnBrk="1" latinLnBrk="0" hangingPunct="1">
       <a:defRPr sz="1200" kern="1200">
         <a:solidFill>
           <a:schemeClr val="tx1"/>
@@ -235,7 +441,7 @@
         <a:cs typeface="+mn-cs"/>
       </a:defRPr>
     </a:lvl7pPr>
-    <a:lvl8pPr marL="3200400" algn="l" defTabSz="914400" rtl="0" eaLnBrk="1" latinLnBrk="0" hangingPunct="1">
+    <a:lvl8pPr marL="3200400" algn="l" defTabSz="457200" rtl="0" eaLnBrk="1" latinLnBrk="0" hangingPunct="1">
       <a:defRPr sz="1200" kern="1200">
         <a:solidFill>
           <a:schemeClr val="tx1"/>
@@ -245,7 +451,7 @@
         <a:cs typeface="+mn-cs"/>
       </a:defRPr>
     </a:lvl8pPr>
-    <a:lvl9pPr marL="3657600" algn="l" defTabSz="914400" rtl="0" eaLnBrk="1" latinLnBrk="0" hangingPunct="1">
+    <a:lvl9pPr marL="3657600" algn="l" defTabSz="457200" rtl="0" eaLnBrk="1" latinLnBrk="0" hangingPunct="1">
       <a:defRPr sz="1200" kern="1200">
         <a:solidFill>
           <a:schemeClr val="tx1"/>
@@ -260,7 +466,7 @@
 </file>
 
 <file path=ppt/notesSlides/notesSlide1.xml><?xml version="1.0" encoding="utf-8"?>
-<p:notes xmlns:a="http://schemas.openxmlformats.org/drawingml/2006/main" xmlns:r="http://schemas.openxmlformats.org/officeDocument/2006/relationships" xmlns:p="http://schemas.openxmlformats.org/presentationml/2006/main">
+<p:notes xmlns:a="http://schemas.openxmlformats.org/drawingml/2006/main" xmlns:p="http://schemas.openxmlformats.org/presentationml/2006/main" xmlns:r="http://schemas.openxmlformats.org/officeDocument/2006/relationships">
   <p:cSld>
     <p:spTree>
       <p:nvGrpSpPr>
@@ -280,7 +486,7 @@
         <p:nvSpPr>
           <p:cNvPr id="2" name="Slide Image Placeholder 1"/>
           <p:cNvSpPr>
-            <a:spLocks noGrp="1" noRot="1" noChangeAspect="1"/>
+            <a:spLocks noGrp="1"/>
           </p:cNvSpPr>
           <p:nvPr>
             <p:ph type="sldImg" idx="2"/>
@@ -295,7 +501,7 @@
             <a:spLocks noGrp="1"/>
           </p:cNvSpPr>
           <p:nvPr>
-            <p:ph type="body" sz="quarter" idx="3"/>
+            <p:ph type="body" idx="3" sz="quarter"/>
           </p:nvPr>
         </p:nvSpPr>
         <p:spPr/>
@@ -316,7 +522,7 @@
             <a:spLocks noGrp="1"/>
           </p:cNvSpPr>
           <p:nvPr>
-            <p:ph type="sldNum" sz="quarter" idx="5"/>
+            <p:ph type="sldNum" idx="5" sz="quarter"/>
           </p:nvPr>
         </p:nvSpPr>
         <p:spPr/>
@@ -330,7 +536,7 @@
 </file>
 
 <file path=ppt/notesSlides/notesSlide2.xml><?xml version="1.0" encoding="utf-8"?>
-<p:notes xmlns:a="http://schemas.openxmlformats.org/drawingml/2006/main" xmlns:r="http://schemas.openxmlformats.org/officeDocument/2006/relationships" xmlns:p="http://schemas.openxmlformats.org/presentationml/2006/main">
+<p:notes xmlns:a="http://schemas.openxmlformats.org/drawingml/2006/main" xmlns:p="http://schemas.openxmlformats.org/presentationml/2006/main" xmlns:r="http://schemas.openxmlformats.org/officeDocument/2006/relationships">
   <p:cSld>
     <p:spTree>
       <p:nvGrpSpPr>
@@ -350,7 +556,7 @@
         <p:nvSpPr>
           <p:cNvPr id="2" name="Slide Image Placeholder 1"/>
           <p:cNvSpPr>
-            <a:spLocks noGrp="1" noRot="1" noChangeAspect="1"/>
+            <a:spLocks noGrp="1"/>
           </p:cNvSpPr>
           <p:nvPr>
             <p:ph type="sldImg" idx="2"/>
@@ -365,7 +571,7 @@
             <a:spLocks noGrp="1"/>
           </p:cNvSpPr>
           <p:nvPr>
-            <p:ph type="body" sz="quarter" idx="3"/>
+            <p:ph type="body" idx="3" sz="quarter"/>
           </p:nvPr>
         </p:nvSpPr>
         <p:spPr/>
@@ -386,7 +592,7 @@
             <a:spLocks noGrp="1"/>
           </p:cNvSpPr>
           <p:nvPr>
-            <p:ph type="sldNum" sz="quarter" idx="5"/>
+            <p:ph type="sldNum" idx="5" sz="quarter"/>
           </p:nvPr>
         </p:nvSpPr>
         <p:spPr/>
@@ -400,7 +606,7 @@
 </file>
 
 <file path=ppt/notesSlides/notesSlide3.xml><?xml version="1.0" encoding="utf-8"?>
-<p:notes xmlns:a="http://schemas.openxmlformats.org/drawingml/2006/main" xmlns:r="http://schemas.openxmlformats.org/officeDocument/2006/relationships" xmlns:p="http://schemas.openxmlformats.org/presentationml/2006/main">
+<p:notes xmlns:a="http://schemas.openxmlformats.org/drawingml/2006/main" xmlns:p="http://schemas.openxmlformats.org/presentationml/2006/main" xmlns:r="http://schemas.openxmlformats.org/officeDocument/2006/relationships">
   <p:cSld>
     <p:spTree>
       <p:nvGrpSpPr>
@@ -420,7 +626,7 @@
         <p:nvSpPr>
           <p:cNvPr id="2" name="Slide Image Placeholder 1"/>
           <p:cNvSpPr>
-            <a:spLocks noGrp="1" noRot="1" noChangeAspect="1"/>
+            <a:spLocks noGrp="1"/>
           </p:cNvSpPr>
           <p:nvPr>
             <p:ph type="sldImg" idx="2"/>
@@ -435,7 +641,7 @@
             <a:spLocks noGrp="1"/>
           </p:cNvSpPr>
           <p:nvPr>
-            <p:ph type="body" sz="quarter" idx="3"/>
+            <p:ph type="body" idx="3" sz="quarter"/>
           </p:nvPr>
         </p:nvSpPr>
         <p:spPr/>
@@ -456,7 +662,7 @@
             <a:spLocks noGrp="1"/>
           </p:cNvSpPr>
           <p:nvPr>
-            <p:ph type="sldNum" sz="quarter" idx="5"/>
+            <p:ph type="sldNum" idx="5" sz="quarter"/>
           </p:nvPr>
         </p:nvSpPr>
         <p:spPr/>
@@ -470,7 +676,7 @@
 </file>
 
 <file path=ppt/notesSlides/notesSlide4.xml><?xml version="1.0" encoding="utf-8"?>
-<p:notes xmlns:a="http://schemas.openxmlformats.org/drawingml/2006/main" xmlns:r="http://schemas.openxmlformats.org/officeDocument/2006/relationships" xmlns:p="http://schemas.openxmlformats.org/presentationml/2006/main">
+<p:notes xmlns:a="http://schemas.openxmlformats.org/drawingml/2006/main" xmlns:p="http://schemas.openxmlformats.org/presentationml/2006/main" xmlns:r="http://schemas.openxmlformats.org/officeDocument/2006/relationships">
   <p:cSld>
     <p:spTree>
       <p:nvGrpSpPr>
@@ -490,7 +696,7 @@
         <p:nvSpPr>
           <p:cNvPr id="2" name="Slide Image Placeholder 1"/>
           <p:cNvSpPr>
-            <a:spLocks noGrp="1" noRot="1" noChangeAspect="1"/>
+            <a:spLocks noGrp="1"/>
           </p:cNvSpPr>
           <p:nvPr>
             <p:ph type="sldImg" idx="2"/>
@@ -505,7 +711,7 @@
             <a:spLocks noGrp="1"/>
           </p:cNvSpPr>
           <p:nvPr>
-            <p:ph type="body" sz="quarter" idx="3"/>
+            <p:ph type="body" idx="3" sz="quarter"/>
           </p:nvPr>
         </p:nvSpPr>
         <p:spPr/>
@@ -526,7 +732,7 @@
             <a:spLocks noGrp="1"/>
           </p:cNvSpPr>
           <p:nvPr>
-            <p:ph type="sldNum" sz="quarter" idx="5"/>
+            <p:ph type="sldNum" idx="5" sz="quarter"/>
           </p:nvPr>
         </p:nvSpPr>
         <p:spPr/>
@@ -540,7 +746,7 @@
 </file>
 
 <file path=ppt/notesSlides/notesSlide5.xml><?xml version="1.0" encoding="utf-8"?>
-<p:notes xmlns:a="http://schemas.openxmlformats.org/drawingml/2006/main" xmlns:r="http://schemas.openxmlformats.org/officeDocument/2006/relationships" xmlns:p="http://schemas.openxmlformats.org/presentationml/2006/main">
+<p:notes xmlns:a="http://schemas.openxmlformats.org/drawingml/2006/main" xmlns:p="http://schemas.openxmlformats.org/presentationml/2006/main" xmlns:r="http://schemas.openxmlformats.org/officeDocument/2006/relationships">
   <p:cSld>
     <p:spTree>
       <p:nvGrpSpPr>
@@ -560,7 +766,7 @@
         <p:nvSpPr>
           <p:cNvPr id="2" name="Slide Image Placeholder 1"/>
           <p:cNvSpPr>
-            <a:spLocks noGrp="1" noRot="1" noChangeAspect="1"/>
+            <a:spLocks noGrp="1"/>
           </p:cNvSpPr>
           <p:nvPr>
             <p:ph type="sldImg" idx="2"/>
@@ -575,7 +781,7 @@
             <a:spLocks noGrp="1"/>
           </p:cNvSpPr>
           <p:nvPr>
-            <p:ph type="body" sz="quarter" idx="3"/>
+            <p:ph type="body" idx="3" sz="quarter"/>
           </p:nvPr>
         </p:nvSpPr>
         <p:spPr/>
@@ -596,7 +802,7 @@
             <a:spLocks noGrp="1"/>
           </p:cNvSpPr>
           <p:nvPr>
-            <p:ph type="sldNum" sz="quarter" idx="5"/>
+            <p:ph type="sldNum" idx="5" sz="quarter"/>
           </p:nvPr>
         </p:nvSpPr>
         <p:spPr/>
@@ -610,7 +816,7 @@
 </file>
 
 <file path=ppt/notesSlides/notesSlide6.xml><?xml version="1.0" encoding="utf-8"?>
-<p:notes xmlns:a="http://schemas.openxmlformats.org/drawingml/2006/main" xmlns:r="http://schemas.openxmlformats.org/officeDocument/2006/relationships" xmlns:p="http://schemas.openxmlformats.org/presentationml/2006/main">
+<p:notes xmlns:a="http://schemas.openxmlformats.org/drawingml/2006/main" xmlns:p="http://schemas.openxmlformats.org/presentationml/2006/main" xmlns:r="http://schemas.openxmlformats.org/officeDocument/2006/relationships">
   <p:cSld>
     <p:spTree>
       <p:nvGrpSpPr>
@@ -630,7 +836,7 @@
         <p:nvSpPr>
           <p:cNvPr id="2" name="Slide Image Placeholder 1"/>
           <p:cNvSpPr>
-            <a:spLocks noGrp="1" noRot="1" noChangeAspect="1"/>
+            <a:spLocks noGrp="1"/>
           </p:cNvSpPr>
           <p:nvPr>
             <p:ph type="sldImg" idx="2"/>
@@ -645,7 +851,7 @@
             <a:spLocks noGrp="1"/>
           </p:cNvSpPr>
           <p:nvPr>
-            <p:ph type="body" sz="quarter" idx="3"/>
+            <p:ph type="body" idx="3" sz="quarter"/>
           </p:nvPr>
         </p:nvSpPr>
         <p:spPr/>
@@ -666,7 +872,7 @@
             <a:spLocks noGrp="1"/>
           </p:cNvSpPr>
           <p:nvPr>
-            <p:ph type="sldNum" sz="quarter" idx="5"/>
+            <p:ph type="sldNum" idx="5" sz="quarter"/>
           </p:nvPr>
         </p:nvSpPr>
         <p:spPr/>
@@ -680,7 +886,7 @@
 </file>
 
 <file path=ppt/notesSlides/notesSlide7.xml><?xml version="1.0" encoding="utf-8"?>
-<p:notes xmlns:a="http://schemas.openxmlformats.org/drawingml/2006/main" xmlns:r="http://schemas.openxmlformats.org/officeDocument/2006/relationships" xmlns:p="http://schemas.openxmlformats.org/presentationml/2006/main">
+<p:notes xmlns:a="http://schemas.openxmlformats.org/drawingml/2006/main" xmlns:p="http://schemas.openxmlformats.org/presentationml/2006/main" xmlns:r="http://schemas.openxmlformats.org/officeDocument/2006/relationships">
   <p:cSld>
     <p:spTree>
       <p:nvGrpSpPr>
@@ -700,7 +906,7 @@
         <p:nvSpPr>
           <p:cNvPr id="2" name="Slide Image Placeholder 1"/>
           <p:cNvSpPr>
-            <a:spLocks noGrp="1" noRot="1" noChangeAspect="1"/>
+            <a:spLocks noGrp="1"/>
           </p:cNvSpPr>
           <p:nvPr>
             <p:ph type="sldImg" idx="2"/>
@@ -715,7 +921,7 @@
             <a:spLocks noGrp="1"/>
           </p:cNvSpPr>
           <p:nvPr>
-            <p:ph type="body" sz="quarter" idx="3"/>
+            <p:ph type="body" idx="3" sz="quarter"/>
           </p:nvPr>
         </p:nvSpPr>
         <p:spPr/>
@@ -736,7 +942,7 @@
             <a:spLocks noGrp="1"/>
           </p:cNvSpPr>
           <p:nvPr>
-            <p:ph type="sldNum" sz="quarter" idx="5"/>
+            <p:ph type="sldNum" idx="5" sz="quarter"/>
           </p:nvPr>
         </p:nvSpPr>
         <p:spPr/>
@@ -750,7 +956,7 @@
 </file>
 
 <file path=ppt/notesSlides/notesSlide8.xml><?xml version="1.0" encoding="utf-8"?>
-<p:notes xmlns:a="http://schemas.openxmlformats.org/drawingml/2006/main" xmlns:r="http://schemas.openxmlformats.org/officeDocument/2006/relationships" xmlns:p="http://schemas.openxmlformats.org/presentationml/2006/main">
+<p:notes xmlns:a="http://schemas.openxmlformats.org/drawingml/2006/main" xmlns:p="http://schemas.openxmlformats.org/presentationml/2006/main" xmlns:r="http://schemas.openxmlformats.org/officeDocument/2006/relationships">
   <p:cSld>
     <p:spTree>
       <p:nvGrpSpPr>
@@ -770,7 +976,7 @@
         <p:nvSpPr>
           <p:cNvPr id="2" name="Slide Image Placeholder 1"/>
           <p:cNvSpPr>
-            <a:spLocks noGrp="1" noRot="1" noChangeAspect="1"/>
+            <a:spLocks noGrp="1"/>
           </p:cNvSpPr>
           <p:nvPr>
             <p:ph type="sldImg" idx="2"/>
@@ -785,7 +991,7 @@
             <a:spLocks noGrp="1"/>
           </p:cNvSpPr>
           <p:nvPr>
-            <p:ph type="body" sz="quarter" idx="3"/>
+            <p:ph type="body" idx="3" sz="quarter"/>
           </p:nvPr>
         </p:nvSpPr>
         <p:spPr/>
@@ -806,7 +1012,7 @@
             <a:spLocks noGrp="1"/>
           </p:cNvSpPr>
           <p:nvPr>
-            <p:ph type="sldNum" sz="quarter" idx="5"/>
+            <p:ph type="sldNum" idx="5" sz="quarter"/>
           </p:nvPr>
         </p:nvSpPr>
         <p:spPr/>
@@ -820,7 +1026,7 @@
 </file>
 
 <file path=ppt/notesSlides/notesSlide9.xml><?xml version="1.0" encoding="utf-8"?>
-<p:notes xmlns:a="http://schemas.openxmlformats.org/drawingml/2006/main" xmlns:r="http://schemas.openxmlformats.org/officeDocument/2006/relationships" xmlns:p="http://schemas.openxmlformats.org/presentationml/2006/main">
+<p:notes xmlns:a="http://schemas.openxmlformats.org/drawingml/2006/main" xmlns:p="http://schemas.openxmlformats.org/presentationml/2006/main" xmlns:r="http://schemas.openxmlformats.org/officeDocument/2006/relationships">
   <p:cSld>
     <p:spTree>
       <p:nvGrpSpPr>
@@ -840,7 +1046,7 @@
         <p:nvSpPr>
           <p:cNvPr id="2" name="Slide Image Placeholder 1"/>
           <p:cNvSpPr>
-            <a:spLocks noGrp="1" noRot="1" noChangeAspect="1"/>
+            <a:spLocks noGrp="1"/>
           </p:cNvSpPr>
           <p:nvPr>
             <p:ph type="sldImg" idx="2"/>
@@ -855,7 +1061,7 @@
             <a:spLocks noGrp="1"/>
           </p:cNvSpPr>
           <p:nvPr>
-            <p:ph type="body" sz="quarter" idx="3"/>
+            <p:ph type="body" idx="3" sz="quarter"/>
           </p:nvPr>
         </p:nvSpPr>
         <p:spPr/>
@@ -876,7 +1082,7 @@
             <a:spLocks noGrp="1"/>
           </p:cNvSpPr>
           <p:nvPr>
-            <p:ph type="sldNum" sz="quarter" idx="5"/>
+            <p:ph type="sldNum" idx="5" sz="quarter"/>
           </p:nvPr>
         </p:nvSpPr>
         <p:spPr/>
@@ -927,9 +1133,10 @@
           <a:lstStyle/>
           <a:p>
             <a:r>
-              <a:rPr lang="en-US"/>
+              <a:rPr lang="en-US" smtClean="0"/>
               <a:t>Click to edit Master title style</a:t>
             </a:r>
+            <a:endParaRPr lang="en-US"/>
           </a:p>
         </p:txBody>
       </p:sp>
@@ -1045,9 +1252,10 @@
           </a:lstStyle>
           <a:p>
             <a:r>
-              <a:rPr lang="en-US"/>
+              <a:rPr lang="en-US" smtClean="0"/>
               <a:t>Click to edit Master subtitle style</a:t>
             </a:r>
+            <a:endParaRPr lang="en-US"/>
           </a:p>
         </p:txBody>
       </p:sp>
@@ -1068,7 +1276,7 @@
           <a:p>
             <a:fld id="{5BCAD085-E8A6-8845-BD4E-CB4CCA059FC4}" type="datetimeFigureOut">
               <a:rPr lang="en-US" smtClean="0"/>
-              <a:t>8/31/2026</a:t>
+              <a:t>1/27/13</a:t>
             </a:fld>
             <a:endParaRPr lang="en-US"/>
           </a:p>
@@ -1162,9 +1370,10 @@
           <a:lstStyle/>
           <a:p>
             <a:r>
-              <a:rPr lang="en-US"/>
+              <a:rPr lang="en-US" smtClean="0"/>
               <a:t>Click to edit Master title style</a:t>
             </a:r>
+            <a:endParaRPr lang="en-US"/>
           </a:p>
         </p:txBody>
       </p:sp>
@@ -1185,37 +1394,38 @@
           <a:p>
             <a:pPr lvl="0"/>
             <a:r>
-              <a:rPr lang="en-US"/>
+              <a:rPr lang="en-US" smtClean="0"/>
               <a:t>Click to edit Master text styles</a:t>
             </a:r>
           </a:p>
           <a:p>
             <a:pPr lvl="1"/>
             <a:r>
-              <a:rPr lang="en-US"/>
+              <a:rPr lang="en-US" smtClean="0"/>
               <a:t>Second level</a:t>
             </a:r>
           </a:p>
           <a:p>
             <a:pPr lvl="2"/>
             <a:r>
-              <a:rPr lang="en-US"/>
+              <a:rPr lang="en-US" smtClean="0"/>
               <a:t>Third level</a:t>
             </a:r>
           </a:p>
           <a:p>
             <a:pPr lvl="3"/>
             <a:r>
-              <a:rPr lang="en-US"/>
+              <a:rPr lang="en-US" smtClean="0"/>
               <a:t>Fourth level</a:t>
             </a:r>
           </a:p>
           <a:p>
             <a:pPr lvl="4"/>
             <a:r>
-              <a:rPr lang="en-US"/>
+              <a:rPr lang="en-US" smtClean="0"/>
               <a:t>Fifth level</a:t>
             </a:r>
+            <a:endParaRPr lang="en-US"/>
           </a:p>
         </p:txBody>
       </p:sp>
@@ -1236,7 +1446,7 @@
           <a:p>
             <a:fld id="{5BCAD085-E8A6-8845-BD4E-CB4CCA059FC4}" type="datetimeFigureOut">
               <a:rPr lang="en-US" smtClean="0"/>
-              <a:t>8/31/2026</a:t>
+              <a:t>1/27/13</a:t>
             </a:fld>
             <a:endParaRPr lang="en-US"/>
           </a:p>
@@ -1335,9 +1545,10 @@
           <a:lstStyle/>
           <a:p>
             <a:r>
-              <a:rPr lang="en-US"/>
+              <a:rPr lang="en-US" smtClean="0"/>
               <a:t>Click to edit Master title style</a:t>
             </a:r>
+            <a:endParaRPr lang="en-US"/>
           </a:p>
         </p:txBody>
       </p:sp>
@@ -1363,37 +1574,38 @@
           <a:p>
             <a:pPr lvl="0"/>
             <a:r>
-              <a:rPr lang="en-US"/>
+              <a:rPr lang="en-US" smtClean="0"/>
               <a:t>Click to edit Master text styles</a:t>
             </a:r>
           </a:p>
           <a:p>
             <a:pPr lvl="1"/>
             <a:r>
-              <a:rPr lang="en-US"/>
+              <a:rPr lang="en-US" smtClean="0"/>
               <a:t>Second level</a:t>
             </a:r>
           </a:p>
           <a:p>
             <a:pPr lvl="2"/>
             <a:r>
-              <a:rPr lang="en-US"/>
+              <a:rPr lang="en-US" smtClean="0"/>
               <a:t>Third level</a:t>
             </a:r>
           </a:p>
           <a:p>
             <a:pPr lvl="3"/>
             <a:r>
-              <a:rPr lang="en-US"/>
+              <a:rPr lang="en-US" smtClean="0"/>
               <a:t>Fourth level</a:t>
             </a:r>
           </a:p>
           <a:p>
             <a:pPr lvl="4"/>
             <a:r>
-              <a:rPr lang="en-US"/>
+              <a:rPr lang="en-US" smtClean="0"/>
               <a:t>Fifth level</a:t>
             </a:r>
+            <a:endParaRPr lang="en-US"/>
           </a:p>
         </p:txBody>
       </p:sp>
@@ -1414,7 +1626,7 @@
           <a:p>
             <a:fld id="{5BCAD085-E8A6-8845-BD4E-CB4CCA059FC4}" type="datetimeFigureOut">
               <a:rPr lang="en-US" smtClean="0"/>
-              <a:t>8/31/2026</a:t>
+              <a:t>1/27/13</a:t>
             </a:fld>
             <a:endParaRPr lang="en-US"/>
           </a:p>
@@ -1508,9 +1720,10 @@
           <a:lstStyle/>
           <a:p>
             <a:r>
-              <a:rPr lang="en-US"/>
+              <a:rPr lang="en-US" smtClean="0"/>
               <a:t>Click to edit Master title style</a:t>
             </a:r>
+            <a:endParaRPr lang="en-US"/>
           </a:p>
         </p:txBody>
       </p:sp>
@@ -1531,37 +1744,38 @@
           <a:p>
             <a:pPr lvl="0"/>
             <a:r>
-              <a:rPr lang="en-US"/>
+              <a:rPr lang="en-US" smtClean="0"/>
               <a:t>Click to edit Master text styles</a:t>
             </a:r>
           </a:p>
           <a:p>
             <a:pPr lvl="1"/>
             <a:r>
-              <a:rPr lang="en-US"/>
+              <a:rPr lang="en-US" smtClean="0"/>
               <a:t>Second level</a:t>
             </a:r>
           </a:p>
           <a:p>
             <a:pPr lvl="2"/>
             <a:r>
-              <a:rPr lang="en-US"/>
+              <a:rPr lang="en-US" smtClean="0"/>
               <a:t>Third level</a:t>
             </a:r>
           </a:p>
           <a:p>
             <a:pPr lvl="3"/>
             <a:r>
-              <a:rPr lang="en-US"/>
+              <a:rPr lang="en-US" smtClean="0"/>
               <a:t>Fourth level</a:t>
             </a:r>
           </a:p>
           <a:p>
             <a:pPr lvl="4"/>
             <a:r>
-              <a:rPr lang="en-US"/>
+              <a:rPr lang="en-US" smtClean="0"/>
               <a:t>Fifth level</a:t>
             </a:r>
+            <a:endParaRPr lang="en-US"/>
           </a:p>
         </p:txBody>
       </p:sp>
@@ -1582,7 +1796,7 @@
           <a:p>
             <a:fld id="{5BCAD085-E8A6-8845-BD4E-CB4CCA059FC4}" type="datetimeFigureOut">
               <a:rPr lang="en-US" smtClean="0"/>
-              <a:t>8/31/2026</a:t>
+              <a:t>1/27/13</a:t>
             </a:fld>
             <a:endParaRPr lang="en-US"/>
           </a:p>
@@ -1685,9 +1899,10 @@
           </a:lstStyle>
           <a:p>
             <a:r>
-              <a:rPr lang="en-US"/>
+              <a:rPr lang="en-US" smtClean="0"/>
               <a:t>Click to edit Master title style</a:t>
             </a:r>
+            <a:endParaRPr lang="en-US"/>
           </a:p>
         </p:txBody>
       </p:sp>
@@ -1804,7 +2019,7 @@
           <a:p>
             <a:pPr lvl="0"/>
             <a:r>
-              <a:rPr lang="en-US"/>
+              <a:rPr lang="en-US" smtClean="0"/>
               <a:t>Click to edit Master text styles</a:t>
             </a:r>
           </a:p>
@@ -1827,7 +2042,7 @@
           <a:p>
             <a:fld id="{5BCAD085-E8A6-8845-BD4E-CB4CCA059FC4}" type="datetimeFigureOut">
               <a:rPr lang="en-US" smtClean="0"/>
-              <a:t>8/31/2026</a:t>
+              <a:t>1/27/13</a:t>
             </a:fld>
             <a:endParaRPr lang="en-US"/>
           </a:p>
@@ -1921,9 +2136,10 @@
           <a:lstStyle/>
           <a:p>
             <a:r>
-              <a:rPr lang="en-US"/>
+              <a:rPr lang="en-US" smtClean="0"/>
               <a:t>Click to edit Master title style</a:t>
             </a:r>
+            <a:endParaRPr lang="en-US"/>
           </a:p>
         </p:txBody>
       </p:sp>
@@ -1977,37 +2193,38 @@
           <a:p>
             <a:pPr lvl="0"/>
             <a:r>
-              <a:rPr lang="en-US"/>
+              <a:rPr lang="en-US" smtClean="0"/>
               <a:t>Click to edit Master text styles</a:t>
             </a:r>
           </a:p>
           <a:p>
             <a:pPr lvl="1"/>
             <a:r>
-              <a:rPr lang="en-US"/>
+              <a:rPr lang="en-US" smtClean="0"/>
               <a:t>Second level</a:t>
             </a:r>
           </a:p>
           <a:p>
             <a:pPr lvl="2"/>
             <a:r>
-              <a:rPr lang="en-US"/>
+              <a:rPr lang="en-US" smtClean="0"/>
               <a:t>Third level</a:t>
             </a:r>
           </a:p>
           <a:p>
             <a:pPr lvl="3"/>
             <a:r>
-              <a:rPr lang="en-US"/>
+              <a:rPr lang="en-US" smtClean="0"/>
               <a:t>Fourth level</a:t>
             </a:r>
           </a:p>
           <a:p>
             <a:pPr lvl="4"/>
             <a:r>
-              <a:rPr lang="en-US"/>
+              <a:rPr lang="en-US" smtClean="0"/>
               <a:t>Fifth level</a:t>
             </a:r>
+            <a:endParaRPr lang="en-US"/>
           </a:p>
         </p:txBody>
       </p:sp>
@@ -2061,37 +2278,38 @@
           <a:p>
             <a:pPr lvl="0"/>
             <a:r>
-              <a:rPr lang="en-US"/>
+              <a:rPr lang="en-US" smtClean="0"/>
               <a:t>Click to edit Master text styles</a:t>
             </a:r>
           </a:p>
           <a:p>
             <a:pPr lvl="1"/>
             <a:r>
-              <a:rPr lang="en-US"/>
+              <a:rPr lang="en-US" smtClean="0"/>
               <a:t>Second level</a:t>
             </a:r>
           </a:p>
           <a:p>
             <a:pPr lvl="2"/>
             <a:r>
-              <a:rPr lang="en-US"/>
+              <a:rPr lang="en-US" smtClean="0"/>
               <a:t>Third level</a:t>
             </a:r>
           </a:p>
           <a:p>
             <a:pPr lvl="3"/>
             <a:r>
-              <a:rPr lang="en-US"/>
+              <a:rPr lang="en-US" smtClean="0"/>
               <a:t>Fourth level</a:t>
             </a:r>
           </a:p>
           <a:p>
             <a:pPr lvl="4"/>
             <a:r>
-              <a:rPr lang="en-US"/>
+              <a:rPr lang="en-US" smtClean="0"/>
               <a:t>Fifth level</a:t>
             </a:r>
+            <a:endParaRPr lang="en-US"/>
           </a:p>
         </p:txBody>
       </p:sp>
@@ -2112,7 +2330,7 @@
           <a:p>
             <a:fld id="{5BCAD085-E8A6-8845-BD4E-CB4CCA059FC4}" type="datetimeFigureOut">
               <a:rPr lang="en-US" smtClean="0"/>
-              <a:t>8/31/2026</a:t>
+              <a:t>1/27/13</a:t>
             </a:fld>
             <a:endParaRPr lang="en-US"/>
           </a:p>
@@ -2210,9 +2428,10 @@
           </a:lstStyle>
           <a:p>
             <a:r>
-              <a:rPr lang="en-US"/>
+              <a:rPr lang="en-US" smtClean="0"/>
               <a:t>Click to edit Master title style</a:t>
             </a:r>
+            <a:endParaRPr lang="en-US"/>
           </a:p>
         </p:txBody>
       </p:sp>
@@ -2275,7 +2494,7 @@
           <a:p>
             <a:pPr lvl="0"/>
             <a:r>
-              <a:rPr lang="en-US"/>
+              <a:rPr lang="en-US" smtClean="0"/>
               <a:t>Click to edit Master text styles</a:t>
             </a:r>
           </a:p>
@@ -2331,37 +2550,38 @@
           <a:p>
             <a:pPr lvl="0"/>
             <a:r>
-              <a:rPr lang="en-US"/>
+              <a:rPr lang="en-US" smtClean="0"/>
               <a:t>Click to edit Master text styles</a:t>
             </a:r>
           </a:p>
           <a:p>
             <a:pPr lvl="1"/>
             <a:r>
-              <a:rPr lang="en-US"/>
+              <a:rPr lang="en-US" smtClean="0"/>
               <a:t>Second level</a:t>
             </a:r>
           </a:p>
           <a:p>
             <a:pPr lvl="2"/>
             <a:r>
-              <a:rPr lang="en-US"/>
+              <a:rPr lang="en-US" smtClean="0"/>
               <a:t>Third level</a:t>
             </a:r>
           </a:p>
           <a:p>
             <a:pPr lvl="3"/>
             <a:r>
-              <a:rPr lang="en-US"/>
+              <a:rPr lang="en-US" smtClean="0"/>
               <a:t>Fourth level</a:t>
             </a:r>
           </a:p>
           <a:p>
             <a:pPr lvl="4"/>
             <a:r>
-              <a:rPr lang="en-US"/>
+              <a:rPr lang="en-US" smtClean="0"/>
               <a:t>Fifth level</a:t>
             </a:r>
+            <a:endParaRPr lang="en-US"/>
           </a:p>
         </p:txBody>
       </p:sp>
@@ -2424,7 +2644,7 @@
           <a:p>
             <a:pPr lvl="0"/>
             <a:r>
-              <a:rPr lang="en-US"/>
+              <a:rPr lang="en-US" smtClean="0"/>
               <a:t>Click to edit Master text styles</a:t>
             </a:r>
           </a:p>
@@ -2480,37 +2700,38 @@
           <a:p>
             <a:pPr lvl="0"/>
             <a:r>
-              <a:rPr lang="en-US"/>
+              <a:rPr lang="en-US" smtClean="0"/>
               <a:t>Click to edit Master text styles</a:t>
             </a:r>
           </a:p>
           <a:p>
             <a:pPr lvl="1"/>
             <a:r>
-              <a:rPr lang="en-US"/>
+              <a:rPr lang="en-US" smtClean="0"/>
               <a:t>Second level</a:t>
             </a:r>
           </a:p>
           <a:p>
             <a:pPr lvl="2"/>
             <a:r>
-              <a:rPr lang="en-US"/>
+              <a:rPr lang="en-US" smtClean="0"/>
               <a:t>Third level</a:t>
             </a:r>
           </a:p>
           <a:p>
             <a:pPr lvl="3"/>
             <a:r>
-              <a:rPr lang="en-US"/>
+              <a:rPr lang="en-US" smtClean="0"/>
               <a:t>Fourth level</a:t>
             </a:r>
           </a:p>
           <a:p>
             <a:pPr lvl="4"/>
             <a:r>
-              <a:rPr lang="en-US"/>
+              <a:rPr lang="en-US" smtClean="0"/>
               <a:t>Fifth level</a:t>
             </a:r>
+            <a:endParaRPr lang="en-US"/>
           </a:p>
         </p:txBody>
       </p:sp>
@@ -2531,7 +2752,7 @@
           <a:p>
             <a:fld id="{5BCAD085-E8A6-8845-BD4E-CB4CCA059FC4}" type="datetimeFigureOut">
               <a:rPr lang="en-US" smtClean="0"/>
-              <a:t>8/31/2026</a:t>
+              <a:t>1/27/13</a:t>
             </a:fld>
             <a:endParaRPr lang="en-US"/>
           </a:p>
@@ -2625,9 +2846,10 @@
           <a:lstStyle/>
           <a:p>
             <a:r>
-              <a:rPr lang="en-US"/>
+              <a:rPr lang="en-US" smtClean="0"/>
               <a:t>Click to edit Master title style</a:t>
             </a:r>
+            <a:endParaRPr lang="en-US"/>
           </a:p>
         </p:txBody>
       </p:sp>
@@ -2648,7 +2870,7 @@
           <a:p>
             <a:fld id="{5BCAD085-E8A6-8845-BD4E-CB4CCA059FC4}" type="datetimeFigureOut">
               <a:rPr lang="en-US" smtClean="0"/>
-              <a:t>8/31/2026</a:t>
+              <a:t>1/27/13</a:t>
             </a:fld>
             <a:endParaRPr lang="en-US"/>
           </a:p>
@@ -2743,7 +2965,7 @@
           <a:p>
             <a:fld id="{5BCAD085-E8A6-8845-BD4E-CB4CCA059FC4}" type="datetimeFigureOut">
               <a:rPr lang="en-US" smtClean="0"/>
-              <a:t>8/31/2026</a:t>
+              <a:t>1/27/13</a:t>
             </a:fld>
             <a:endParaRPr lang="en-US"/>
           </a:p>
@@ -2846,9 +3068,10 @@
           </a:lstStyle>
           <a:p>
             <a:r>
-              <a:rPr lang="en-US"/>
+              <a:rPr lang="en-US" smtClean="0"/>
               <a:t>Click to edit Master title style</a:t>
             </a:r>
+            <a:endParaRPr lang="en-US"/>
           </a:p>
         </p:txBody>
       </p:sp>
@@ -2902,37 +3125,38 @@
           <a:p>
             <a:pPr lvl="0"/>
             <a:r>
-              <a:rPr lang="en-US"/>
+              <a:rPr lang="en-US" smtClean="0"/>
               <a:t>Click to edit Master text styles</a:t>
             </a:r>
           </a:p>
           <a:p>
             <a:pPr lvl="1"/>
             <a:r>
-              <a:rPr lang="en-US"/>
+              <a:rPr lang="en-US" smtClean="0"/>
               <a:t>Second level</a:t>
             </a:r>
           </a:p>
           <a:p>
             <a:pPr lvl="2"/>
             <a:r>
-              <a:rPr lang="en-US"/>
+              <a:rPr lang="en-US" smtClean="0"/>
               <a:t>Third level</a:t>
             </a:r>
           </a:p>
           <a:p>
             <a:pPr lvl="3"/>
             <a:r>
-              <a:rPr lang="en-US"/>
+              <a:rPr lang="en-US" smtClean="0"/>
               <a:t>Fourth level</a:t>
             </a:r>
           </a:p>
           <a:p>
             <a:pPr lvl="4"/>
             <a:r>
-              <a:rPr lang="en-US"/>
+              <a:rPr lang="en-US" smtClean="0"/>
               <a:t>Fifth level</a:t>
             </a:r>
+            <a:endParaRPr lang="en-US"/>
           </a:p>
         </p:txBody>
       </p:sp>
@@ -2995,7 +3219,7 @@
           <a:p>
             <a:pPr lvl="0"/>
             <a:r>
-              <a:rPr lang="en-US"/>
+              <a:rPr lang="en-US" smtClean="0"/>
               <a:t>Click to edit Master text styles</a:t>
             </a:r>
           </a:p>
@@ -3018,7 +3242,7 @@
           <a:p>
             <a:fld id="{5BCAD085-E8A6-8845-BD4E-CB4CCA059FC4}" type="datetimeFigureOut">
               <a:rPr lang="en-US" smtClean="0"/>
-              <a:t>8/31/2026</a:t>
+              <a:t>1/27/13</a:t>
             </a:fld>
             <a:endParaRPr lang="en-US"/>
           </a:p>
@@ -3121,9 +3345,10 @@
           </a:lstStyle>
           <a:p>
             <a:r>
-              <a:rPr lang="en-US"/>
+              <a:rPr lang="en-US" smtClean="0"/>
               <a:t>Click to edit Master title style</a:t>
             </a:r>
+            <a:endParaRPr lang="en-US"/>
           </a:p>
         </p:txBody>
       </p:sp>
@@ -3247,7 +3472,7 @@
           <a:p>
             <a:pPr lvl="0"/>
             <a:r>
-              <a:rPr lang="en-US"/>
+              <a:rPr lang="en-US" smtClean="0"/>
               <a:t>Click to edit Master text styles</a:t>
             </a:r>
           </a:p>
@@ -3270,7 +3495,7 @@
           <a:p>
             <a:fld id="{5BCAD085-E8A6-8845-BD4E-CB4CCA059FC4}" type="datetimeFigureOut">
               <a:rPr lang="en-US" smtClean="0"/>
-              <a:t>8/31/2026</a:t>
+              <a:t>1/27/13</a:t>
             </a:fld>
             <a:endParaRPr lang="en-US"/>
           </a:p>
@@ -3379,9 +3604,10 @@
           <a:lstStyle/>
           <a:p>
             <a:r>
-              <a:rPr lang="en-US"/>
+              <a:rPr lang="en-US" smtClean="0"/>
               <a:t>Click to edit Master title style</a:t>
             </a:r>
+            <a:endParaRPr lang="en-US"/>
           </a:p>
         </p:txBody>
       </p:sp>
@@ -3412,37 +3638,38 @@
           <a:p>
             <a:pPr lvl="0"/>
             <a:r>
-              <a:rPr lang="en-US"/>
+              <a:rPr lang="en-US" smtClean="0"/>
               <a:t>Click to edit Master text styles</a:t>
             </a:r>
           </a:p>
           <a:p>
             <a:pPr lvl="1"/>
             <a:r>
-              <a:rPr lang="en-US"/>
+              <a:rPr lang="en-US" smtClean="0"/>
               <a:t>Second level</a:t>
             </a:r>
           </a:p>
           <a:p>
             <a:pPr lvl="2"/>
             <a:r>
-              <a:rPr lang="en-US"/>
+              <a:rPr lang="en-US" smtClean="0"/>
               <a:t>Third level</a:t>
             </a:r>
           </a:p>
           <a:p>
             <a:pPr lvl="3"/>
             <a:r>
-              <a:rPr lang="en-US"/>
+              <a:rPr lang="en-US" smtClean="0"/>
               <a:t>Fourth level</a:t>
             </a:r>
           </a:p>
           <a:p>
             <a:pPr lvl="4"/>
             <a:r>
-              <a:rPr lang="en-US"/>
+              <a:rPr lang="en-US" smtClean="0"/>
               <a:t>Fifth level</a:t>
             </a:r>
+            <a:endParaRPr lang="en-US"/>
           </a:p>
         </p:txBody>
       </p:sp>
@@ -3481,7 +3708,7 @@
           <a:p>
             <a:fld id="{5BCAD085-E8A6-8845-BD4E-CB4CCA059FC4}" type="datetimeFigureOut">
               <a:rPr lang="en-US" smtClean="0"/>
-              <a:t>8/31/2026</a:t>
+              <a:t>1/27/13</a:t>
             </a:fld>
             <a:endParaRPr lang="en-US"/>
           </a:p>
@@ -3840,7 +4067,7 @@
 </file>
 
 <file path=ppt/slides/slide1.xml><?xml version="1.0" encoding="utf-8"?>
-<p:sld xmlns:a="http://schemas.openxmlformats.org/drawingml/2006/main" xmlns:r="http://schemas.openxmlformats.org/officeDocument/2006/relationships" xmlns:p="http://schemas.openxmlformats.org/presentationml/2006/main">
+<p:sld xmlns:a="http://schemas.openxmlformats.org/drawingml/2006/main" xmlns:p="http://schemas.openxmlformats.org/presentationml/2006/main" xmlns:r="http://schemas.openxmlformats.org/officeDocument/2006/relationships">
   <p:cSld>
     <p:bg>
       <p:bgPr>
@@ -3856,14 +4083,7 @@
         <p:cNvGrpSpPr/>
         <p:nvPr/>
       </p:nvGrpSpPr>
-      <p:grpSpPr>
-        <a:xfrm>
-          <a:off x="0" y="0"/>
-          <a:ext cx="0" cy="0"/>
-          <a:chOff x="0" y="0"/>
-          <a:chExt cx="0" cy="0"/>
-        </a:xfrm>
-      </p:grpSpPr>
+      <p:grpSpPr/>
       <p:sp>
         <p:nvSpPr>
           <p:cNvPr id="2" name="TextBox 1"/>
@@ -3881,7 +4101,7 @@
           <a:noFill/>
         </p:spPr>
         <p:txBody>
-          <a:bodyPr wrap="square" lIns="0" tIns="0" rIns="0" bIns="0">
+          <a:bodyPr wrap="square" lIns="0" rIns="0" tIns="0" bIns="0">
             <a:spAutoFit/>
           </a:bodyPr>
           <a:lstStyle/>
@@ -3924,7 +4144,7 @@
           <a:noFill/>
         </p:spPr>
         <p:txBody>
-          <a:bodyPr wrap="square" lIns="0" tIns="0" rIns="0" bIns="0">
+          <a:bodyPr wrap="square" lIns="0" rIns="0" tIns="0" bIns="0">
             <a:spAutoFit/>
           </a:bodyPr>
           <a:lstStyle/>
@@ -3963,7 +4183,7 @@
           <a:noFill/>
         </p:spPr>
         <p:txBody>
-          <a:bodyPr wrap="square" lIns="0" tIns="0" rIns="0" bIns="0">
+          <a:bodyPr wrap="square" lIns="0" rIns="0" tIns="0" bIns="0">
             <a:spAutoFit/>
           </a:bodyPr>
           <a:lstStyle/>
@@ -4010,7 +4230,7 @@
           <p:nvPr/>
         </p:nvPicPr>
         <p:blipFill>
-          <a:blip r:embed="rId3"/>
+          <a:blip r:embed="rId2"/>
           <a:stretch>
             <a:fillRect/>
           </a:stretch>
@@ -4034,7 +4254,7 @@
 </file>
 
 <file path=ppt/slides/slide2.xml><?xml version="1.0" encoding="utf-8"?>
-<p:sld xmlns:a="http://schemas.openxmlformats.org/drawingml/2006/main" xmlns:r="http://schemas.openxmlformats.org/officeDocument/2006/relationships" xmlns:p="http://schemas.openxmlformats.org/presentationml/2006/main">
+<p:sld xmlns:a="http://schemas.openxmlformats.org/drawingml/2006/main" xmlns:p="http://schemas.openxmlformats.org/presentationml/2006/main" xmlns:r="http://schemas.openxmlformats.org/officeDocument/2006/relationships">
   <p:cSld>
     <p:bg>
       <p:bgPr>
@@ -4050,14 +4270,7 @@
         <p:cNvGrpSpPr/>
         <p:nvPr/>
       </p:nvGrpSpPr>
-      <p:grpSpPr>
-        <a:xfrm>
-          <a:off x="0" y="0"/>
-          <a:ext cx="0" cy="0"/>
-          <a:chOff x="0" y="0"/>
-          <a:chExt cx="0" cy="0"/>
-        </a:xfrm>
-      </p:grpSpPr>
+      <p:grpSpPr/>
       <p:sp>
         <p:nvSpPr>
           <p:cNvPr id="2" name="TextBox 1"/>
@@ -4075,7 +4288,7 @@
           <a:noFill/>
         </p:spPr>
         <p:txBody>
-          <a:bodyPr wrap="square" lIns="0" tIns="0" rIns="0" bIns="0">
+          <a:bodyPr wrap="square" lIns="0" rIns="0" tIns="0" bIns="0">
             <a:spAutoFit/>
           </a:bodyPr>
           <a:lstStyle/>
@@ -4114,7 +4327,7 @@
           <a:noFill/>
         </p:spPr>
         <p:txBody>
-          <a:bodyPr wrap="square" lIns="0" tIns="0" rIns="0" bIns="0">
+          <a:bodyPr wrap="square" lIns="0" rIns="0" tIns="0" bIns="0">
             <a:spAutoFit/>
           </a:bodyPr>
           <a:lstStyle/>
@@ -4220,7 +4433,6 @@
           <a:lstStyle/>
           <a:p>
             <a:pPr algn="ctr"/>
-            <a:endParaRPr/>
           </a:p>
         </p:txBody>
       </p:sp>
@@ -4241,7 +4453,7 @@
           <a:noFill/>
         </p:spPr>
         <p:txBody>
-          <a:bodyPr wrap="square" lIns="0" tIns="0" rIns="0" bIns="0">
+          <a:bodyPr wrap="square" lIns="0" rIns="0" tIns="0" bIns="0">
             <a:spAutoFit/>
           </a:bodyPr>
           <a:lstStyle/>
@@ -4309,7 +4521,6 @@
           <a:lstStyle/>
           <a:p>
             <a:pPr algn="ctr"/>
-            <a:endParaRPr/>
           </a:p>
         </p:txBody>
       </p:sp>
@@ -4330,7 +4541,7 @@
           <a:noFill/>
         </p:spPr>
         <p:txBody>
-          <a:bodyPr wrap="square" lIns="0" tIns="0" rIns="0" bIns="0">
+          <a:bodyPr wrap="square" lIns="0" rIns="0" tIns="0" bIns="0">
             <a:spAutoFit/>
           </a:bodyPr>
           <a:lstStyle/>
@@ -4372,7 +4583,7 @@
           <a:noFill/>
         </p:spPr>
         <p:txBody>
-          <a:bodyPr wrap="square" lIns="0" tIns="0" rIns="0" bIns="0">
+          <a:bodyPr wrap="square" lIns="0" rIns="0" tIns="0" bIns="0">
             <a:spAutoFit/>
           </a:bodyPr>
           <a:lstStyle/>
@@ -4411,7 +4622,7 @@
           <a:noFill/>
         </p:spPr>
         <p:txBody>
-          <a:bodyPr wrap="square" lIns="0" tIns="0" rIns="0" bIns="0">
+          <a:bodyPr wrap="square" lIns="0" rIns="0" tIns="0" bIns="0">
             <a:spAutoFit/>
           </a:bodyPr>
           <a:lstStyle/>
@@ -4450,7 +4661,7 @@
           <a:noFill/>
         </p:spPr>
         <p:txBody>
-          <a:bodyPr wrap="square" lIns="0" tIns="0" rIns="0" bIns="0">
+          <a:bodyPr wrap="square" lIns="0" rIns="0" tIns="0" bIns="0">
             <a:spAutoFit/>
           </a:bodyPr>
           <a:lstStyle/>
@@ -4489,7 +4700,7 @@
           <a:noFill/>
         </p:spPr>
         <p:txBody>
-          <a:bodyPr wrap="square" lIns="0" tIns="0" rIns="0" bIns="0">
+          <a:bodyPr wrap="square" lIns="0" rIns="0" tIns="0" bIns="0">
             <a:spAutoFit/>
           </a:bodyPr>
           <a:lstStyle/>
@@ -4531,7 +4742,7 @@
           <a:noFill/>
         </p:spPr>
         <p:txBody>
-          <a:bodyPr wrap="square" lIns="0" tIns="0" rIns="0" bIns="0">
+          <a:bodyPr wrap="square" lIns="0" rIns="0" tIns="0" bIns="0">
             <a:spAutoFit/>
           </a:bodyPr>
           <a:lstStyle/>
@@ -4570,7 +4781,7 @@
           <a:noFill/>
         </p:spPr>
         <p:txBody>
-          <a:bodyPr wrap="square" lIns="0" tIns="0" rIns="0" bIns="0">
+          <a:bodyPr wrap="square" lIns="0" rIns="0" tIns="0" bIns="0">
             <a:spAutoFit/>
           </a:bodyPr>
           <a:lstStyle/>
@@ -4609,7 +4820,7 @@
           <a:noFill/>
         </p:spPr>
         <p:txBody>
-          <a:bodyPr wrap="square" lIns="0" tIns="0" rIns="0" bIns="0">
+          <a:bodyPr wrap="square" lIns="0" rIns="0" tIns="0" bIns="0">
             <a:spAutoFit/>
           </a:bodyPr>
           <a:lstStyle/>
@@ -4643,7 +4854,7 @@
 </file>
 
 <file path=ppt/slides/slide3.xml><?xml version="1.0" encoding="utf-8"?>
-<p:sld xmlns:a="http://schemas.openxmlformats.org/drawingml/2006/main" xmlns:r="http://schemas.openxmlformats.org/officeDocument/2006/relationships" xmlns:p="http://schemas.openxmlformats.org/presentationml/2006/main">
+<p:sld xmlns:a="http://schemas.openxmlformats.org/drawingml/2006/main" xmlns:p="http://schemas.openxmlformats.org/presentationml/2006/main" xmlns:r="http://schemas.openxmlformats.org/officeDocument/2006/relationships">
   <p:cSld>
     <p:bg>
       <p:bgPr>
@@ -4659,14 +4870,7 @@
         <p:cNvGrpSpPr/>
         <p:nvPr/>
       </p:nvGrpSpPr>
-      <p:grpSpPr>
-        <a:xfrm>
-          <a:off x="0" y="0"/>
-          <a:ext cx="0" cy="0"/>
-          <a:chOff x="0" y="0"/>
-          <a:chExt cx="0" cy="0"/>
-        </a:xfrm>
-      </p:grpSpPr>
+      <p:grpSpPr/>
       <p:sp>
         <p:nvSpPr>
           <p:cNvPr id="2" name="TextBox 1"/>
@@ -4684,7 +4888,7 @@
           <a:noFill/>
         </p:spPr>
         <p:txBody>
-          <a:bodyPr wrap="square" lIns="0" tIns="0" rIns="0" bIns="0">
+          <a:bodyPr wrap="square" lIns="0" rIns="0" tIns="0" bIns="0">
             <a:spAutoFit/>
           </a:bodyPr>
           <a:lstStyle/>
@@ -4747,7 +4951,7 @@
           </a:fontRef>
         </p:style>
         <p:txBody>
-          <a:bodyPr wrap="square" rtlCol="0" anchor="ctr"/>
+          <a:bodyPr rtlCol="0" anchor="ctr" wrap="square"/>
           <a:lstStyle/>
           <a:p>
             <a:pPr algn="ctr"/>
@@ -4805,7 +5009,6 @@
           <a:lstStyle/>
           <a:p>
             <a:pPr algn="ctr"/>
-            <a:endParaRPr/>
           </a:p>
         </p:txBody>
       </p:sp>
@@ -4850,7 +5053,7 @@
           </a:fontRef>
         </p:style>
         <p:txBody>
-          <a:bodyPr wrap="square" rtlCol="0" anchor="ctr"/>
+          <a:bodyPr rtlCol="0" anchor="ctr" wrap="square"/>
           <a:lstStyle/>
           <a:p>
             <a:pPr algn="ctr"/>
@@ -4907,7 +5110,6 @@
           <a:lstStyle/>
           <a:p>
             <a:pPr algn="ctr"/>
-            <a:endParaRPr/>
           </a:p>
         </p:txBody>
       </p:sp>
@@ -4952,7 +5154,7 @@
           </a:fontRef>
         </p:style>
         <p:txBody>
-          <a:bodyPr wrap="square" rtlCol="0" anchor="ctr"/>
+          <a:bodyPr rtlCol="0" anchor="ctr" wrap="square"/>
           <a:lstStyle/>
           <a:p>
             <a:pPr algn="ctr"/>
@@ -5009,7 +5211,6 @@
           <a:lstStyle/>
           <a:p>
             <a:pPr algn="ctr"/>
-            <a:endParaRPr/>
           </a:p>
         </p:txBody>
       </p:sp>
@@ -5054,7 +5255,7 @@
           </a:fontRef>
         </p:style>
         <p:txBody>
-          <a:bodyPr wrap="square" rtlCol="0" anchor="ctr"/>
+          <a:bodyPr rtlCol="0" anchor="ctr" wrap="square"/>
           <a:lstStyle/>
           <a:p>
             <a:pPr algn="ctr"/>
@@ -5111,7 +5312,6 @@
           <a:lstStyle/>
           <a:p>
             <a:pPr algn="ctr"/>
-            <a:endParaRPr/>
           </a:p>
         </p:txBody>
       </p:sp>
@@ -5156,7 +5356,7 @@
           </a:fontRef>
         </p:style>
         <p:txBody>
-          <a:bodyPr wrap="square" rtlCol="0" anchor="ctr"/>
+          <a:bodyPr rtlCol="0" anchor="ctr" wrap="square"/>
           <a:lstStyle/>
           <a:p>
             <a:pPr algn="ctr"/>
@@ -5190,7 +5390,7 @@
           <a:noFill/>
         </p:spPr>
         <p:txBody>
-          <a:bodyPr wrap="square" lIns="0" tIns="0" rIns="0" bIns="0">
+          <a:bodyPr wrap="square" lIns="0" rIns="0" tIns="0" bIns="0">
             <a:spAutoFit/>
           </a:bodyPr>
           <a:lstStyle/>
@@ -5229,7 +5429,7 @@
           <a:noFill/>
         </p:spPr>
         <p:txBody>
-          <a:bodyPr wrap="square" lIns="0" tIns="0" rIns="0" bIns="0">
+          <a:bodyPr wrap="square" lIns="0" rIns="0" tIns="0" bIns="0">
             <a:spAutoFit/>
           </a:bodyPr>
           <a:lstStyle/>
@@ -5268,7 +5468,7 @@
           <a:noFill/>
         </p:spPr>
         <p:txBody>
-          <a:bodyPr wrap="square" lIns="0" tIns="0" rIns="0" bIns="0">
+          <a:bodyPr wrap="square" lIns="0" rIns="0" tIns="0" bIns="0">
             <a:spAutoFit/>
           </a:bodyPr>
           <a:lstStyle/>
@@ -5329,7 +5529,7 @@
           <a:noFill/>
         </p:spPr>
         <p:txBody>
-          <a:bodyPr wrap="square" lIns="0" tIns="0" rIns="0" bIns="0">
+          <a:bodyPr wrap="square" lIns="0" rIns="0" tIns="0" bIns="0">
             <a:spAutoFit/>
           </a:bodyPr>
           <a:lstStyle/>
@@ -5368,7 +5568,7 @@
           <a:noFill/>
         </p:spPr>
         <p:txBody>
-          <a:bodyPr wrap="square" lIns="0" tIns="0" rIns="0" bIns="0">
+          <a:bodyPr wrap="square" lIns="0" rIns="0" tIns="0" bIns="0">
             <a:spAutoFit/>
           </a:bodyPr>
           <a:lstStyle/>
@@ -5410,7 +5610,7 @@
           <a:noFill/>
         </p:spPr>
         <p:txBody>
-          <a:bodyPr wrap="square" lIns="0" tIns="0" rIns="0" bIns="0">
+          <a:bodyPr wrap="square" lIns="0" rIns="0" tIns="0" bIns="0">
             <a:spAutoFit/>
           </a:bodyPr>
           <a:lstStyle/>
@@ -5449,7 +5649,7 @@
           <a:noFill/>
         </p:spPr>
         <p:txBody>
-          <a:bodyPr wrap="square" lIns="0" tIns="0" rIns="0" bIns="0">
+          <a:bodyPr wrap="square" lIns="0" rIns="0" tIns="0" bIns="0">
             <a:spAutoFit/>
           </a:bodyPr>
           <a:lstStyle/>
@@ -5483,7 +5683,7 @@
 </file>
 
 <file path=ppt/slides/slide4.xml><?xml version="1.0" encoding="utf-8"?>
-<p:sld xmlns:a="http://schemas.openxmlformats.org/drawingml/2006/main" xmlns:r="http://schemas.openxmlformats.org/officeDocument/2006/relationships" xmlns:p="http://schemas.openxmlformats.org/presentationml/2006/main">
+<p:sld xmlns:a="http://schemas.openxmlformats.org/drawingml/2006/main" xmlns:p="http://schemas.openxmlformats.org/presentationml/2006/main" xmlns:r="http://schemas.openxmlformats.org/officeDocument/2006/relationships">
   <p:cSld>
     <p:bg>
       <p:bgPr>
@@ -5499,14 +5699,7 @@
         <p:cNvGrpSpPr/>
         <p:nvPr/>
       </p:nvGrpSpPr>
-      <p:grpSpPr>
-        <a:xfrm>
-          <a:off x="0" y="0"/>
-          <a:ext cx="0" cy="0"/>
-          <a:chOff x="0" y="0"/>
-          <a:chExt cx="0" cy="0"/>
-        </a:xfrm>
-      </p:grpSpPr>
+      <p:grpSpPr/>
       <p:sp>
         <p:nvSpPr>
           <p:cNvPr id="2" name="TextBox 1"/>
@@ -5524,7 +5717,7 @@
           <a:noFill/>
         </p:spPr>
         <p:txBody>
-          <a:bodyPr wrap="square" lIns="0" tIns="0" rIns="0" bIns="0">
+          <a:bodyPr wrap="square" lIns="0" rIns="0" tIns="0" bIns="0">
             <a:spAutoFit/>
           </a:bodyPr>
           <a:lstStyle/>
@@ -5555,7 +5748,7 @@
           <p:nvPr/>
         </p:nvPicPr>
         <p:blipFill>
-          <a:blip r:embed="rId3"/>
+          <a:blip r:embed="rId2"/>
           <a:stretch>
             <a:fillRect/>
           </a:stretch>
@@ -5587,7 +5780,7 @@
           <a:noFill/>
         </p:spPr>
         <p:txBody>
-          <a:bodyPr wrap="square" lIns="0" tIns="0" rIns="0" bIns="0">
+          <a:bodyPr wrap="square" lIns="0" rIns="0" tIns="0" bIns="0">
             <a:spAutoFit/>
           </a:bodyPr>
           <a:lstStyle/>
@@ -5648,7 +5841,7 @@
           <a:noFill/>
         </p:spPr>
         <p:txBody>
-          <a:bodyPr wrap="square" lIns="0" tIns="0" rIns="0" bIns="0">
+          <a:bodyPr wrap="square" lIns="0" rIns="0" tIns="0" bIns="0">
             <a:spAutoFit/>
           </a:bodyPr>
           <a:lstStyle/>
@@ -5687,7 +5880,7 @@
           <a:noFill/>
         </p:spPr>
         <p:txBody>
-          <a:bodyPr wrap="square" lIns="0" tIns="0" rIns="0" bIns="0">
+          <a:bodyPr wrap="square" lIns="0" rIns="0" tIns="0" bIns="0">
             <a:spAutoFit/>
           </a:bodyPr>
           <a:lstStyle/>
@@ -5721,7 +5914,7 @@
 </file>
 
 <file path=ppt/slides/slide5.xml><?xml version="1.0" encoding="utf-8"?>
-<p:sld xmlns:a="http://schemas.openxmlformats.org/drawingml/2006/main" xmlns:r="http://schemas.openxmlformats.org/officeDocument/2006/relationships" xmlns:p="http://schemas.openxmlformats.org/presentationml/2006/main">
+<p:sld xmlns:a="http://schemas.openxmlformats.org/drawingml/2006/main" xmlns:p="http://schemas.openxmlformats.org/presentationml/2006/main" xmlns:r="http://schemas.openxmlformats.org/officeDocument/2006/relationships">
   <p:cSld>
     <p:bg>
       <p:bgPr>
@@ -5737,14 +5930,7 @@
         <p:cNvGrpSpPr/>
         <p:nvPr/>
       </p:nvGrpSpPr>
-      <p:grpSpPr>
-        <a:xfrm>
-          <a:off x="0" y="0"/>
-          <a:ext cx="0" cy="0"/>
-          <a:chOff x="0" y="0"/>
-          <a:chExt cx="0" cy="0"/>
-        </a:xfrm>
-      </p:grpSpPr>
+      <p:grpSpPr/>
       <p:sp>
         <p:nvSpPr>
           <p:cNvPr id="2" name="TextBox 1"/>
@@ -5762,7 +5948,7 @@
           <a:noFill/>
         </p:spPr>
         <p:txBody>
-          <a:bodyPr wrap="square" lIns="0" tIns="0" rIns="0" bIns="0">
+          <a:bodyPr wrap="square" lIns="0" rIns="0" tIns="0" bIns="0">
             <a:spAutoFit/>
           </a:bodyPr>
           <a:lstStyle/>
@@ -5779,7 +5965,7 @@
                 </a:solidFill>
                 <a:latin typeface="Cambria"/>
               </a:rPr>
-              <a:t>Under fading, the gain disappears</a:t>
+              <a:t>Under fading, the gain is small</a:t>
             </a:r>
           </a:p>
         </p:txBody>
@@ -5803,34 +5989,10 @@
                 <a:tableStyleId>{5C22544A-7EE6-4342-B048-85BDC9FD1C3A}</a:tableStyleId>
               </a:tblPr>
               <a:tblGrid>
-                <a:gridCol w="3383280">
-                  <a:extLst>
-                    <a:ext uri="{9D8B030D-6E8A-4147-A177-3AD203B41FA5}">
-                      <a16:colId xmlns:a16="http://schemas.microsoft.com/office/drawing/2014/main" val="20000"/>
-                    </a:ext>
-                  </a:extLst>
-                </a:gridCol>
-                <a:gridCol w="1188720">
-                  <a:extLst>
-                    <a:ext uri="{9D8B030D-6E8A-4147-A177-3AD203B41FA5}">
-                      <a16:colId xmlns:a16="http://schemas.microsoft.com/office/drawing/2014/main" val="20001"/>
-                    </a:ext>
-                  </a:extLst>
-                </a:gridCol>
-                <a:gridCol w="1188720">
-                  <a:extLst>
-                    <a:ext uri="{9D8B030D-6E8A-4147-A177-3AD203B41FA5}">
-                      <a16:colId xmlns:a16="http://schemas.microsoft.com/office/drawing/2014/main" val="20002"/>
-                    </a:ext>
-                  </a:extLst>
-                </a:gridCol>
-                <a:gridCol w="1188720">
-                  <a:extLst>
-                    <a:ext uri="{9D8B030D-6E8A-4147-A177-3AD203B41FA5}">
-                      <a16:colId xmlns:a16="http://schemas.microsoft.com/office/drawing/2014/main" val="20003"/>
-                    </a:ext>
-                  </a:extLst>
-                </a:gridCol>
+                <a:gridCol w="3383280"/>
+                <a:gridCol w="1188720"/>
+                <a:gridCol w="1188720"/>
+                <a:gridCol w="1188720"/>
               </a:tblGrid>
               <a:tr h="457200">
                 <a:tc>
@@ -5925,11 +6087,6 @@
                     </a:solidFill>
                   </a:tcPr>
                 </a:tc>
-                <a:extLst>
-                  <a:ext uri="{0D108BD9-81ED-4DB2-BD59-A6C34878D82A}">
-                    <a16:rowId xmlns:a16="http://schemas.microsoft.com/office/drawing/2014/main" val="10000"/>
-                  </a:ext>
-                </a:extLst>
               </a:tr>
               <a:tr h="457200">
                 <a:tc>
@@ -6024,11 +6181,6 @@
                     </a:solidFill>
                   </a:tcPr>
                 </a:tc>
-                <a:extLst>
-                  <a:ext uri="{0D108BD9-81ED-4DB2-BD59-A6C34878D82A}">
-                    <a16:rowId xmlns:a16="http://schemas.microsoft.com/office/drawing/2014/main" val="10001"/>
-                  </a:ext>
-                </a:extLst>
               </a:tr>
               <a:tr h="457200">
                 <a:tc>
@@ -6123,11 +6275,6 @@
                     </a:solidFill>
                   </a:tcPr>
                 </a:tc>
-                <a:extLst>
-                  <a:ext uri="{0D108BD9-81ED-4DB2-BD59-A6C34878D82A}">
-                    <a16:rowId xmlns:a16="http://schemas.microsoft.com/office/drawing/2014/main" val="10002"/>
-                  </a:ext>
-                </a:extLst>
               </a:tr>
               <a:tr h="457200">
                 <a:tc>
@@ -6222,11 +6369,6 @@
                     </a:solidFill>
                   </a:tcPr>
                 </a:tc>
-                <a:extLst>
-                  <a:ext uri="{0D108BD9-81ED-4DB2-BD59-A6C34878D82A}">
-                    <a16:rowId xmlns:a16="http://schemas.microsoft.com/office/drawing/2014/main" val="10003"/>
-                  </a:ext>
-                </a:extLst>
               </a:tr>
               <a:tr h="457200">
                 <a:tc>
@@ -6321,11 +6463,6 @@
                     </a:solidFill>
                   </a:tcPr>
                 </a:tc>
-                <a:extLst>
-                  <a:ext uri="{0D108BD9-81ED-4DB2-BD59-A6C34878D82A}">
-                    <a16:rowId xmlns:a16="http://schemas.microsoft.com/office/drawing/2014/main" val="10004"/>
-                  </a:ext>
-                </a:extLst>
               </a:tr>
               <a:tr h="457200">
                 <a:tc>
@@ -6420,11 +6557,6 @@
                     </a:solidFill>
                   </a:tcPr>
                 </a:tc>
-                <a:extLst>
-                  <a:ext uri="{0D108BD9-81ED-4DB2-BD59-A6C34878D82A}">
-                    <a16:rowId xmlns:a16="http://schemas.microsoft.com/office/drawing/2014/main" val="10005"/>
-                  </a:ext>
-                </a:extLst>
               </a:tr>
             </a:tbl>
           </a:graphicData>
@@ -6447,7 +6579,7 @@
           <a:noFill/>
         </p:spPr>
         <p:txBody>
-          <a:bodyPr wrap="square" lIns="0" tIns="0" rIns="0" bIns="0">
+          <a:bodyPr wrap="square" lIns="0" rIns="0" tIns="0" bIns="0">
             <a:spAutoFit/>
           </a:bodyPr>
           <a:lstStyle/>
@@ -6486,7 +6618,7 @@
           <a:noFill/>
         </p:spPr>
         <p:txBody>
-          <a:bodyPr wrap="square" lIns="0" tIns="0" rIns="0" bIns="0">
+          <a:bodyPr wrap="square" lIns="0" rIns="0" tIns="0" bIns="0">
             <a:spAutoFit/>
           </a:bodyPr>
           <a:lstStyle/>
@@ -6525,7 +6657,7 @@
           <a:noFill/>
         </p:spPr>
         <p:txBody>
-          <a:bodyPr wrap="square" lIns="0" tIns="0" rIns="0" bIns="0">
+          <a:bodyPr wrap="square" lIns="0" rIns="0" tIns="0" bIns="0">
             <a:spAutoFit/>
           </a:bodyPr>
           <a:lstStyle/>
@@ -6567,7 +6699,7 @@
           <a:noFill/>
         </p:spPr>
         <p:txBody>
-          <a:bodyPr wrap="square" lIns="0" tIns="0" rIns="0" bIns="0">
+          <a:bodyPr wrap="square" lIns="0" rIns="0" tIns="0" bIns="0">
             <a:spAutoFit/>
           </a:bodyPr>
           <a:lstStyle/>
@@ -6606,7 +6738,7 @@
           <a:noFill/>
         </p:spPr>
         <p:txBody>
-          <a:bodyPr wrap="square" lIns="0" tIns="0" rIns="0" bIns="0">
+          <a:bodyPr wrap="square" lIns="0" rIns="0" tIns="0" bIns="0">
             <a:spAutoFit/>
           </a:bodyPr>
           <a:lstStyle/>
@@ -6648,7 +6780,7 @@
           <a:noFill/>
         </p:spPr>
         <p:txBody>
-          <a:bodyPr wrap="square" lIns="0" tIns="0" rIns="0" bIns="0">
+          <a:bodyPr wrap="square" lIns="0" rIns="0" tIns="0" bIns="0">
             <a:spAutoFit/>
           </a:bodyPr>
           <a:lstStyle/>
@@ -6682,7 +6814,7 @@
 </file>
 
 <file path=ppt/slides/slide6.xml><?xml version="1.0" encoding="utf-8"?>
-<p:sld xmlns:a="http://schemas.openxmlformats.org/drawingml/2006/main" xmlns:r="http://schemas.openxmlformats.org/officeDocument/2006/relationships" xmlns:p="http://schemas.openxmlformats.org/presentationml/2006/main">
+<p:sld xmlns:a="http://schemas.openxmlformats.org/drawingml/2006/main" xmlns:p="http://schemas.openxmlformats.org/presentationml/2006/main" xmlns:r="http://schemas.openxmlformats.org/officeDocument/2006/relationships">
   <p:cSld>
     <p:bg>
       <p:bgPr>
@@ -6698,14 +6830,7 @@
         <p:cNvGrpSpPr/>
         <p:nvPr/>
       </p:nvGrpSpPr>
-      <p:grpSpPr>
-        <a:xfrm>
-          <a:off x="0" y="0"/>
-          <a:ext cx="0" cy="0"/>
-          <a:chOff x="0" y="0"/>
-          <a:chExt cx="0" cy="0"/>
-        </a:xfrm>
-      </p:grpSpPr>
+      <p:grpSpPr/>
       <p:sp>
         <p:nvSpPr>
           <p:cNvPr id="2" name="TextBox 1"/>
@@ -6723,7 +6848,7 @@
           <a:noFill/>
         </p:spPr>
         <p:txBody>
-          <a:bodyPr wrap="square" lIns="0" tIns="0" rIns="0" bIns="0">
+          <a:bodyPr wrap="square" lIns="0" rIns="0" tIns="0" bIns="0">
             <a:spAutoFit/>
           </a:bodyPr>
           <a:lstStyle/>
@@ -6754,7 +6879,7 @@
           <p:nvPr/>
         </p:nvPicPr>
         <p:blipFill>
-          <a:blip r:embed="rId3"/>
+          <a:blip r:embed="rId2"/>
           <a:stretch>
             <a:fillRect/>
           </a:stretch>
@@ -6786,7 +6911,7 @@
           <a:noFill/>
         </p:spPr>
         <p:txBody>
-          <a:bodyPr wrap="square" lIns="0" tIns="0" rIns="0" bIns="0">
+          <a:bodyPr wrap="square" lIns="0" rIns="0" tIns="0" bIns="0">
             <a:spAutoFit/>
           </a:bodyPr>
           <a:lstStyle/>
@@ -6847,7 +6972,7 @@
           <a:noFill/>
         </p:spPr>
         <p:txBody>
-          <a:bodyPr wrap="square" lIns="0" tIns="0" rIns="0" bIns="0">
+          <a:bodyPr wrap="square" lIns="0" rIns="0" tIns="0" bIns="0">
             <a:spAutoFit/>
           </a:bodyPr>
           <a:lstStyle/>
@@ -6886,7 +7011,7 @@
           <a:noFill/>
         </p:spPr>
         <p:txBody>
-          <a:bodyPr wrap="square" lIns="0" tIns="0" rIns="0" bIns="0">
+          <a:bodyPr wrap="square" lIns="0" rIns="0" tIns="0" bIns="0">
             <a:spAutoFit/>
           </a:bodyPr>
           <a:lstStyle/>
@@ -6928,7 +7053,7 @@
           <a:noFill/>
         </p:spPr>
         <p:txBody>
-          <a:bodyPr wrap="square" lIns="0" tIns="0" rIns="0" bIns="0">
+          <a:bodyPr wrap="square" lIns="0" rIns="0" tIns="0" bIns="0">
             <a:spAutoFit/>
           </a:bodyPr>
           <a:lstStyle/>
@@ -6967,7 +7092,7 @@
           <a:noFill/>
         </p:spPr>
         <p:txBody>
-          <a:bodyPr wrap="square" lIns="0" tIns="0" rIns="0" bIns="0">
+          <a:bodyPr wrap="square" lIns="0" rIns="0" tIns="0" bIns="0">
             <a:spAutoFit/>
           </a:bodyPr>
           <a:lstStyle/>
@@ -7001,7 +7126,7 @@
 </file>
 
 <file path=ppt/slides/slide7.xml><?xml version="1.0" encoding="utf-8"?>
-<p:sld xmlns:a="http://schemas.openxmlformats.org/drawingml/2006/main" xmlns:r="http://schemas.openxmlformats.org/officeDocument/2006/relationships" xmlns:p="http://schemas.openxmlformats.org/presentationml/2006/main">
+<p:sld xmlns:a="http://schemas.openxmlformats.org/drawingml/2006/main" xmlns:p="http://schemas.openxmlformats.org/presentationml/2006/main" xmlns:r="http://schemas.openxmlformats.org/officeDocument/2006/relationships">
   <p:cSld>
     <p:bg>
       <p:bgPr>
@@ -7017,14 +7142,7 @@
         <p:cNvGrpSpPr/>
         <p:nvPr/>
       </p:nvGrpSpPr>
-      <p:grpSpPr>
-        <a:xfrm>
-          <a:off x="0" y="0"/>
-          <a:ext cx="0" cy="0"/>
-          <a:chOff x="0" y="0"/>
-          <a:chExt cx="0" cy="0"/>
-        </a:xfrm>
-      </p:grpSpPr>
+      <p:grpSpPr/>
       <p:sp>
         <p:nvSpPr>
           <p:cNvPr id="2" name="TextBox 1"/>
@@ -7042,7 +7160,7 @@
           <a:noFill/>
         </p:spPr>
         <p:txBody>
-          <a:bodyPr wrap="square" lIns="0" tIns="0" rIns="0" bIns="0">
+          <a:bodyPr wrap="square" lIns="0" rIns="0" tIns="0" bIns="0">
             <a:spAutoFit/>
           </a:bodyPr>
           <a:lstStyle/>
@@ -7081,7 +7199,7 @@
           <a:noFill/>
         </p:spPr>
         <p:txBody>
-          <a:bodyPr wrap="square" lIns="0" tIns="0" rIns="0" bIns="0">
+          <a:bodyPr wrap="square" lIns="0" rIns="0" tIns="0" bIns="0">
             <a:spAutoFit/>
           </a:bodyPr>
           <a:lstStyle/>
@@ -7120,7 +7238,7 @@
           <a:noFill/>
         </p:spPr>
         <p:txBody>
-          <a:bodyPr wrap="square" lIns="0" tIns="0" rIns="0" bIns="0">
+          <a:bodyPr wrap="square" lIns="0" rIns="0" tIns="0" bIns="0">
             <a:spAutoFit/>
           </a:bodyPr>
           <a:lstStyle/>
@@ -7159,7 +7277,7 @@
           <a:noFill/>
         </p:spPr>
         <p:txBody>
-          <a:bodyPr wrap="square" lIns="0" tIns="0" rIns="0" bIns="0">
+          <a:bodyPr wrap="square" lIns="0" rIns="0" tIns="0" bIns="0">
             <a:spAutoFit/>
           </a:bodyPr>
           <a:lstStyle/>
@@ -7198,7 +7316,7 @@
           <a:noFill/>
         </p:spPr>
         <p:txBody>
-          <a:bodyPr wrap="square" lIns="0" tIns="0" rIns="0" bIns="0">
+          <a:bodyPr wrap="square" lIns="0" rIns="0" tIns="0" bIns="0">
             <a:spAutoFit/>
           </a:bodyPr>
           <a:lstStyle/>
@@ -7240,7 +7358,7 @@
           <a:noFill/>
         </p:spPr>
         <p:txBody>
-          <a:bodyPr wrap="square" lIns="0" tIns="0" rIns="0" bIns="0">
+          <a:bodyPr wrap="square" lIns="0" rIns="0" tIns="0" bIns="0">
             <a:spAutoFit/>
           </a:bodyPr>
           <a:lstStyle/>
@@ -7279,7 +7397,7 @@
           <a:noFill/>
         </p:spPr>
         <p:txBody>
-          <a:bodyPr wrap="square" lIns="0" tIns="0" rIns="0" bIns="0">
+          <a:bodyPr wrap="square" lIns="0" rIns="0" tIns="0" bIns="0">
             <a:spAutoFit/>
           </a:bodyPr>
           <a:lstStyle/>
@@ -7318,7 +7436,7 @@
           <a:noFill/>
         </p:spPr>
         <p:txBody>
-          <a:bodyPr wrap="square" lIns="0" tIns="0" rIns="0" bIns="0">
+          <a:bodyPr wrap="square" lIns="0" rIns="0" tIns="0" bIns="0">
             <a:spAutoFit/>
           </a:bodyPr>
           <a:lstStyle/>
@@ -7386,7 +7504,6 @@
           <a:lstStyle/>
           <a:p>
             <a:pPr algn="ctr"/>
-            <a:endParaRPr/>
           </a:p>
         </p:txBody>
       </p:sp>
@@ -7407,7 +7524,7 @@
           <a:noFill/>
         </p:spPr>
         <p:txBody>
-          <a:bodyPr wrap="square" lIns="0" tIns="0" rIns="0" bIns="0">
+          <a:bodyPr wrap="square" lIns="0" rIns="0" tIns="0" bIns="0">
             <a:spAutoFit/>
           </a:bodyPr>
           <a:lstStyle/>
@@ -7446,7 +7563,7 @@
           <a:noFill/>
         </p:spPr>
         <p:txBody>
-          <a:bodyPr wrap="square" lIns="0" tIns="0" rIns="0" bIns="0">
+          <a:bodyPr wrap="square" lIns="0" rIns="0" tIns="0" bIns="0">
             <a:spAutoFit/>
           </a:bodyPr>
           <a:lstStyle/>
@@ -7518,7 +7635,7 @@
 </file>
 
 <file path=ppt/slides/slide8.xml><?xml version="1.0" encoding="utf-8"?>
-<p:sld xmlns:a="http://schemas.openxmlformats.org/drawingml/2006/main" xmlns:r="http://schemas.openxmlformats.org/officeDocument/2006/relationships" xmlns:p="http://schemas.openxmlformats.org/presentationml/2006/main">
+<p:sld xmlns:a="http://schemas.openxmlformats.org/drawingml/2006/main" xmlns:p="http://schemas.openxmlformats.org/presentationml/2006/main" xmlns:r="http://schemas.openxmlformats.org/officeDocument/2006/relationships">
   <p:cSld>
     <p:bg>
       <p:bgPr>
@@ -7534,14 +7651,7 @@
         <p:cNvGrpSpPr/>
         <p:nvPr/>
       </p:nvGrpSpPr>
-      <p:grpSpPr>
-        <a:xfrm>
-          <a:off x="0" y="0"/>
-          <a:ext cx="0" cy="0"/>
-          <a:chOff x="0" y="0"/>
-          <a:chExt cx="0" cy="0"/>
-        </a:xfrm>
-      </p:grpSpPr>
+      <p:grpSpPr/>
       <p:sp>
         <p:nvSpPr>
           <p:cNvPr id="2" name="TextBox 1"/>
@@ -7559,7 +7669,7 @@
           <a:noFill/>
         </p:spPr>
         <p:txBody>
-          <a:bodyPr wrap="square" lIns="0" tIns="0" rIns="0" bIns="0">
+          <a:bodyPr wrap="square" lIns="0" rIns="0" tIns="0" bIns="0">
             <a:spAutoFit/>
           </a:bodyPr>
           <a:lstStyle/>
@@ -7598,7 +7708,7 @@
           <a:noFill/>
         </p:spPr>
         <p:txBody>
-          <a:bodyPr wrap="square" lIns="0" tIns="0" rIns="0" bIns="0">
+          <a:bodyPr wrap="square" lIns="0" rIns="0" tIns="0" bIns="0">
             <a:spAutoFit/>
           </a:bodyPr>
           <a:lstStyle/>
@@ -7637,7 +7747,7 @@
           <a:noFill/>
         </p:spPr>
         <p:txBody>
-          <a:bodyPr wrap="square" lIns="0" tIns="0" rIns="0" bIns="0">
+          <a:bodyPr wrap="square" lIns="0" rIns="0" tIns="0" bIns="0">
             <a:spAutoFit/>
           </a:bodyPr>
           <a:lstStyle/>
@@ -7676,7 +7786,7 @@
           <a:noFill/>
         </p:spPr>
         <p:txBody>
-          <a:bodyPr wrap="square" lIns="0" tIns="0" rIns="0" bIns="0">
+          <a:bodyPr wrap="square" lIns="0" rIns="0" tIns="0" bIns="0">
             <a:spAutoFit/>
           </a:bodyPr>
           <a:lstStyle/>
@@ -7715,7 +7825,7 @@
           <a:noFill/>
         </p:spPr>
         <p:txBody>
-          <a:bodyPr wrap="square" lIns="0" tIns="0" rIns="0" bIns="0">
+          <a:bodyPr wrap="square" lIns="0" rIns="0" tIns="0" bIns="0">
             <a:spAutoFit/>
           </a:bodyPr>
           <a:lstStyle/>
@@ -7757,7 +7867,7 @@
           <a:noFill/>
         </p:spPr>
         <p:txBody>
-          <a:bodyPr wrap="square" lIns="0" tIns="0" rIns="0" bIns="0">
+          <a:bodyPr wrap="square" lIns="0" rIns="0" tIns="0" bIns="0">
             <a:spAutoFit/>
           </a:bodyPr>
           <a:lstStyle/>
@@ -7796,7 +7906,7 @@
           <a:noFill/>
         </p:spPr>
         <p:txBody>
-          <a:bodyPr wrap="square" lIns="0" tIns="0" rIns="0" bIns="0">
+          <a:bodyPr wrap="square" lIns="0" rIns="0" tIns="0" bIns="0">
             <a:spAutoFit/>
           </a:bodyPr>
           <a:lstStyle/>
@@ -7835,7 +7945,7 @@
           <a:noFill/>
         </p:spPr>
         <p:txBody>
-          <a:bodyPr wrap="square" lIns="0" tIns="0" rIns="0" bIns="0">
+          <a:bodyPr wrap="square" lIns="0" rIns="0" tIns="0" bIns="0">
             <a:spAutoFit/>
           </a:bodyPr>
           <a:lstStyle/>
@@ -7903,7 +8013,6 @@
           <a:lstStyle/>
           <a:p>
             <a:pPr algn="ctr"/>
-            <a:endParaRPr/>
           </a:p>
         </p:txBody>
       </p:sp>
@@ -7924,7 +8033,7 @@
           <a:noFill/>
         </p:spPr>
         <p:txBody>
-          <a:bodyPr wrap="square" lIns="0" tIns="0" rIns="0" bIns="0">
+          <a:bodyPr wrap="square" lIns="0" rIns="0" tIns="0" bIns="0">
             <a:spAutoFit/>
           </a:bodyPr>
           <a:lstStyle/>
@@ -7963,7 +8072,7 @@
           <a:noFill/>
         </p:spPr>
         <p:txBody>
-          <a:bodyPr wrap="square" lIns="0" tIns="0" rIns="0" bIns="0">
+          <a:bodyPr wrap="square" lIns="0" rIns="0" tIns="0" bIns="0">
             <a:spAutoFit/>
           </a:bodyPr>
           <a:lstStyle/>
@@ -8035,7 +8144,7 @@
 </file>
 
 <file path=ppt/slides/slide9.xml><?xml version="1.0" encoding="utf-8"?>
-<p:sld xmlns:a="http://schemas.openxmlformats.org/drawingml/2006/main" xmlns:r="http://schemas.openxmlformats.org/officeDocument/2006/relationships" xmlns:p="http://schemas.openxmlformats.org/presentationml/2006/main">
+<p:sld xmlns:a="http://schemas.openxmlformats.org/drawingml/2006/main" xmlns:p="http://schemas.openxmlformats.org/presentationml/2006/main" xmlns:r="http://schemas.openxmlformats.org/officeDocument/2006/relationships">
   <p:cSld>
     <p:bg>
       <p:bgPr>
@@ -8051,14 +8160,7 @@
         <p:cNvGrpSpPr/>
         <p:nvPr/>
       </p:nvGrpSpPr>
-      <p:grpSpPr>
-        <a:xfrm>
-          <a:off x="0" y="0"/>
-          <a:ext cx="0" cy="0"/>
-          <a:chOff x="0" y="0"/>
-          <a:chExt cx="0" cy="0"/>
-        </a:xfrm>
-      </p:grpSpPr>
+      <p:grpSpPr/>
       <p:sp>
         <p:nvSpPr>
           <p:cNvPr id="2" name="TextBox 1"/>
@@ -8076,7 +8178,7 @@
           <a:noFill/>
         </p:spPr>
         <p:txBody>
-          <a:bodyPr wrap="square" lIns="0" tIns="0" rIns="0" bIns="0">
+          <a:bodyPr wrap="square" lIns="0" rIns="0" tIns="0" bIns="0">
             <a:spAutoFit/>
           </a:bodyPr>
           <a:lstStyle/>
@@ -8115,7 +8217,7 @@
           <a:noFill/>
         </p:spPr>
         <p:txBody>
-          <a:bodyPr wrap="square" lIns="0" tIns="0" rIns="0" bIns="0">
+          <a:bodyPr wrap="square" lIns="0" rIns="0" tIns="0" bIns="0">
             <a:spAutoFit/>
           </a:bodyPr>
           <a:lstStyle/>
@@ -8202,7 +8304,6 @@
           <a:lstStyle/>
           <a:p>
             <a:pPr algn="ctr"/>
-            <a:endParaRPr/>
           </a:p>
         </p:txBody>
       </p:sp>
@@ -8223,7 +8324,7 @@
           <a:noFill/>
         </p:spPr>
         <p:txBody>
-          <a:bodyPr wrap="square" lIns="0" tIns="0" rIns="0" bIns="0">
+          <a:bodyPr wrap="square" lIns="0" rIns="0" tIns="0" bIns="0">
             <a:spAutoFit/>
           </a:bodyPr>
           <a:lstStyle/>
@@ -8284,7 +8385,7 @@
           <a:noFill/>
         </p:spPr>
         <p:txBody>
-          <a:bodyPr wrap="square" lIns="0" tIns="0" rIns="0" bIns="0">
+          <a:bodyPr wrap="square" lIns="0" rIns="0" tIns="0" bIns="0">
             <a:spAutoFit/>
           </a:bodyPr>
           <a:lstStyle/>
@@ -8645,44 +8746,44 @@
         <a:sysClr val="window" lastClr="FFFFFF"/>
       </a:lt1>
       <a:dk2>
-        <a:srgbClr val="0E2841"/>
+        <a:srgbClr val="1F497D"/>
       </a:dk2>
       <a:lt2>
-        <a:srgbClr val="E8E8E8"/>
+        <a:srgbClr val="EEECE1"/>
       </a:lt2>
       <a:accent1>
-        <a:srgbClr val="156082"/>
+        <a:srgbClr val="4F81BD"/>
       </a:accent1>
       <a:accent2>
-        <a:srgbClr val="E97132"/>
+        <a:srgbClr val="C0504D"/>
       </a:accent2>
       <a:accent3>
-        <a:srgbClr val="196B24"/>
+        <a:srgbClr val="9BBB59"/>
       </a:accent3>
       <a:accent4>
-        <a:srgbClr val="0F9ED5"/>
+        <a:srgbClr val="8064A2"/>
       </a:accent4>
       <a:accent5>
-        <a:srgbClr val="A02B93"/>
+        <a:srgbClr val="4BACC6"/>
       </a:accent5>
       <a:accent6>
-        <a:srgbClr val="4EA72E"/>
+        <a:srgbClr val="F79646"/>
       </a:accent6>
       <a:hlink>
-        <a:srgbClr val="467886"/>
+        <a:srgbClr val="0000FF"/>
       </a:hlink>
       <a:folHlink>
-        <a:srgbClr val="96607D"/>
+        <a:srgbClr val="800080"/>
       </a:folHlink>
     </a:clrScheme>
     <a:fontScheme name="Office">
       <a:majorFont>
-        <a:latin typeface="Aptos Display" panose="02110004020202020204"/>
+        <a:latin typeface="Calibri"/>
         <a:ea typeface=""/>
         <a:cs typeface=""/>
-        <a:font script="Jpan" typeface="游ゴシック Light"/>
+        <a:font script="Jpan" typeface="ＭＳ Ｐゴシック"/>
         <a:font script="Hang" typeface="맑은 고딕"/>
-        <a:font script="Hans" typeface="等线 Light"/>
+        <a:font script="Hans" typeface="宋体"/>
         <a:font script="Hant" typeface="新細明體"/>
         <a:font script="Arab" typeface="Times New Roman"/>
         <a:font script="Hebr" typeface="Times New Roman"/>
@@ -8710,31 +8811,14 @@
         <a:font script="Viet" typeface="Times New Roman"/>
         <a:font script="Uigh" typeface="Microsoft Uighur"/>
         <a:font script="Geor" typeface="Sylfaen"/>
-        <a:font script="Armn" typeface="Arial"/>
-        <a:font script="Bugi" typeface="Leelawadee UI"/>
-        <a:font script="Bopo" typeface="Microsoft JhengHei"/>
-        <a:font script="Java" typeface="Javanese Text"/>
-        <a:font script="Lisu" typeface="Segoe UI"/>
-        <a:font script="Mymr" typeface="Myanmar Text"/>
-        <a:font script="Nkoo" typeface="Ebrima"/>
-        <a:font script="Olck" typeface="Nirmala UI"/>
-        <a:font script="Osma" typeface="Ebrima"/>
-        <a:font script="Phag" typeface="Phagspa"/>
-        <a:font script="Syrn" typeface="Estrangelo Edessa"/>
-        <a:font script="Syrj" typeface="Estrangelo Edessa"/>
-        <a:font script="Syre" typeface="Estrangelo Edessa"/>
-        <a:font script="Sora" typeface="Nirmala UI"/>
-        <a:font script="Tale" typeface="Microsoft Tai Le"/>
-        <a:font script="Talu" typeface="Microsoft New Tai Lue"/>
-        <a:font script="Tfng" typeface="Ebrima"/>
       </a:majorFont>
       <a:minorFont>
-        <a:latin typeface="Aptos" panose="02110004020202020204"/>
+        <a:latin typeface="Calibri"/>
         <a:ea typeface=""/>
         <a:cs typeface=""/>
-        <a:font script="Jpan" typeface="游ゴシック"/>
+        <a:font script="Jpan" typeface="ＭＳ Ｐゴシック"/>
         <a:font script="Hang" typeface="맑은 고딕"/>
-        <a:font script="Hans" typeface="等线"/>
+        <a:font script="Hans" typeface="宋体"/>
         <a:font script="Hant" typeface="新細明體"/>
         <a:font script="Arab" typeface="Arial"/>
         <a:font script="Hebr" typeface="Arial"/>
@@ -8762,23 +8846,6 @@
         <a:font script="Viet" typeface="Arial"/>
         <a:font script="Uigh" typeface="Microsoft Uighur"/>
         <a:font script="Geor" typeface="Sylfaen"/>
-        <a:font script="Armn" typeface="Arial"/>
-        <a:font script="Bugi" typeface="Leelawadee UI"/>
-        <a:font script="Bopo" typeface="Microsoft JhengHei"/>
-        <a:font script="Java" typeface="Javanese Text"/>
-        <a:font script="Lisu" typeface="Segoe UI"/>
-        <a:font script="Mymr" typeface="Myanmar Text"/>
-        <a:font script="Nkoo" typeface="Ebrima"/>
-        <a:font script="Olck" typeface="Nirmala UI"/>
-        <a:font script="Osma" typeface="Ebrima"/>
-        <a:font script="Phag" typeface="Phagspa"/>
-        <a:font script="Syrn" typeface="Estrangelo Edessa"/>
-        <a:font script="Syrj" typeface="Estrangelo Edessa"/>
-        <a:font script="Syre" typeface="Estrangelo Edessa"/>
-        <a:font script="Sora" typeface="Nirmala UI"/>
-        <a:font script="Tale" typeface="Microsoft Tai Le"/>
-        <a:font script="Talu" typeface="Microsoft New Tai Lue"/>
-        <a:font script="Tfng" typeface="Ebrima"/>
       </a:minorFont>
     </a:fontScheme>
     <a:fmtScheme name="Office">
@@ -8790,136 +8857,180 @@
           <a:gsLst>
             <a:gs pos="0">
               <a:schemeClr val="phClr">
-                <a:lumMod val="110000"/>
-                <a:satMod val="105000"/>
-                <a:tint val="67000"/>
+                <a:tint val="50000"/>
+                <a:satMod val="300000"/>
               </a:schemeClr>
             </a:gs>
-            <a:gs pos="50000">
+            <a:gs pos="35000">
               <a:schemeClr val="phClr">
-                <a:lumMod val="105000"/>
-                <a:satMod val="103000"/>
-                <a:tint val="73000"/>
+                <a:tint val="37000"/>
+                <a:satMod val="300000"/>
               </a:schemeClr>
             </a:gs>
             <a:gs pos="100000">
               <a:schemeClr val="phClr">
-                <a:lumMod val="105000"/>
-                <a:satMod val="109000"/>
-                <a:tint val="81000"/>
+                <a:tint val="15000"/>
+                <a:satMod val="350000"/>
               </a:schemeClr>
             </a:gs>
           </a:gsLst>
-          <a:lin ang="5400000" scaled="0"/>
+          <a:lin ang="16200000" scaled="1"/>
         </a:gradFill>
         <a:gradFill rotWithShape="1">
           <a:gsLst>
             <a:gs pos="0">
               <a:schemeClr val="phClr">
-                <a:satMod val="103000"/>
-                <a:lumMod val="102000"/>
-                <a:tint val="94000"/>
-              </a:schemeClr>
-            </a:gs>
-            <a:gs pos="50000">
-              <a:schemeClr val="phClr">
-                <a:satMod val="110000"/>
-                <a:lumMod val="100000"/>
+                <a:tint val="100000"/>
                 <a:shade val="100000"/>
+                <a:satMod val="130000"/>
               </a:schemeClr>
             </a:gs>
             <a:gs pos="100000">
               <a:schemeClr val="phClr">
-                <a:lumMod val="99000"/>
-                <a:satMod val="120000"/>
-                <a:shade val="78000"/>
+                <a:tint val="50000"/>
+                <a:shade val="100000"/>
+                <a:satMod val="350000"/>
               </a:schemeClr>
             </a:gs>
           </a:gsLst>
-          <a:lin ang="5400000" scaled="0"/>
+          <a:lin ang="16200000" scaled="0"/>
         </a:gradFill>
       </a:fillStyleLst>
       <a:lnStyleLst>
-        <a:ln w="12700" cap="flat" cmpd="sng" algn="ctr">
+        <a:ln w="9525" cap="flat" cmpd="sng" algn="ctr">
           <a:solidFill>
-            <a:schemeClr val="phClr"/>
+            <a:schemeClr val="phClr">
+              <a:shade val="95000"/>
+              <a:satMod val="105000"/>
+            </a:schemeClr>
           </a:solidFill>
           <a:prstDash val="solid"/>
-          <a:miter lim="800000"/>
-        </a:ln>
-        <a:ln w="19050" cap="flat" cmpd="sng" algn="ctr">
-          <a:solidFill>
-            <a:schemeClr val="phClr"/>
-          </a:solidFill>
-          <a:prstDash val="solid"/>
-          <a:miter lim="800000"/>
         </a:ln>
         <a:ln w="25400" cap="flat" cmpd="sng" algn="ctr">
           <a:solidFill>
             <a:schemeClr val="phClr"/>
           </a:solidFill>
           <a:prstDash val="solid"/>
-          <a:miter lim="800000"/>
+        </a:ln>
+        <a:ln w="38100" cap="flat" cmpd="sng" algn="ctr">
+          <a:solidFill>
+            <a:schemeClr val="phClr"/>
+          </a:solidFill>
+          <a:prstDash val="solid"/>
         </a:ln>
       </a:lnStyleLst>
       <a:effectStyleLst>
         <a:effectStyle>
-          <a:effectLst/>
-        </a:effectStyle>
-        <a:effectStyle>
-          <a:effectLst/>
+          <a:effectLst>
+            <a:outerShdw blurRad="40000" dist="20000" dir="5400000" rotWithShape="0">
+              <a:srgbClr val="000000">
+                <a:alpha val="38000"/>
+              </a:srgbClr>
+            </a:outerShdw>
+          </a:effectLst>
         </a:effectStyle>
         <a:effectStyle>
           <a:effectLst>
-            <a:outerShdw blurRad="57150" dist="19050" dir="5400000" algn="ctr" rotWithShape="0">
+            <a:outerShdw blurRad="40000" dist="23000" dir="5400000" rotWithShape="0">
               <a:srgbClr val="000000">
-                <a:alpha val="63000"/>
+                <a:alpha val="35000"/>
               </a:srgbClr>
             </a:outerShdw>
           </a:effectLst>
+        </a:effectStyle>
+        <a:effectStyle>
+          <a:effectLst>
+            <a:outerShdw blurRad="40000" dist="23000" dir="5400000" rotWithShape="0">
+              <a:srgbClr val="000000">
+                <a:alpha val="35000"/>
+              </a:srgbClr>
+            </a:outerShdw>
+          </a:effectLst>
+          <a:scene3d>
+            <a:camera prst="orthographicFront">
+              <a:rot lat="0" lon="0" rev="0"/>
+            </a:camera>
+            <a:lightRig rig="threePt" dir="t">
+              <a:rot lat="0" lon="0" rev="1200000"/>
+            </a:lightRig>
+          </a:scene3d>
+          <a:sp3d>
+            <a:bevelT w="63500" h="25400"/>
+          </a:sp3d>
         </a:effectStyle>
       </a:effectStyleLst>
       <a:bgFillStyleLst>
         <a:solidFill>
           <a:schemeClr val="phClr"/>
         </a:solidFill>
-        <a:solidFill>
-          <a:schemeClr val="phClr">
-            <a:tint val="95000"/>
-            <a:satMod val="170000"/>
-          </a:schemeClr>
-        </a:solidFill>
         <a:gradFill rotWithShape="1">
           <a:gsLst>
             <a:gs pos="0">
               <a:schemeClr val="phClr">
-                <a:tint val="93000"/>
-                <a:satMod val="150000"/>
-                <a:shade val="98000"/>
-                <a:lumMod val="102000"/>
+                <a:tint val="40000"/>
+                <a:satMod val="350000"/>
               </a:schemeClr>
             </a:gs>
-            <a:gs pos="50000">
+            <a:gs pos="40000">
               <a:schemeClr val="phClr">
-                <a:tint val="98000"/>
-                <a:satMod val="130000"/>
-                <a:shade val="90000"/>
-                <a:lumMod val="103000"/>
+                <a:tint val="45000"/>
+                <a:shade val="99000"/>
+                <a:satMod val="350000"/>
               </a:schemeClr>
             </a:gs>
             <a:gs pos="100000">
               <a:schemeClr val="phClr">
-                <a:shade val="63000"/>
-                <a:satMod val="120000"/>
+                <a:shade val="20000"/>
+                <a:satMod val="255000"/>
               </a:schemeClr>
             </a:gs>
           </a:gsLst>
-          <a:lin ang="5400000" scaled="0"/>
+          <a:path path="circle">
+            <a:fillToRect l="50000" t="-80000" r="50000" b="180000"/>
+          </a:path>
+        </a:gradFill>
+        <a:gradFill rotWithShape="1">
+          <a:gsLst>
+            <a:gs pos="0">
+              <a:schemeClr val="phClr">
+                <a:tint val="80000"/>
+                <a:satMod val="300000"/>
+              </a:schemeClr>
+            </a:gs>
+            <a:gs pos="100000">
+              <a:schemeClr val="phClr">
+                <a:shade val="30000"/>
+                <a:satMod val="200000"/>
+              </a:schemeClr>
+            </a:gs>
+          </a:gsLst>
+          <a:path path="circle">
+            <a:fillToRect l="50000" t="50000" r="50000" b="50000"/>
+          </a:path>
         </a:gradFill>
       </a:bgFillStyleLst>
     </a:fmtScheme>
   </a:themeElements>
   <a:objectDefaults>
+    <a:spDef>
+      <a:spPr/>
+      <a:bodyPr/>
+      <a:lstStyle/>
+      <a:style>
+        <a:lnRef idx="1">
+          <a:schemeClr val="accent1"/>
+        </a:lnRef>
+        <a:fillRef idx="3">
+          <a:schemeClr val="accent1"/>
+        </a:fillRef>
+        <a:effectRef idx="2">
+          <a:schemeClr val="accent1"/>
+        </a:effectRef>
+        <a:fontRef idx="minor">
+          <a:schemeClr val="lt1"/>
+        </a:fontRef>
+      </a:style>
+    </a:spDef>
     <a:lnDef>
       <a:spPr/>
       <a:bodyPr/>
@@ -8941,10 +9052,5 @@
     </a:lnDef>
   </a:objectDefaults>
   <a:extraClrSchemeLst/>
-  <a:extLst>
-    <a:ext uri="{05A4C25C-085E-4340-85A3-A5531E510DB2}">
-      <thm15:themeFamily xmlns:thm15="http://schemas.microsoft.com/office/thememl/2012/main" name="Office Theme" id="{2E142A2C-CD16-42D6-873A-C26D2A0506FA}" vid="{1BDDFF52-6CD6-40A5-AB3C-68EB2F1E4D0A}"/>
-    </a:ext>
-  </a:extLst>
 </a:theme>
 </file>
</xml_diff>